<commit_message>
Update the defence decks and scripts to the clean-data results
Every hard-coded number now matches the thesis after the faulty-quote
cleaning and the 60% threshold: constant step, ranking, panels, line
movement (Q1 now just significant), deployment on 7,861 common matches,
value betting (both Pinnacle prices now significant losses), 42%.
The long deck gains a common-matches slide (33 slides); the short one
stays at 17 and carries the Pinnacle-Betfair answer on its deployment
slide.

Co-Authored-By: Claude Opus 5.5 <noreply@anthropic.com>
</commit_message>
<xml_diff>
--- a/docs/defense_presentation_short.pptx
+++ b/docs/defense_presentation_short.pptx
@@ -123,7 +123,7 @@
   <p:extLst>
     <p:ext uri="{521415D9-36F7-43E2-AB2F-B90AF26B5E84}">
       <p14:sectionLst xmlns:p14="http://schemas.microsoft.com/office/powerpoint/2010/main">
-        <p14:section name="Talk" id="{c7c447e8-ee6c-d268-b0cf-ca0267ab95b0}">
+        <p14:section name="Talk" id="{1b2e6139-6840-06e5-b71e-586d879176ec}">
           <p14:sldIdLst>
             <p14:sldId id="256"/>
             <p14:sldId id="257"/>
@@ -300,31 +300,31 @@
                   <c:v>0.998</c:v>
                 </c:pt>
                 <c:pt idx="2">
-                  <c:v>0.99794</c:v>
+                  <c:v>0.99795</c:v>
                 </c:pt>
                 <c:pt idx="3">
-                  <c:v>0.99789</c:v>
+                  <c:v>0.99791</c:v>
                 </c:pt>
                 <c:pt idx="4">
-                  <c:v>0.9978</c:v>
+                  <c:v>0.99781</c:v>
                 </c:pt>
                 <c:pt idx="5">
-                  <c:v>0.9977</c:v>
+                  <c:v>0.99772</c:v>
                 </c:pt>
                 <c:pt idx="6">
+                  <c:v>0.99767</c:v>
+                </c:pt>
+                <c:pt idx="7">
                   <c:v>0.99766</c:v>
                 </c:pt>
-                <c:pt idx="7">
-                  <c:v>0.99765</c:v>
-                </c:pt>
                 <c:pt idx="8">
-                  <c:v>0.99765</c:v>
+                  <c:v>0.99766</c:v>
                 </c:pt>
                 <c:pt idx="9">
-                  <c:v>0.99765</c:v>
+                  <c:v>0.99766</c:v>
                 </c:pt>
                 <c:pt idx="10">
-                  <c:v>0.99766</c:v>
+                  <c:v>0.99767</c:v>
                 </c:pt>
                 <c:pt idx="11">
                   <c:v>0.99769</c:v>
@@ -333,10 +333,10 @@
                   <c:v>0.99778</c:v>
                 </c:pt>
                 <c:pt idx="13">
-                  <c:v>0.99858</c:v>
+                  <c:v>0.99857</c:v>
                 </c:pt>
                 <c:pt idx="14">
-                  <c:v>0.99895</c:v>
+                  <c:v>0.99886</c:v>
                 </c:pt>
               </c:numCache>
             </c:numRef>
@@ -724,19 +724,19 @@
                   <c:v>0.99693</c:v>
                 </c:pt>
                 <c:pt idx="2">
+                  <c:v>0.99772</c:v>
+                </c:pt>
+                <c:pt idx="3">
                   <c:v>0.99773</c:v>
                 </c:pt>
-                <c:pt idx="3">
-                  <c:v>0.99774</c:v>
-                </c:pt>
                 <c:pt idx="4">
-                  <c:v>0.99813</c:v>
+                  <c:v>0.99814</c:v>
                 </c:pt>
                 <c:pt idx="5">
                   <c:v>0.9991</c:v>
                 </c:pt>
                 <c:pt idx="6">
-                  <c:v>0.99919</c:v>
+                  <c:v>0.99917</c:v>
                 </c:pt>
                 <c:pt idx="7">
                   <c:v>1.00026</c:v>
@@ -984,13 +984,13 @@
                   <c:v>1.00076</c:v>
                 </c:pt>
                 <c:pt idx="1">
-                  <c:v>1.00088</c:v>
+                  <c:v>1.00078</c:v>
                 </c:pt>
                 <c:pt idx="2">
-                  <c:v>1.00088</c:v>
+                  <c:v>1.00078</c:v>
                 </c:pt>
                 <c:pt idx="3">
-                  <c:v>1.0008</c:v>
+                  <c:v>1.00077</c:v>
                 </c:pt>
               </c:numCache>
             </c:numRef>
@@ -1070,13 +1070,13 @@
                 <c:formatCode>General</c:formatCode>
                 <c:ptCount val="4"/>
                 <c:pt idx="0">
-                  <c:v>0.99745</c:v>
+                  <c:v>0.99746</c:v>
                 </c:pt>
                 <c:pt idx="1">
-                  <c:v>0.99842</c:v>
+                  <c:v>0.99839</c:v>
                 </c:pt>
                 <c:pt idx="2">
-                  <c:v>0.99843</c:v>
+                  <c:v>0.99841</c:v>
                 </c:pt>
                 <c:pt idx="3">
                   <c:v>0.99886</c:v>
@@ -1159,7 +1159,7 @@
                 <c:formatCode>General</c:formatCode>
                 <c:ptCount val="4"/>
                 <c:pt idx="0">
-                  <c:v>0.99722</c:v>
+                  <c:v>0.99723</c:v>
                 </c:pt>
                 <c:pt idx="1">
                   <c:v>0.99762</c:v>
@@ -1487,19 +1487,19 @@
                 <c:formatCode>General</c:formatCode>
                 <c:ptCount val="5"/>
                 <c:pt idx="0">
-                  <c:v>0.0004386258771955</c:v>
+                  <c:v>0.0004455286072115</c:v>
                 </c:pt>
                 <c:pt idx="1">
-                  <c:v>0.0007151847052722</c:v>
+                  <c:v>0.0006720359451092</c:v>
                 </c:pt>
                 <c:pt idx="2">
-                  <c:v>0.0019983758222999</c:v>
+                  <c:v>0.0020182809653802</c:v>
                 </c:pt>
                 <c:pt idx="3">
-                  <c:v>0.0045231329698202</c:v>
+                  <c:v>0.0042176873941862</c:v>
                 </c:pt>
                 <c:pt idx="4">
-                  <c:v>0.0115806553449734</c:v>
+                  <c:v>0.0117989748500138</c:v>
                 </c:pt>
               </c:numCache>
             </c:numRef>
@@ -1790,7 +1790,7 @@
             <c:bubble3D val="0"/>
             <c:spPr>
               <a:solidFill>
-                <a:srgbClr val="94A3B8"/>
+                <a:srgbClr val="C1121F"/>
               </a:solidFill>
               <a:effectLst/>
             </c:spPr>
@@ -1850,28 +1850,28 @@
                 <c:formatCode>General</c:formatCode>
                 <c:ptCount val="9"/>
                 <c:pt idx="0">
-                  <c:v>1.586</c:v>
+                  <c:v>1.596</c:v>
                 </c:pt>
                 <c:pt idx="1">
                   <c:v>0.897</c:v>
                 </c:pt>
                 <c:pt idx="2">
-                  <c:v>0.258</c:v>
+                  <c:v>0.204</c:v>
                 </c:pt>
                 <c:pt idx="3">
-                  <c:v>0.14</c:v>
+                  <c:v>0.146</c:v>
                 </c:pt>
                 <c:pt idx="4">
-                  <c:v>0.037</c:v>
+                  <c:v>0.1</c:v>
                 </c:pt>
                 <c:pt idx="5">
-                  <c:v>-0.125</c:v>
+                  <c:v>-0.155</c:v>
                 </c:pt>
                 <c:pt idx="6">
-                  <c:v>-0.237</c:v>
+                  <c:v>-0.292</c:v>
                 </c:pt>
                 <c:pt idx="7">
-                  <c:v>-0.585</c:v>
+                  <c:v>-0.602</c:v>
                 </c:pt>
                 <c:pt idx="8">
                   <c:v>-3.699</c:v>
@@ -2627,7 +2627,7 @@
           <a:p>
             <a:r>
               <a:rPr lang="en-US" dirty="0"/>
-              <a:t>Say the Betfair line yourself, first. It is the question they will ask.</a:t>
+              <a:t>Say the Betfair line yourself, first. It is the question they will ask. The answer is the common-matches check: where Pinnacle and Betfair both quote, the gap is not significant, so Betfair's lead coincides with Pinnacle's absence. On those common matches the algorithms also tie with Pinnacle.</a:t>
             </a:r>
             <a:endParaRPr lang="en-US" dirty="0"/>
           </a:p>
@@ -4913,7 +4913,7 @@
                   <a:schemeClr val="tx1"/>
                 </a:solidFill>
               </a:rPr>
-              <a:t>Microstructure predicts the closing advantage should concentrate where the line moved. It does: 0.00044 in the quiet fifth, 0.01158 in the noisy one.</a:t>
+              <a:t>Microstructure predicts the closing advantage should concentrate where the line moved. It does: 0.00045 in the quiet fifth, 0.01180 in the noisy one.</a:t>
             </a:r>
             <a:endParaRPr lang="en-US" sz="1400" dirty="0"/>
           </a:p>
@@ -4949,7 +4949,7 @@
                   <a:schemeClr val="accent2"/>
                 </a:solidFill>
               </a:rPr>
-              <a:t>In Q1 it is not even significant (p = 0.052).</a:t>
+              <a:t>In Q1 it is only just significant (p = 0.048).</a:t>
             </a:r>
             <a:endParaRPr lang="en-US" sz="1400" dirty="0"/>
           </a:p>
@@ -5129,7 +5129,7 @@
                   <a:schemeClr val="tx1"/>
                 </a:solidFill>
               </a:rPr>
-              <a:t>Fitted through 31/12/2024, measured on 11,574 rounds of 2025-26.</a:t>
+              <a:t>Fitted through 31/12/2024, measured on 2025-26: 7,861 matches every series quoted.</a:t>
             </a:r>
             <a:endParaRPr lang="en-US" sz="1600" dirty="0"/>
           </a:p>
@@ -5264,7 +5264,7 @@
                   <a:schemeClr val="accent5"/>
                 </a:solidFill>
               </a:rPr>
-              <a:t>−0.0019 to −0.0065, all p ≤ 0.019</a:t>
+              <a:t>−0.0018 to −0.0029, all p ≤ 0.011</a:t>
             </a:r>
             <a:endParaRPr lang="en-US" sz="1350" dirty="0"/>
           </a:p>
@@ -5399,7 +5399,7 @@
                   <a:schemeClr val="accent5"/>
                 </a:solidFill>
               </a:rPr>
-              <a:t>B365C p=0.193 · BWC p=0.361 · BFEC p=0.052</a:t>
+              <a:t>B365C and BWC tie with every variant, p from 0.263 to 0.892 · PSC ties too, on its own rounds</a:t>
             </a:r>
             <a:endParaRPr lang="en-US" sz="1350" dirty="0"/>
           </a:p>
@@ -5534,7 +5534,7 @@
                   <a:schemeClr val="accent5"/>
                 </a:solidFill>
               </a:rPr>
-              <a:t>an exchange, not a bookmaker: a market price with no operator margin</a:t>
+              <a:t>+0.00078 to +0.00143, p ≤ 0.026, with Pinnacle gone · on 2024/25 matches both quoted, PSC and BFEC cannot be told apart (p = 0.122)</a:t>
             </a:r>
             <a:endParaRPr lang="en-US" sz="1350" dirty="0"/>
           </a:p>
@@ -5757,7 +5757,7 @@
                   <a:schemeClr val="tx2"/>
                 </a:solidFill>
               </a:rPr>
-              <a:t>Two profits, one loss</a:t>
+              <a:t>Two profits, two losses</a:t>
             </a:r>
             <a:endParaRPr lang="en-US" sz="1800" dirty="0"/>
           </a:p>
@@ -5793,7 +5793,7 @@
                   <a:schemeClr val="tx1"/>
                 </a:solidFill>
               </a:rPr>
-              <a:t>Significant gains against WHC (p&lt;0.001) and IW (p=0.008), both recreational-facing houses. A significant LOSS against PSC, the best forecaster in the panel, i.e. exactly the opponent an inferior model should lose to.</a:t>
+              <a:t>Significant gains against WHC (p=0.001) and IW (p=0.008), both recreational-facing houses. Significant LOSSES against both Pinnacle prices (PS p=0.050, PSC p&lt;0.001), the best forecaster in the panel, i.e. exactly the opponent an inferior model should lose to.</a:t>
             </a:r>
             <a:endParaRPr lang="en-US" sz="1350" dirty="0"/>
           </a:p>
@@ -5973,7 +5973,7 @@
                   <a:schemeClr val="bg1"/>
                 </a:solidFill>
               </a:rPr>
-              <a:t>41% of the margin over the uniform average is not learning</a:t>
+              <a:t>42% of the margin over the uniform average is not learning</a:t>
             </a:r>
             <a:endParaRPr lang="en-US" sz="3400" dirty="0"/>
           </a:p>
@@ -7322,7 +7322,7 @@
                   <a:schemeClr val="accent5"/>
                 </a:solidFill>
               </a:rPr>
-              <a:t>41% of the margin over uniform, isolated with a zero-step control.</a:t>
+              <a:t>42% of the margin over uniform, isolated with a zero-step control.</a:t>
             </a:r>
             <a:endParaRPr lang="en-US" sz="1350" dirty="0"/>
           </a:p>
@@ -12204,7 +12204,7 @@
                   <a:schemeClr val="tx1"/>
                 </a:solidFill>
               </a:rPr>
-              <a:t>beats the uniform average by 0.00141 (p &lt; 0.001)</a:t>
+              <a:t>beats the uniform average by 0.00140 (p &lt; 0.001)</a:t>
             </a:r>
             <a:endParaRPr lang="en-US" sz="1350" dirty="0"/>
           </a:p>
@@ -12537,7 +12537,7 @@
                   <a:schemeClr val="tx1"/>
                 </a:solidFill>
               </a:rPr>
-              <a:t>On a HOMOGENEOUS panel, Hedge and FTRL LOSE to it, in 8 tests out of 8.</a:t>
+              <a:t>On the HOMOGENEOUS closing panel, Hedge and FTRL LOSE to it, in 4 tests out of 4; on the opening one all three tie.</a:t>
             </a:r>
             <a:endParaRPr lang="en-US" sz="1400" dirty="0"/>
           </a:p>
@@ -12573,7 +12573,7 @@
                   <a:schemeClr val="accent5"/>
                 </a:solidFill>
               </a:rPr>
-              <a:t>Remove the quality spread and adaptation is pure cost.</a:t>
+              <a:t>Remove the quality spread and adaptation buys nothing.</a:t>
             </a:r>
             <a:endParaRPr lang="en-US" sz="1350" dirty="0"/>
           </a:p>

</xml_diff>

<commit_message>
Short defence deck: give the common-matches check its own slide
18 slides for the 20-minute talk. The deployment slide goes back to
stating the Betfair result; the new slide 12 answers it (Pinnacle and
Betfair cannot be told apart where both quote) and shows that the
results hold with nobody asleep. Script renumbered and retimed to 19:30.

Co-Authored-By: Claude Opus 5.5 <noreply@anthropic.com>
</commit_message>
<xml_diff>
--- a/docs/defense_presentation_short.pptx
+++ b/docs/defense_presentation_short.pptx
@@ -22,9 +22,10 @@
     <p:sldId id="270" r:id="rId16"/>
     <p:sldId id="271" r:id="rId17"/>
     <p:sldId id="272" r:id="rId18"/>
+    <p:sldId id="273" r:id="rId19"/>
   </p:sldIdLst>
   <p:notesMasterIdLst>
-    <p:notesMasterId r:id="rId19"/>
+    <p:notesMasterId r:id="rId20"/>
   </p:notesMasterIdLst>
   <p:sldSz cx="12192000" cy="6858000"/>
   <p:notesSz cx="6858000" cy="12192000"/>
@@ -123,7 +124,7 @@
   <p:extLst>
     <p:ext uri="{521415D9-36F7-43E2-AB2F-B90AF26B5E84}">
       <p14:sectionLst xmlns:p14="http://schemas.microsoft.com/office/powerpoint/2010/main">
-        <p14:section name="Talk" id="{1b2e6139-6840-06e5-b71e-586d879176ec}">
+        <p14:section name="Talk" id="{0da056a3-4d3d-364b-bda4-a5e76eb1e8bc}">
           <p14:sldIdLst>
             <p14:sldId id="256"/>
             <p14:sldId id="257"/>
@@ -142,6 +143,7 @@
             <p14:sldId id="270"/>
             <p14:sldId id="271"/>
             <p14:sldId id="272"/>
+            <p14:sldId id="273"/>
           </p14:sldIdLst>
         </p14:section>
       </p14:sectionLst>
@@ -2627,7 +2629,7 @@
           <a:p>
             <a:r>
               <a:rPr lang="en-US" dirty="0"/>
-              <a:t>Say the Betfair line yourself, first. It is the question they will ask. The answer is the common-matches check: where Pinnacle and Betfair both quote, the gap is not significant, so Betfair's lead coincides with Pinnacle's absence. On those common matches the algorithms also tie with Pinnacle.</a:t>
+              <a:t>Say the Betfair line yourself, first. It is the question they will ask, and the next slide answers it.</a:t>
             </a:r>
             <a:endParaRPr lang="en-US" dirty="0"/>
           </a:p>
@@ -2715,7 +2717,7 @@
           <a:p>
             <a:r>
               <a:rPr lang="en-US" dirty="0"/>
-              <a:t>The edge sits at the soft houses and is absent at the sharp one. That is the thesis's uncomfortable finding.</a:t>
+              <a:t>Answers the two obvious objections at once: the results do not depend on the sleeping-experts reduction, and Betfair is not shown to be better than Pinnacle. Calibrated log-loss, lower is better.</a:t>
             </a:r>
             <a:endParaRPr lang="en-US" dirty="0"/>
           </a:p>
@@ -2803,7 +2805,7 @@
           <a:p>
             <a:r>
               <a:rPr lang="en-US" dirty="0"/>
-              <a:t>The methodological high point. Any comparison against a uniform baseline should now carry this control.</a:t>
+              <a:t>The edge sits at the soft houses and is absent at the sharp one. That is the thesis's uncomfortable finding.</a:t>
             </a:r>
             <a:endParaRPr lang="en-US" dirty="0"/>
           </a:p>
@@ -2891,7 +2893,7 @@
           <a:p>
             <a:r>
               <a:rPr lang="en-US" dirty="0"/>
-              <a:t>Fast slide. The pattern matters more than the list.</a:t>
+              <a:t>The methodological high point. Any comparison against a uniform baseline should now carry this control.</a:t>
             </a:r>
             <a:endParaRPr lang="en-US" dirty="0"/>
           </a:p>
@@ -2979,7 +2981,7 @@
           <a:p>
             <a:r>
               <a:rPr lang="en-US" dirty="0"/>
-              <a:t>Five points, about twelve seconds each. Nothing new here.</a:t>
+              <a:t>Fast slide. The pattern matters more than the list.</a:t>
             </a:r>
             <a:endParaRPr lang="en-US" dirty="0"/>
           </a:p>
@@ -3067,7 +3069,7 @@
           <a:p>
             <a:r>
               <a:rPr lang="en-US" dirty="0"/>
-              <a:t>The live feed answers the thesis's own main limitation.</a:t>
+              <a:t>Five points, about twelve seconds each. Nothing new here.</a:t>
             </a:r>
             <a:endParaRPr lang="en-US" dirty="0"/>
           </a:p>
@@ -3155,7 +3157,7 @@
           <a:p>
             <a:r>
               <a:rPr lang="en-US" dirty="0"/>
-              <a:t>Stop talking. Let them ask.</a:t>
+              <a:t>The live feed answers the thesis's own main limitation.</a:t>
             </a:r>
             <a:endParaRPr lang="en-US" dirty="0"/>
           </a:p>
@@ -3179,6 +3181,94 @@
             <a:fld id="{F7021451-1387-4CA6-816F-3879F97B5CBC}" type="slidenum">
               <a:rPr lang="en-US"/>
               <a:t>17</a:t>
+            </a:fld>
+            <a:endParaRPr lang="en-US"/>
+          </a:p>
+        </p:txBody>
+      </p:sp>
+    </p:spTree>
+    <p:extLst>
+      <p:ext uri="{BB962C8B-B14F-4D97-AF65-F5344CB8AC3E}">
+        <p14:creationId xmlns:p14="http://schemas.microsoft.com/office/powerpoint/2010/main" val="1024086991"/>
+      </p:ext>
+    </p:extLst>
+  </p:cSld>
+  <p:clrMapOvr>
+    <a:masterClrMapping/>
+  </p:clrMapOvr>
+</p:notes>
+</file>
+
+<file path=ppt/notesSlides/notesSlide18.xml><?xml version="1.0" encoding="utf-8"?>
+<p:notes xmlns:a="http://schemas.openxmlformats.org/drawingml/2006/main" xmlns:r="http://schemas.openxmlformats.org/officeDocument/2006/relationships" xmlns:p="http://schemas.openxmlformats.org/presentationml/2006/main">
+  <p:cSld>
+    <p:spTree>
+      <p:nvGrpSpPr>
+        <p:cNvPr id="1" name=""/>
+        <p:cNvGrpSpPr/>
+        <p:nvPr/>
+      </p:nvGrpSpPr>
+      <p:grpSpPr>
+        <a:xfrm>
+          <a:off x="0" y="0"/>
+          <a:ext cx="0" cy="0"/>
+          <a:chOff x="0" y="0"/>
+          <a:chExt cx="0" cy="0"/>
+        </a:xfrm>
+      </p:grpSpPr>
+      <p:sp>
+        <p:nvSpPr>
+          <p:cNvPr id="2" name="Slide Image Placeholder 1"/>
+          <p:cNvSpPr>
+            <a:spLocks noGrp="1" noRot="1" noChangeAspect="1"/>
+          </p:cNvSpPr>
+          <p:nvPr>
+            <p:ph type="sldImg"/>
+          </p:nvPr>
+        </p:nvSpPr>
+        <p:spPr/>
+      </p:sp>
+      <p:sp>
+        <p:nvSpPr>
+          <p:cNvPr id="3" name="Notes Placeholder 2"/>
+          <p:cNvSpPr>
+            <a:spLocks noGrp="1"/>
+          </p:cNvSpPr>
+          <p:nvPr>
+            <p:ph type="body" idx="1"/>
+          </p:nvPr>
+        </p:nvSpPr>
+        <p:spPr/>
+        <p:txBody>
+          <a:bodyPr/>
+          <a:lstStyle/>
+          <a:p>
+            <a:r>
+              <a:rPr lang="en-US" dirty="0"/>
+              <a:t>Stop talking. Let them ask.</a:t>
+            </a:r>
+            <a:endParaRPr lang="en-US" dirty="0"/>
+          </a:p>
+        </p:txBody>
+      </p:sp>
+      <p:sp>
+        <p:nvSpPr>
+          <p:cNvPr id="4" name="Slide Number Placeholder 3"/>
+          <p:cNvSpPr>
+            <a:spLocks noGrp="1"/>
+          </p:cNvSpPr>
+          <p:nvPr>
+            <p:ph type="sldNum" sz="quarter" idx="10"/>
+          </p:nvPr>
+        </p:nvSpPr>
+        <p:spPr/>
+        <p:txBody>
+          <a:bodyPr/>
+          <a:lstStyle/>
+          <a:p>
+            <a:fld id="{F7021451-1387-4CA6-816F-3879F97B5CBC}" type="slidenum">
+              <a:rPr lang="en-US"/>
+              <a:t>18</a:t>
             </a:fld>
             <a:endParaRPr lang="en-US"/>
           </a:p>
@@ -5534,7 +5624,7 @@
                   <a:schemeClr val="accent5"/>
                 </a:solidFill>
               </a:rPr>
-              <a:t>+0.00078 to +0.00143, p ≤ 0.026, with Pinnacle gone · on 2024/25 matches both quoted, PSC and BFEC cannot be told apart (p = 0.122)</a:t>
+              <a:t>+0.00078 to +0.00143, p ≤ 0.026 · an exchange, a market price with no operator margin, and Pinnacle has stopped quoting</a:t>
             </a:r>
             <a:endParaRPr lang="en-US" sz="1350" dirty="0"/>
           </a:p>
@@ -5678,42 +5768,62 @@
                   <a:schemeClr val="tx2"/>
                 </a:solidFill>
               </a:rPr>
-              <a:t>Better prediction does not mean profit</a:t>
+              <a:t>Common matches: nobody asleep, same conclusions</a:t>
             </a:r>
             <a:endParaRPr lang="en-US" sz="3000" dirty="0"/>
           </a:p>
         </p:txBody>
       </p:sp>
-      <p:graphicFrame>
-        <p:nvGraphicFramePr>
-          <p:cNvPr id="3" name="Chart 0" descr=""/>
-          <p:cNvGraphicFramePr/>
-          <p:nvPr/>
-        </p:nvGraphicFramePr>
-        <p:xfrm>
-          <a:off x="640080" y="1554480"/>
-          <a:ext cx="6675120" cy="3749040"/>
-        </p:xfrm>
-        <a:graphic xmlns:a="http://schemas.openxmlformats.org/drawingml/2006/main">
-          <a:graphicData uri="http://schemas.openxmlformats.org/drawingml/2006/chart">
-            <c:chart xmlns:c="http://schemas.openxmlformats.org/drawingml/2006/chart" r:id="rId1"/>
-          </a:graphicData>
-        </a:graphic>
-      </p:graphicFrame>
-      <p:sp>
-        <p:nvSpPr>
-          <p:cNvPr id="4" name="vb-note"/>
+      <p:sp>
+        <p:nvSpPr>
+          <p:cNvPr id="3" name="Text 1"/>
+          <p:cNvSpPr txBox="1"/>
+          <p:nvPr/>
+        </p:nvSpPr>
+        <p:spPr>
+          <a:xfrm>
+            <a:off x="640080" y="1325880"/>
+            <a:ext cx="10881360" cy="365760"/>
+          </a:xfrm>
+          <a:prstGeom prst="rect">
+            <a:avLst/>
+          </a:prstGeom>
+          <a:noFill/>
+          <a:ln/>
+        </p:spPr>
+        <p:txBody>
+          <a:bodyPr wrap="square" rtlCol="0" anchor="ctr"/>
+          <a:lstStyle/>
+          <a:p>
+            <a:pPr indent="0" marL="0">
+              <a:buNone/>
+            </a:pPr>
+            <a:r>
+              <a:rPr lang="en-US" sz="1500" dirty="0">
+                <a:solidFill>
+                  <a:schemeClr val="tx1"/>
+                </a:solidFill>
+              </a:rPr>
+              <a:t>Only the matches every chosen series quoted: the algorithms are the classical ones, and every series is scored on the same matches.</a:t>
+            </a:r>
+            <a:endParaRPr lang="en-US" sz="1500" dirty="0"/>
+          </a:p>
+        </p:txBody>
+      </p:sp>
+      <p:sp>
+        <p:nvSpPr>
+          <p:cNvPr id="4" name="cm-0"/>
           <p:cNvSpPr/>
           <p:nvPr/>
         </p:nvSpPr>
         <p:spPr>
           <a:xfrm>
-            <a:off x="7589520" y="1554480"/>
-            <a:ext cx="3931920" cy="3749040"/>
+            <a:off x="640080" y="1828800"/>
+            <a:ext cx="10881360" cy="1143000"/>
           </a:xfrm>
           <a:prstGeom prst="roundRect">
             <a:avLst>
-              <a:gd name="adj" fmla="val 1951"/>
+              <a:gd name="adj" fmla="val 6400"/>
             </a:avLst>
           </a:prstGeom>
           <a:solidFill>
@@ -5729,14 +5839,14 @@
       </p:sp>
       <p:sp>
         <p:nvSpPr>
-          <p:cNvPr id="5" name="Text 2"/>
+          <p:cNvPr id="5" name="Text 3"/>
           <p:cNvSpPr txBox="1"/>
           <p:nvPr/>
         </p:nvSpPr>
         <p:spPr>
           <a:xfrm>
-            <a:off x="7909560" y="1783080"/>
-            <a:ext cx="3291840" cy="365760"/>
+            <a:off x="960120" y="1965960"/>
+            <a:ext cx="5669280" cy="411480"/>
           </a:xfrm>
           <a:prstGeom prst="rect">
             <a:avLst/>
@@ -5752,27 +5862,27 @@
               <a:buNone/>
             </a:pPr>
             <a:r>
-              <a:rPr lang="en-US" sz="1800" b="1" dirty="0">
+              <a:rPr lang="en-US" sz="1700" b="1" dirty="0">
                 <a:solidFill>
                   <a:schemeClr val="tx2"/>
                 </a:solidFill>
               </a:rPr>
-              <a:t>Two profits, two losses</a:t>
-            </a:r>
-            <a:endParaRPr lang="en-US" sz="1800" dirty="0"/>
-          </a:p>
-        </p:txBody>
-      </p:sp>
-      <p:sp>
-        <p:nvSpPr>
-          <p:cNvPr id="6" name="Text 3"/>
+              <a:t>B · 12 series · 31,596 matches</a:t>
+            </a:r>
+            <a:endParaRPr lang="en-US" sz="1700" dirty="0"/>
+          </a:p>
+        </p:txBody>
+      </p:sp>
+      <p:sp>
+        <p:nvSpPr>
+          <p:cNvPr id="6" name="Text 4"/>
           <p:cNvSpPr txBox="1"/>
           <p:nvPr/>
         </p:nvSpPr>
         <p:spPr>
           <a:xfrm>
-            <a:off x="7909560" y="2194560"/>
-            <a:ext cx="3291840" cy="1828800"/>
+            <a:off x="6766560" y="1965960"/>
+            <a:ext cx="4480560" cy="411480"/>
           </a:xfrm>
           <a:prstGeom prst="rect">
             <a:avLst/>
@@ -5788,12 +5898,48 @@
               <a:buNone/>
             </a:pPr>
             <a:r>
+              <a:rPr lang="en-US" sz="1700" b="1" dirty="0">
+                <a:solidFill>
+                  <a:schemeClr val="accent1"/>
+                </a:solidFill>
+              </a:rPr>
+              <a:t>level with Pinnacle</a:t>
+            </a:r>
+            <a:endParaRPr lang="en-US" sz="1700" dirty="0"/>
+          </a:p>
+        </p:txBody>
+      </p:sp>
+      <p:sp>
+        <p:nvSpPr>
+          <p:cNvPr id="7" name="Text 5"/>
+          <p:cNvSpPr txBox="1"/>
+          <p:nvPr/>
+        </p:nvSpPr>
+        <p:spPr>
+          <a:xfrm>
+            <a:off x="960120" y="2450592"/>
+            <a:ext cx="10241280" cy="411480"/>
+          </a:xfrm>
+          <a:prstGeom prst="rect">
+            <a:avLst/>
+          </a:prstGeom>
+          <a:noFill/>
+          <a:ln/>
+        </p:spPr>
+        <p:txBody>
+          <a:bodyPr wrap="square" lIns="0" tIns="0" rIns="0" bIns="0" rtlCol="0" anchor="ctr"/>
+          <a:lstStyle/>
+          <a:p>
+            <a:pPr indent="0" marL="0">
+              <a:buNone/>
+            </a:pPr>
+            <a:r>
               <a:rPr lang="en-US" sz="1350" dirty="0">
                 <a:solidFill>
-                  <a:schemeClr val="tx1"/>
-                </a:solidFill>
-              </a:rPr>
-              <a:t>Significant gains against WHC (p=0.001) and IW (p=0.008), both recreational-facing houses. Significant LOSSES against both Pinnacle prices (PS p=0.050, PSC p&lt;0.001), the best forecaster in the panel, i.e. exactly the opponent an inferior model should lose to.</a:t>
+                  <a:schemeClr val="accent5"/>
+                </a:solidFill>
+              </a:rPr>
+              <a:t>FTRL 0.99895 · OGD 0.99910 · PSC 0.99893, every gap p ≥ 0.099 · uniform 1.00048, beaten</a:t>
             </a:r>
             <a:endParaRPr lang="en-US" sz="1350" dirty="0"/>
           </a:p>
@@ -5801,14 +5947,41 @@
       </p:sp>
       <p:sp>
         <p:nvSpPr>
-          <p:cNvPr id="7" name="Text 4"/>
+          <p:cNvPr id="8" name="cm-1"/>
+          <p:cNvSpPr/>
+          <p:nvPr/>
+        </p:nvSpPr>
+        <p:spPr>
+          <a:xfrm>
+            <a:off x="640080" y="3154680"/>
+            <a:ext cx="10881360" cy="1143000"/>
+          </a:xfrm>
+          <a:prstGeom prst="roundRect">
+            <a:avLst>
+              <a:gd name="adj" fmla="val 6400"/>
+            </a:avLst>
+          </a:prstGeom>
+          <a:solidFill>
+            <a:srgbClr val="F2F5F9"/>
+          </a:solidFill>
+          <a:ln w="12700">
+            <a:solidFill>
+              <a:srgbClr val="E2E8F0"/>
+            </a:solidFill>
+            <a:prstDash val="solid"/>
+          </a:ln>
+        </p:spPr>
+      </p:sp>
+      <p:sp>
+        <p:nvSpPr>
+          <p:cNvPr id="9" name="Text 7"/>
           <p:cNvSpPr txBox="1"/>
           <p:nvPr/>
         </p:nvSpPr>
         <p:spPr>
           <a:xfrm>
-            <a:off x="7909560" y="4114800"/>
-            <a:ext cx="3291840" cy="1005840"/>
+            <a:off x="960120" y="3291840"/>
+            <a:ext cx="5669280" cy="411480"/>
           </a:xfrm>
           <a:prstGeom prst="rect">
             <a:avLst/>
@@ -5824,12 +5997,84 @@
               <a:buNone/>
             </a:pPr>
             <a:r>
-              <a:rPr lang="en-US" sz="1350" i="1" dirty="0">
+              <a:rPr lang="en-US" sz="1700" b="1" dirty="0">
+                <a:solidFill>
+                  <a:schemeClr val="tx2"/>
+                </a:solidFill>
+              </a:rPr>
+              <a:t>B′ · the same matches, no Pinnacle</a:t>
+            </a:r>
+            <a:endParaRPr lang="en-US" sz="1700" dirty="0"/>
+          </a:p>
+        </p:txBody>
+      </p:sp>
+      <p:sp>
+        <p:nvSpPr>
+          <p:cNvPr id="10" name="Text 8"/>
+          <p:cNvSpPr txBox="1"/>
+          <p:nvPr/>
+        </p:nvSpPr>
+        <p:spPr>
+          <a:xfrm>
+            <a:off x="6766560" y="3291840"/>
+            <a:ext cx="4480560" cy="411480"/>
+          </a:xfrm>
+          <a:prstGeom prst="rect">
+            <a:avLst/>
+          </a:prstGeom>
+          <a:noFill/>
+          <a:ln/>
+        </p:spPr>
+        <p:txBody>
+          <a:bodyPr wrap="square" lIns="0" tIns="0" rIns="0" bIns="0" rtlCol="0" anchor="ctr"/>
+          <a:lstStyle/>
+          <a:p>
+            <a:pPr indent="0" marL="0">
+              <a:buNone/>
+            </a:pPr>
+            <a:r>
+              <a:rPr lang="en-US" sz="1700" b="1" dirty="0">
+                <a:solidFill>
+                  <a:schemeClr val="accent1"/>
+                </a:solidFill>
+              </a:rPr>
+              <a:t>level with the best closing</a:t>
+            </a:r>
+            <a:endParaRPr lang="en-US" sz="1700" dirty="0"/>
+          </a:p>
+        </p:txBody>
+      </p:sp>
+      <p:sp>
+        <p:nvSpPr>
+          <p:cNvPr id="11" name="Text 9"/>
+          <p:cNvSpPr txBox="1"/>
+          <p:nvPr/>
+        </p:nvSpPr>
+        <p:spPr>
+          <a:xfrm>
+            <a:off x="960120" y="3776472"/>
+            <a:ext cx="10241280" cy="411480"/>
+          </a:xfrm>
+          <a:prstGeom prst="rect">
+            <a:avLst/>
+          </a:prstGeom>
+          <a:noFill/>
+          <a:ln/>
+        </p:spPr>
+        <p:txBody>
+          <a:bodyPr wrap="square" lIns="0" tIns="0" rIns="0" bIns="0" rtlCol="0" anchor="ctr"/>
+          <a:lstStyle/>
+          <a:p>
+            <a:pPr indent="0" marL="0">
+              <a:buNone/>
+            </a:pPr>
+            <a:r>
+              <a:rPr lang="en-US" sz="1350" dirty="0">
                 <a:solidFill>
                   <a:schemeClr val="accent5"/>
                 </a:solidFill>
               </a:rPr>
-              <a:t>The quality gained is smaller than the margin charged.</a:t>
+              <a:t>FTRL 0.99940 · VC_BVC 0.99949, p 0.151 to 0.618 · the plain average loses to VC_BVC (p &lt; 0.001)</a:t>
             </a:r>
             <a:endParaRPr lang="en-US" sz="1350" dirty="0"/>
           </a:p>
@@ -5837,14 +6082,149 @@
       </p:sp>
       <p:sp>
         <p:nvSpPr>
-          <p:cNvPr id="8" name="Text 5"/>
+          <p:cNvPr id="12" name="cm-2"/>
+          <p:cNvSpPr/>
+          <p:nvPr/>
+        </p:nvSpPr>
+        <p:spPr>
+          <a:xfrm>
+            <a:off x="640080" y="4480560"/>
+            <a:ext cx="10881360" cy="1143000"/>
+          </a:xfrm>
+          <a:prstGeom prst="roundRect">
+            <a:avLst>
+              <a:gd name="adj" fmla="val 6400"/>
+            </a:avLst>
+          </a:prstGeom>
+          <a:solidFill>
+            <a:srgbClr val="F2F5F9"/>
+          </a:solidFill>
+          <a:ln w="12700">
+            <a:solidFill>
+              <a:srgbClr val="E2E8F0"/>
+            </a:solidFill>
+            <a:prstDash val="solid"/>
+          </a:ln>
+        </p:spPr>
+      </p:sp>
+      <p:sp>
+        <p:nvSpPr>
+          <p:cNvPr id="13" name="Text 11"/>
           <p:cNvSpPr txBox="1"/>
           <p:nvPr/>
         </p:nvSpPr>
         <p:spPr>
           <a:xfrm>
-            <a:off x="640080" y="5440680"/>
-            <a:ext cx="6675120" cy="320040"/>
+            <a:off x="960120" y="4617720"/>
+            <a:ext cx="5669280" cy="411480"/>
+          </a:xfrm>
+          <a:prstGeom prst="rect">
+            <a:avLst/>
+          </a:prstGeom>
+          <a:noFill/>
+          <a:ln/>
+        </p:spPr>
+        <p:txBody>
+          <a:bodyPr wrap="square" lIns="0" tIns="0" rIns="0" bIns="0" rtlCol="0" anchor="ctr"/>
+          <a:lstStyle/>
+          <a:p>
+            <a:pPr indent="0" marL="0">
+              <a:buNone/>
+            </a:pPr>
+            <a:r>
+              <a:rPr lang="en-US" sz="1700" b="1" dirty="0">
+                <a:solidFill>
+                  <a:schemeClr val="tx2"/>
+                </a:solidFill>
+              </a:rPr>
+              <a:t>C · 10 series with Betfair · 6,941 matches</a:t>
+            </a:r>
+            <a:endParaRPr lang="en-US" sz="1700" dirty="0"/>
+          </a:p>
+        </p:txBody>
+      </p:sp>
+      <p:sp>
+        <p:nvSpPr>
+          <p:cNvPr id="14" name="Text 12"/>
+          <p:cNvSpPr txBox="1"/>
+          <p:nvPr/>
+        </p:nvSpPr>
+        <p:spPr>
+          <a:xfrm>
+            <a:off x="6766560" y="4617720"/>
+            <a:ext cx="4480560" cy="411480"/>
+          </a:xfrm>
+          <a:prstGeom prst="rect">
+            <a:avLst/>
+          </a:prstGeom>
+          <a:noFill/>
+          <a:ln/>
+        </p:spPr>
+        <p:txBody>
+          <a:bodyPr wrap="square" lIns="0" tIns="0" rIns="0" bIns="0" rtlCol="0" anchor="ctr"/>
+          <a:lstStyle/>
+          <a:p>
+            <a:pPr indent="0" marL="0">
+              <a:buNone/>
+            </a:pPr>
+            <a:r>
+              <a:rPr lang="en-US" sz="1700" b="1" dirty="0">
+                <a:solidFill>
+                  <a:schemeClr val="accent3"/>
+                </a:solidFill>
+              </a:rPr>
+              <a:t>Pinnacle ≈ Betfair</a:t>
+            </a:r>
+            <a:endParaRPr lang="en-US" sz="1700" dirty="0"/>
+          </a:p>
+        </p:txBody>
+      </p:sp>
+      <p:sp>
+        <p:nvSpPr>
+          <p:cNvPr id="15" name="Text 13"/>
+          <p:cNvSpPr txBox="1"/>
+          <p:nvPr/>
+        </p:nvSpPr>
+        <p:spPr>
+          <a:xfrm>
+            <a:off x="960120" y="5102352"/>
+            <a:ext cx="10241280" cy="411480"/>
+          </a:xfrm>
+          <a:prstGeom prst="rect">
+            <a:avLst/>
+          </a:prstGeom>
+          <a:noFill/>
+          <a:ln/>
+        </p:spPr>
+        <p:txBody>
+          <a:bodyPr wrap="square" lIns="0" tIns="0" rIns="0" bIns="0" rtlCol="0" anchor="ctr"/>
+          <a:lstStyle/>
+          <a:p>
+            <a:pPr indent="0" marL="0">
+              <a:buNone/>
+            </a:pPr>
+            <a:r>
+              <a:rPr lang="en-US" sz="1350" dirty="0">
+                <a:solidFill>
+                  <a:schemeClr val="accent5"/>
+                </a:solidFill>
+              </a:rPr>
+              <a:t>PSC 0.99775 · BFEC 0.99820, p = 0.122 · Betfair's 2025-26 lead coincides with Pinnacle's absence</a:t>
+            </a:r>
+            <a:endParaRPr lang="en-US" sz="1350" dirty="0"/>
+          </a:p>
+        </p:txBody>
+      </p:sp>
+      <p:sp>
+        <p:nvSpPr>
+          <p:cNvPr id="16" name="Text 14"/>
+          <p:cNvSpPr txBox="1"/>
+          <p:nvPr/>
+        </p:nvSpPr>
+        <p:spPr>
+          <a:xfrm>
+            <a:off x="640080" y="5852160"/>
+            <a:ext cx="10881360" cy="640080"/>
           </a:xfrm>
           <a:prstGeom prst="rect">
             <a:avLst/>
@@ -5860,14 +6240,14 @@
               <a:buNone/>
             </a:pPr>
             <a:r>
-              <a:rPr lang="en-US" sz="1200" i="1" dirty="0">
-                <a:solidFill>
-                  <a:schemeClr val="accent5"/>
-                </a:solidFill>
-              </a:rPr>
-              <a:t>0 = break even · +1 = a ten-fold bankroll · green = significant profit · red = significant loss</a:t>
-            </a:r>
-            <a:endParaRPr lang="en-US" sz="1200" dirty="0"/>
+              <a:rPr lang="en-US" sz="1500" b="1" dirty="0">
+                <a:solidFill>
+                  <a:schemeClr val="tx2"/>
+                </a:solidFill>
+              </a:rPr>
+              <a:t>The optimal step is a property of the panel: with nobody asleep, Hedge and FTRL select steps 30 to 1000 times the textbook one, not smaller.</a:t>
+            </a:r>
+            <a:endParaRPr lang="en-US" sz="1500" dirty="0"/>
           </a:p>
         </p:txBody>
       </p:sp>
@@ -5951,8 +6331,8 @@
         </p:nvSpPr>
         <p:spPr>
           <a:xfrm>
-            <a:off x="914400" y="1737360"/>
-            <a:ext cx="10332720" cy="2194560"/>
+            <a:off x="640080" y="411480"/>
+            <a:ext cx="10881360" cy="777240"/>
           </a:xfrm>
           <a:prstGeom prst="rect">
             <a:avLst/>
@@ -5968,52 +6348,246 @@
               <a:buNone/>
             </a:pPr>
             <a:r>
-              <a:rPr lang="en-US" sz="3400" b="1" dirty="0">
-                <a:solidFill>
-                  <a:schemeClr val="bg1"/>
-                </a:solidFill>
-              </a:rPr>
-              <a:t>42% of the margin over the uniform average is not learning</a:t>
-            </a:r>
-            <a:endParaRPr lang="en-US" sz="3400" dirty="0"/>
-          </a:p>
-        </p:txBody>
-      </p:sp>
-      <p:sp>
-        <p:nvSpPr>
-          <p:cNvPr id="3" name="Text 0"/>
+              <a:rPr lang="en-US" sz="3000" b="1" dirty="0">
+                <a:solidFill>
+                  <a:schemeClr val="tx2"/>
+                </a:solidFill>
+              </a:rPr>
+              <a:t>Better prediction does not mean profit</a:t>
+            </a:r>
+            <a:endParaRPr lang="en-US" sz="3000" dirty="0"/>
+          </a:p>
+        </p:txBody>
+      </p:sp>
+      <p:graphicFrame>
+        <p:nvGraphicFramePr>
+          <p:cNvPr id="3" name="Chart 0" descr=""/>
+          <p:cNvGraphicFramePr/>
+          <p:nvPr/>
+        </p:nvGraphicFramePr>
+        <p:xfrm>
+          <a:off x="640080" y="1554480"/>
+          <a:ext cx="6675120" cy="3749040"/>
+        </p:xfrm>
+        <a:graphic xmlns:a="http://schemas.openxmlformats.org/drawingml/2006/main">
+          <a:graphicData uri="http://schemas.openxmlformats.org/drawingml/2006/chart">
+            <c:chart xmlns:c="http://schemas.openxmlformats.org/drawingml/2006/chart" r:id="rId1"/>
+          </a:graphicData>
+        </a:graphic>
+      </p:graphicFrame>
+      <p:sp>
+        <p:nvSpPr>
+          <p:cNvPr id="4" name="vb-note"/>
           <p:cNvSpPr/>
+          <p:nvPr/>
+        </p:nvSpPr>
+        <p:spPr>
+          <a:xfrm>
+            <a:off x="7589520" y="1554480"/>
+            <a:ext cx="3931920" cy="3749040"/>
+          </a:xfrm>
+          <a:prstGeom prst="roundRect">
+            <a:avLst>
+              <a:gd name="adj" fmla="val 1951"/>
+            </a:avLst>
+          </a:prstGeom>
+          <a:solidFill>
+            <a:srgbClr val="F2F5F9"/>
+          </a:solidFill>
+          <a:ln w="12700">
+            <a:solidFill>
+              <a:srgbClr val="E2E8F0"/>
+            </a:solidFill>
+            <a:prstDash val="solid"/>
+          </a:ln>
+        </p:spPr>
+      </p:sp>
+      <p:sp>
+        <p:nvSpPr>
+          <p:cNvPr id="5" name="Text 2"/>
+          <p:cNvSpPr txBox="1"/>
+          <p:nvPr/>
+        </p:nvSpPr>
+        <p:spPr>
+          <a:xfrm>
+            <a:off x="7909560" y="1783080"/>
+            <a:ext cx="3291840" cy="365760"/>
+          </a:xfrm>
+          <a:prstGeom prst="rect">
+            <a:avLst/>
+          </a:prstGeom>
+          <a:noFill/>
+          <a:ln/>
+        </p:spPr>
+        <p:txBody>
+          <a:bodyPr wrap="square" lIns="0" tIns="0" rIns="0" bIns="0" rtlCol="0" anchor="ctr"/>
+          <a:lstStyle/>
+          <a:p>
+            <a:pPr indent="0" marL="0">
+              <a:buNone/>
+            </a:pPr>
+            <a:r>
+              <a:rPr lang="en-US" sz="1800" b="1" dirty="0">
+                <a:solidFill>
+                  <a:schemeClr val="tx2"/>
+                </a:solidFill>
+              </a:rPr>
+              <a:t>Two profits, two losses</a:t>
+            </a:r>
+            <a:endParaRPr lang="en-US" sz="1800" dirty="0"/>
+          </a:p>
+        </p:txBody>
+      </p:sp>
+      <p:sp>
+        <p:nvSpPr>
+          <p:cNvPr id="6" name="Text 3"/>
+          <p:cNvSpPr txBox="1"/>
+          <p:nvPr/>
+        </p:nvSpPr>
+        <p:spPr>
+          <a:xfrm>
+            <a:off x="7909560" y="2194560"/>
+            <a:ext cx="3291840" cy="1828800"/>
+          </a:xfrm>
+          <a:prstGeom prst="rect">
+            <a:avLst/>
+          </a:prstGeom>
+          <a:noFill/>
+          <a:ln/>
+        </p:spPr>
+        <p:txBody>
+          <a:bodyPr wrap="square" lIns="0" tIns="0" rIns="0" bIns="0" rtlCol="0" anchor="ctr"/>
+          <a:lstStyle/>
+          <a:p>
+            <a:pPr indent="0" marL="0">
+              <a:buNone/>
+            </a:pPr>
+            <a:r>
+              <a:rPr lang="en-US" sz="1350" dirty="0">
+                <a:solidFill>
+                  <a:schemeClr val="tx1"/>
+                </a:solidFill>
+              </a:rPr>
+              <a:t>Significant gains against WHC (p=0.001) and IW (p=0.008), both recreational-facing houses. Significant LOSSES against both Pinnacle prices (PS p=0.050, PSC p&lt;0.001), the best forecaster in the panel, i.e. exactly the opponent an inferior model should lose to.</a:t>
+            </a:r>
+            <a:endParaRPr lang="en-US" sz="1350" dirty="0"/>
+          </a:p>
+        </p:txBody>
+      </p:sp>
+      <p:sp>
+        <p:nvSpPr>
+          <p:cNvPr id="7" name="Text 4"/>
+          <p:cNvSpPr txBox="1"/>
+          <p:nvPr/>
+        </p:nvSpPr>
+        <p:spPr>
+          <a:xfrm>
+            <a:off x="7909560" y="4114800"/>
+            <a:ext cx="3291840" cy="1005840"/>
+          </a:xfrm>
+          <a:prstGeom prst="rect">
+            <a:avLst/>
+          </a:prstGeom>
+          <a:noFill/>
+          <a:ln/>
+        </p:spPr>
+        <p:txBody>
+          <a:bodyPr wrap="square" lIns="0" tIns="0" rIns="0" bIns="0" rtlCol="0" anchor="ctr"/>
+          <a:lstStyle/>
+          <a:p>
+            <a:pPr indent="0" marL="0">
+              <a:buNone/>
+            </a:pPr>
+            <a:r>
+              <a:rPr lang="en-US" sz="1350" i="1" dirty="0">
+                <a:solidFill>
+                  <a:schemeClr val="accent5"/>
+                </a:solidFill>
+              </a:rPr>
+              <a:t>The quality gained is smaller than the margin charged.</a:t>
+            </a:r>
+            <a:endParaRPr lang="en-US" sz="1350" dirty="0"/>
+          </a:p>
+        </p:txBody>
+      </p:sp>
+      <p:sp>
+        <p:nvSpPr>
+          <p:cNvPr id="8" name="Text 5"/>
+          <p:cNvSpPr txBox="1"/>
+          <p:nvPr/>
+        </p:nvSpPr>
+        <p:spPr>
+          <a:xfrm>
+            <a:off x="640080" y="5440680"/>
+            <a:ext cx="6675120" cy="320040"/>
+          </a:xfrm>
+          <a:prstGeom prst="rect">
+            <a:avLst/>
+          </a:prstGeom>
+          <a:noFill/>
+          <a:ln/>
+        </p:spPr>
+        <p:txBody>
+          <a:bodyPr wrap="square" rtlCol="0" anchor="ctr"/>
+          <a:lstStyle/>
+          <a:p>
+            <a:pPr indent="0" marL="0">
+              <a:buNone/>
+            </a:pPr>
+            <a:r>
+              <a:rPr lang="en-US" sz="1200" i="1" dirty="0">
+                <a:solidFill>
+                  <a:schemeClr val="accent5"/>
+                </a:solidFill>
+              </a:rPr>
+              <a:t>0 = break even · +1 = a ten-fold bankroll · green = significant profit · red = significant loss</a:t>
+            </a:r>
+            <a:endParaRPr lang="en-US" sz="1200" dirty="0"/>
+          </a:p>
+        </p:txBody>
+      </p:sp>
+      <p:sp>
+        <p:nvSpPr>
+          <p:cNvPr id="25" name="Slide Number Placeholder 0"/>
+          <p:cNvSpPr>
+            <a:spLocks noGrp="1"/>
+          </p:cNvSpPr>
           <p:nvPr>
-            <p:ph idx="101" type="body" hasCustomPrompt="1"/>
+            <p:ph type="sldNum" sz="quarter" idx="4294967295"/>
           </p:nvPr>
         </p:nvSpPr>
         <p:spPr>
           <a:xfrm>
-            <a:off x="914400" y="4114800"/>
-            <a:ext cx="10332720" cy="1645920"/>
-          </a:xfrm>
-          <a:prstGeom prst="rect">
-            <a:avLst/>
-          </a:prstGeom>
-          <a:noFill/>
-          <a:ln/>
-        </p:spPr>
-        <p:txBody>
-          <a:bodyPr wrap="square" rtlCol="0" anchor="t"/>
-          <a:lstStyle/>
-          <a:p>
-            <a:pPr algn="l" indent="0" marL="0">
-              <a:buNone/>
-            </a:pPr>
-            <a:r>
-              <a:rPr lang="en-US" sz="1700" dirty="0">
-                <a:solidFill>
-                  <a:srgbClr val="CBD5E1"/>
-                </a:solidFill>
-              </a:rPr>
-              <a:t>Under the Sleeping Experts reduction the weight vector moves even with a step of ZERO: the projection is re-done onto a simplex of different dimension whenever the awake set changes. A zero-step control separates the two. The number was real; the obvious reading of it was false.</a:t>
-            </a:r>
-            <a:endParaRPr lang="en-US" sz="1700" dirty="0"/>
+            <a:off x="11521440" y="6355080"/>
+            <a:ext cx="800000" cy="300000"/>
+          </a:xfrm>
+          <a:prstGeom prst="rect">
+            <a:avLst/>
+          </a:prstGeom>
+          <a:extLst>
+            <a:ext uri="{C572A759-6A51-4108-AA02-DFA0A04FC94B}">
+              <ma14:wrappingTextBoxFlag xmlns:ma14="http://schemas.microsoft.com/office/mac/drawingml/2011/main" val="0"/>
+            </a:ext>
+          </a:extLst>
+        </p:spPr>
+        <p:txBody>
+          <a:bodyPr/>
+          <a:lstStyle>
+            <a:lvl1pPr>
+              <a:defRPr sz="1100">
+                <a:solidFill>
+                  <a:schemeClr val="accent6"/>
+                </a:solidFill>
+              </a:defRPr>
+            </a:lvl1pPr>
+          </a:lstStyle>
+          <a:p>
+            <a:pPr algn="l"/>
+            <a:fld id="{F7021451-1387-4CA6-816F-3879F97B5CBC}" type="slidenum">
+              <a:rPr b="0" lang="en-US"/>
+              <a:t>13</a:t>
+            </a:fld>
+            <a:endParaRPr lang="en-US"/>
           </a:p>
         </p:txBody>
       </p:sp>
@@ -6052,8 +6626,8 @@
         </p:nvSpPr>
         <p:spPr>
           <a:xfrm>
-            <a:off x="640080" y="411480"/>
-            <a:ext cx="10881360" cy="777240"/>
+            <a:off x="914400" y="1737360"/>
+            <a:ext cx="10332720" cy="2194560"/>
           </a:xfrm>
           <a:prstGeom prst="rect">
             <a:avLst/>
@@ -6069,923 +6643,52 @@
               <a:buNone/>
             </a:pPr>
             <a:r>
-              <a:rPr lang="en-US" sz="3000" b="1" dirty="0">
-                <a:solidFill>
-                  <a:schemeClr val="tx2"/>
-                </a:solidFill>
-              </a:rPr>
-              <a:t>Nine ideas tried and rejected</a:t>
-            </a:r>
-            <a:endParaRPr lang="en-US" sz="3000" dirty="0"/>
-          </a:p>
-        </p:txBody>
-      </p:sp>
-      <p:sp>
-        <p:nvSpPr>
-          <p:cNvPr id="3" name="neg-0"/>
+              <a:rPr lang="en-US" sz="3400" b="1" dirty="0">
+                <a:solidFill>
+                  <a:schemeClr val="bg1"/>
+                </a:solidFill>
+              </a:rPr>
+              <a:t>42% of the margin over the uniform average is not learning</a:t>
+            </a:r>
+            <a:endParaRPr lang="en-US" sz="3400" dirty="0"/>
+          </a:p>
+        </p:txBody>
+      </p:sp>
+      <p:sp>
+        <p:nvSpPr>
+          <p:cNvPr id="3" name="Text 0"/>
           <p:cNvSpPr/>
-          <p:nvPr/>
-        </p:nvSpPr>
-        <p:spPr>
-          <a:xfrm>
-            <a:off x="640080" y="1719072"/>
-            <a:ext cx="237744" cy="237744"/>
-          </a:xfrm>
-          <a:prstGeom prst="ellipse">
-            <a:avLst/>
-          </a:prstGeom>
-          <a:solidFill>
-            <a:schemeClr val="accent4"/>
-          </a:solidFill>
-          <a:ln/>
-        </p:spPr>
-      </p:sp>
-      <p:sp>
-        <p:nvSpPr>
-          <p:cNvPr id="4" name="Text 2"/>
-          <p:cNvSpPr txBox="1"/>
-          <p:nvPr/>
-        </p:nvSpPr>
-        <p:spPr>
-          <a:xfrm>
-            <a:off x="1024128" y="1645920"/>
-            <a:ext cx="3017520" cy="548640"/>
-          </a:xfrm>
-          <a:prstGeom prst="rect">
-            <a:avLst/>
-          </a:prstGeom>
-          <a:noFill/>
-          <a:ln/>
-        </p:spPr>
-        <p:txBody>
-          <a:bodyPr wrap="square" lIns="0" tIns="0" rIns="0" bIns="0" rtlCol="0" anchor="t"/>
-          <a:lstStyle/>
-          <a:p>
-            <a:pPr indent="0" marL="0">
-              <a:buNone/>
-            </a:pPr>
-            <a:r>
-              <a:rPr lang="en-US" sz="1500" b="1" dirty="0">
-                <a:solidFill>
-                  <a:schemeClr val="tx2"/>
-                </a:solidFill>
-              </a:rPr>
-              <a:t>Fixed-Share</a:t>
-            </a:r>
-            <a:endParaRPr lang="en-US" sz="1500" dirty="0"/>
-          </a:p>
-        </p:txBody>
-      </p:sp>
-      <p:sp>
-        <p:nvSpPr>
-          <p:cNvPr id="5" name="Text 3"/>
-          <p:cNvSpPr txBox="1"/>
-          <p:nvPr/>
-        </p:nvSpPr>
-        <p:spPr>
-          <a:xfrm>
-            <a:off x="1024128" y="2212848"/>
-            <a:ext cx="3017520" cy="640080"/>
-          </a:xfrm>
-          <a:prstGeom prst="rect">
-            <a:avLst/>
-          </a:prstGeom>
-          <a:noFill/>
-          <a:ln/>
-        </p:spPr>
-        <p:txBody>
-          <a:bodyPr wrap="square" lIns="0" tIns="0" rIns="0" bIns="0" rtlCol="0" anchor="t"/>
-          <a:lstStyle/>
-          <a:p>
-            <a:pPr indent="0" marL="0">
-              <a:buNone/>
-            </a:pPr>
-            <a:r>
-              <a:rPr lang="en-US" sz="1250" dirty="0">
-                <a:solidFill>
-                  <a:schemeClr val="accent5"/>
-                </a:solidFill>
-              </a:rPr>
-              <a:t>every α &gt; 0 loses</a:t>
-            </a:r>
-            <a:endParaRPr lang="en-US" sz="1250" dirty="0"/>
-          </a:p>
-        </p:txBody>
-      </p:sp>
-      <p:sp>
-        <p:nvSpPr>
-          <p:cNvPr id="6" name="neg-1"/>
-          <p:cNvSpPr/>
-          <p:nvPr/>
-        </p:nvSpPr>
-        <p:spPr>
-          <a:xfrm>
-            <a:off x="4297680" y="1719072"/>
-            <a:ext cx="237744" cy="237744"/>
-          </a:xfrm>
-          <a:prstGeom prst="ellipse">
-            <a:avLst/>
-          </a:prstGeom>
-          <a:solidFill>
-            <a:schemeClr val="accent4"/>
-          </a:solidFill>
-          <a:ln/>
-        </p:spPr>
-      </p:sp>
-      <p:sp>
-        <p:nvSpPr>
-          <p:cNvPr id="7" name="Text 5"/>
-          <p:cNvSpPr txBox="1"/>
-          <p:nvPr/>
-        </p:nvSpPr>
-        <p:spPr>
-          <a:xfrm>
-            <a:off x="4681728" y="1645920"/>
-            <a:ext cx="3017520" cy="548640"/>
-          </a:xfrm>
-          <a:prstGeom prst="rect">
-            <a:avLst/>
-          </a:prstGeom>
-          <a:noFill/>
-          <a:ln/>
-        </p:spPr>
-        <p:txBody>
-          <a:bodyPr wrap="square" lIns="0" tIns="0" rIns="0" bIns="0" rtlCol="0" anchor="t"/>
-          <a:lstStyle/>
-          <a:p>
-            <a:pPr indent="0" marL="0">
-              <a:buNone/>
-            </a:pPr>
-            <a:r>
-              <a:rPr lang="en-US" sz="1500" b="1" dirty="0">
-                <a:solidFill>
-                  <a:schemeClr val="tx2"/>
-                </a:solidFill>
-              </a:rPr>
-              <a:t>Per-expert step clock</a:t>
-            </a:r>
-            <a:endParaRPr lang="en-US" sz="1500" dirty="0"/>
-          </a:p>
-        </p:txBody>
-      </p:sp>
-      <p:sp>
-        <p:nvSpPr>
-          <p:cNvPr id="8" name="Text 6"/>
-          <p:cNvSpPr txBox="1"/>
-          <p:nvPr/>
-        </p:nvSpPr>
-        <p:spPr>
-          <a:xfrm>
-            <a:off x="4681728" y="2212848"/>
-            <a:ext cx="3017520" cy="640080"/>
-          </a:xfrm>
-          <a:prstGeom prst="rect">
-            <a:avLst/>
-          </a:prstGeom>
-          <a:noFill/>
-          <a:ln/>
-        </p:spPr>
-        <p:txBody>
-          <a:bodyPr wrap="square" lIns="0" tIns="0" rIns="0" bIns="0" rtlCol="0" anchor="t"/>
-          <a:lstStyle/>
-          <a:p>
-            <a:pPr indent="0" marL="0">
-              <a:buNone/>
-            </a:pPr>
-            <a:r>
-              <a:rPr lang="en-US" sz="1250" dirty="0">
-                <a:solidFill>
-                  <a:schemeClr val="accent5"/>
-                </a:solidFill>
-              </a:rPr>
-              <a:t>−0.00073 on the tail: overfitting</a:t>
-            </a:r>
-            <a:endParaRPr lang="en-US" sz="1250" dirty="0"/>
-          </a:p>
-        </p:txBody>
-      </p:sp>
-      <p:sp>
-        <p:nvSpPr>
-          <p:cNvPr id="9" name="neg-2"/>
-          <p:cNvSpPr/>
-          <p:nvPr/>
-        </p:nvSpPr>
-        <p:spPr>
-          <a:xfrm>
-            <a:off x="7955280" y="1719072"/>
-            <a:ext cx="237744" cy="237744"/>
-          </a:xfrm>
-          <a:prstGeom prst="ellipse">
-            <a:avLst/>
-          </a:prstGeom>
-          <a:solidFill>
-            <a:schemeClr val="accent4"/>
-          </a:solidFill>
-          <a:ln/>
-        </p:spPr>
-      </p:sp>
-      <p:sp>
-        <p:nvSpPr>
-          <p:cNvPr id="10" name="Text 8"/>
-          <p:cNvSpPr txBox="1"/>
-          <p:nvPr/>
-        </p:nvSpPr>
-        <p:spPr>
-          <a:xfrm>
-            <a:off x="8339328" y="1645920"/>
-            <a:ext cx="3017520" cy="548640"/>
-          </a:xfrm>
-          <a:prstGeom prst="rect">
-            <a:avLst/>
-          </a:prstGeom>
-          <a:noFill/>
-          <a:ln/>
-        </p:spPr>
-        <p:txBody>
-          <a:bodyPr wrap="square" lIns="0" tIns="0" rIns="0" bIns="0" rtlCol="0" anchor="t"/>
-          <a:lstStyle/>
-          <a:p>
-            <a:pPr indent="0" marL="0">
-              <a:buNone/>
-            </a:pPr>
-            <a:r>
-              <a:rPr lang="en-US" sz="1500" b="1" dirty="0">
-                <a:solidFill>
-                  <a:schemeClr val="tx2"/>
-                </a:solidFill>
-              </a:rPr>
-              <a:t>Markov kernels on the weights</a:t>
-            </a:r>
-            <a:endParaRPr lang="en-US" sz="1500" dirty="0"/>
-          </a:p>
-        </p:txBody>
-      </p:sp>
-      <p:sp>
-        <p:nvSpPr>
-          <p:cNvPr id="11" name="Text 9"/>
-          <p:cNvSpPr txBox="1"/>
-          <p:nvPr/>
-        </p:nvSpPr>
-        <p:spPr>
-          <a:xfrm>
-            <a:off x="8339328" y="2212848"/>
-            <a:ext cx="3017520" cy="640080"/>
-          </a:xfrm>
-          <a:prstGeom prst="rect">
-            <a:avLst/>
-          </a:prstGeom>
-          <a:noFill/>
-          <a:ln/>
-        </p:spPr>
-        <p:txBody>
-          <a:bodyPr wrap="square" lIns="0" tIns="0" rIns="0" bIns="0" rtlCol="0" anchor="t"/>
-          <a:lstStyle/>
-          <a:p>
-            <a:pPr indent="0" marL="0">
-              <a:buNone/>
-            </a:pPr>
-            <a:r>
-              <a:rPr lang="en-US" sz="1250" dirty="0">
-                <a:solidFill>
-                  <a:schemeClr val="accent5"/>
-                </a:solidFill>
-              </a:rPr>
-              <a:t>every kernel selects α = 0</a:t>
-            </a:r>
-            <a:endParaRPr lang="en-US" sz="1250" dirty="0"/>
-          </a:p>
-        </p:txBody>
-      </p:sp>
-      <p:sp>
-        <p:nvSpPr>
-          <p:cNvPr id="12" name="neg-3"/>
-          <p:cNvSpPr/>
-          <p:nvPr/>
-        </p:nvSpPr>
-        <p:spPr>
-          <a:xfrm>
-            <a:off x="640080" y="3090672"/>
-            <a:ext cx="237744" cy="237744"/>
-          </a:xfrm>
-          <a:prstGeom prst="ellipse">
-            <a:avLst/>
-          </a:prstGeom>
-          <a:solidFill>
-            <a:schemeClr val="accent4"/>
-          </a:solidFill>
-          <a:ln/>
-        </p:spPr>
-      </p:sp>
-      <p:sp>
-        <p:nvSpPr>
-          <p:cNvPr id="13" name="Text 11"/>
-          <p:cNvSpPr txBox="1"/>
-          <p:nvPr/>
-        </p:nvSpPr>
-        <p:spPr>
-          <a:xfrm>
-            <a:off x="1024128" y="3017520"/>
-            <a:ext cx="3017520" cy="548640"/>
-          </a:xfrm>
-          <a:prstGeom prst="rect">
-            <a:avLst/>
-          </a:prstGeom>
-          <a:noFill/>
-          <a:ln/>
-        </p:spPr>
-        <p:txBody>
-          <a:bodyPr wrap="square" lIns="0" tIns="0" rIns="0" bIns="0" rtlCol="0" anchor="t"/>
-          <a:lstStyle/>
-          <a:p>
-            <a:pPr indent="0" marL="0">
-              <a:buNone/>
-            </a:pPr>
-            <a:r>
-              <a:rPr lang="en-US" sz="1500" b="1" dirty="0">
-                <a:solidFill>
-                  <a:schemeClr val="tx2"/>
-                </a:solidFill>
-              </a:rPr>
-              <a:t>Latent market regimes</a:t>
-            </a:r>
-            <a:endParaRPr lang="en-US" sz="1500" dirty="0"/>
-          </a:p>
-        </p:txBody>
-      </p:sp>
-      <p:sp>
-        <p:nvSpPr>
-          <p:cNvPr id="14" name="Text 12"/>
-          <p:cNvSpPr txBox="1"/>
-          <p:nvPr/>
-        </p:nvSpPr>
-        <p:spPr>
-          <a:xfrm>
-            <a:off x="1024128" y="3584448"/>
-            <a:ext cx="3017520" cy="640080"/>
-          </a:xfrm>
-          <a:prstGeom prst="rect">
-            <a:avLst/>
-          </a:prstGeom>
-          <a:noFill/>
-          <a:ln/>
-        </p:spPr>
-        <p:txBody>
-          <a:bodyPr wrap="square" lIns="0" tIns="0" rIns="0" bIns="0" rtlCol="0" anchor="t"/>
-          <a:lstStyle/>
-          <a:p>
-            <a:pPr indent="0" marL="0">
-              <a:buNone/>
-            </a:pPr>
-            <a:r>
-              <a:rPr lang="en-US" sz="1250" dirty="0">
-                <a:solidFill>
-                  <a:schemeClr val="accent5"/>
-                </a:solidFill>
-              </a:rPr>
-              <a:t>belief sd 0.0000: it does nothing</a:t>
-            </a:r>
-            <a:endParaRPr lang="en-US" sz="1250" dirty="0"/>
-          </a:p>
-        </p:txBody>
-      </p:sp>
-      <p:sp>
-        <p:nvSpPr>
-          <p:cNvPr id="15" name="neg-4"/>
-          <p:cNvSpPr/>
-          <p:nvPr/>
-        </p:nvSpPr>
-        <p:spPr>
-          <a:xfrm>
-            <a:off x="4297680" y="3090672"/>
-            <a:ext cx="237744" cy="237744"/>
-          </a:xfrm>
-          <a:prstGeom prst="ellipse">
-            <a:avLst/>
-          </a:prstGeom>
-          <a:solidFill>
-            <a:schemeClr val="accent4"/>
-          </a:solidFill>
-          <a:ln/>
-        </p:spPr>
-      </p:sp>
-      <p:sp>
-        <p:nvSpPr>
-          <p:cNvPr id="16" name="Text 14"/>
-          <p:cNvSpPr txBox="1"/>
-          <p:nvPr/>
-        </p:nvSpPr>
-        <p:spPr>
-          <a:xfrm>
-            <a:off x="4681728" y="3017520"/>
-            <a:ext cx="3017520" cy="548640"/>
-          </a:xfrm>
-          <a:prstGeom prst="rect">
-            <a:avLst/>
-          </a:prstGeom>
-          <a:noFill/>
-          <a:ln/>
-        </p:spPr>
-        <p:txBody>
-          <a:bodyPr wrap="square" lIns="0" tIns="0" rIns="0" bIns="0" rtlCol="0" anchor="t"/>
-          <a:lstStyle/>
-          <a:p>
-            <a:pPr indent="0" marL="0">
-              <a:buNone/>
-            </a:pPr>
-            <a:r>
-              <a:rPr lang="en-US" sz="1500" b="1" dirty="0">
-                <a:solidFill>
-                  <a:schemeClr val="tx2"/>
-                </a:solidFill>
-              </a:rPr>
-              <a:t>Bandit, one-point estimator</a:t>
-            </a:r>
-            <a:endParaRPr lang="en-US" sz="1500" dirty="0"/>
-          </a:p>
-        </p:txBody>
-      </p:sp>
-      <p:sp>
-        <p:nvSpPr>
-          <p:cNvPr id="17" name="Text 15"/>
-          <p:cNvSpPr txBox="1"/>
-          <p:nvPr/>
-        </p:nvSpPr>
-        <p:spPr>
-          <a:xfrm>
-            <a:off x="4681728" y="3584448"/>
-            <a:ext cx="3017520" cy="640080"/>
-          </a:xfrm>
-          <a:prstGeom prst="rect">
-            <a:avLst/>
-          </a:prstGeom>
-          <a:noFill/>
-          <a:ln/>
-        </p:spPr>
-        <p:txBody>
-          <a:bodyPr wrap="square" lIns="0" tIns="0" rIns="0" bIns="0" rtlCol="0" anchor="t"/>
-          <a:lstStyle/>
-          <a:p>
-            <a:pPr indent="0" marL="0">
-              <a:buNone/>
-            </a:pPr>
-            <a:r>
-              <a:rPr lang="en-US" sz="1250" dirty="0">
-                <a:solidFill>
-                  <a:schemeClr val="accent5"/>
-                </a:solidFill>
-              </a:rPr>
-              <a:t>the horizon is too short</a:t>
-            </a:r>
-            <a:endParaRPr lang="en-US" sz="1250" dirty="0"/>
-          </a:p>
-        </p:txBody>
-      </p:sp>
-      <p:sp>
-        <p:nvSpPr>
-          <p:cNvPr id="18" name="neg-5"/>
-          <p:cNvSpPr/>
-          <p:nvPr/>
-        </p:nvSpPr>
-        <p:spPr>
-          <a:xfrm>
-            <a:off x="7955280" y="3090672"/>
-            <a:ext cx="237744" cy="237744"/>
-          </a:xfrm>
-          <a:prstGeom prst="ellipse">
-            <a:avLst/>
-          </a:prstGeom>
-          <a:solidFill>
-            <a:schemeClr val="accent4"/>
-          </a:solidFill>
-          <a:ln/>
-        </p:spPr>
-      </p:sp>
-      <p:sp>
-        <p:nvSpPr>
-          <p:cNvPr id="19" name="Text 17"/>
-          <p:cNvSpPr txBox="1"/>
-          <p:nvPr/>
-        </p:nvSpPr>
-        <p:spPr>
-          <a:xfrm>
-            <a:off x="8339328" y="3017520"/>
-            <a:ext cx="3017520" cy="548640"/>
-          </a:xfrm>
-          <a:prstGeom prst="rect">
-            <a:avLst/>
-          </a:prstGeom>
-          <a:noFill/>
-          <a:ln/>
-        </p:spPr>
-        <p:txBody>
-          <a:bodyPr wrap="square" lIns="0" tIns="0" rIns="0" bIns="0" rtlCol="0" anchor="t"/>
-          <a:lstStyle/>
-          <a:p>
-            <a:pPr indent="0" marL="0">
-              <a:buNone/>
-            </a:pPr>
-            <a:r>
-              <a:rPr lang="en-US" sz="1500" b="1" dirty="0">
-                <a:solidFill>
-                  <a:schemeClr val="tx2"/>
-                </a:solidFill>
-              </a:rPr>
-              <a:t>Bayesian / MCMC Kelly</a:t>
-            </a:r>
-            <a:endParaRPr lang="en-US" sz="1500" dirty="0"/>
-          </a:p>
-        </p:txBody>
-      </p:sp>
-      <p:sp>
-        <p:nvSpPr>
-          <p:cNvPr id="20" name="Text 18"/>
-          <p:cNvSpPr txBox="1"/>
-          <p:nvPr/>
-        </p:nvSpPr>
-        <p:spPr>
-          <a:xfrm>
-            <a:off x="8339328" y="3584448"/>
-            <a:ext cx="3017520" cy="640080"/>
-          </a:xfrm>
-          <a:prstGeom prst="rect">
-            <a:avLst/>
-          </a:prstGeom>
-          <a:noFill/>
-          <a:ln/>
-        </p:spPr>
-        <p:txBody>
-          <a:bodyPr wrap="square" lIns="0" tIns="0" rIns="0" bIns="0" rtlCol="0" anchor="t"/>
-          <a:lstStyle/>
-          <a:p>
-            <a:pPr indent="0" marL="0">
-              <a:buNone/>
-            </a:pPr>
-            <a:r>
-              <a:rPr lang="en-US" sz="1250" dirty="0">
-                <a:solidFill>
-                  <a:schemeClr val="accent5"/>
-                </a:solidFill>
-              </a:rPr>
-              <a:t>6 ties, 2 losses, zero wins</a:t>
-            </a:r>
-            <a:endParaRPr lang="en-US" sz="1250" dirty="0"/>
-          </a:p>
-        </p:txBody>
-      </p:sp>
-      <p:sp>
-        <p:nvSpPr>
-          <p:cNvPr id="21" name="neg-6"/>
-          <p:cNvSpPr/>
-          <p:nvPr/>
-        </p:nvSpPr>
-        <p:spPr>
-          <a:xfrm>
-            <a:off x="640080" y="4462272"/>
-            <a:ext cx="237744" cy="237744"/>
-          </a:xfrm>
-          <a:prstGeom prst="ellipse">
-            <a:avLst/>
-          </a:prstGeom>
-          <a:solidFill>
-            <a:schemeClr val="accent4"/>
-          </a:solidFill>
-          <a:ln/>
-        </p:spPr>
-      </p:sp>
-      <p:sp>
-        <p:nvSpPr>
-          <p:cNvPr id="22" name="Text 20"/>
-          <p:cNvSpPr txBox="1"/>
-          <p:nvPr/>
-        </p:nvSpPr>
-        <p:spPr>
-          <a:xfrm>
-            <a:off x="1024128" y="4389120"/>
-            <a:ext cx="3017520" cy="548640"/>
-          </a:xfrm>
-          <a:prstGeom prst="rect">
-            <a:avLst/>
-          </a:prstGeom>
-          <a:noFill/>
-          <a:ln/>
-        </p:spPr>
-        <p:txBody>
-          <a:bodyPr wrap="square" lIns="0" tIns="0" rIns="0" bIns="0" rtlCol="0" anchor="t"/>
-          <a:lstStyle/>
-          <a:p>
-            <a:pPr indent="0" marL="0">
-              <a:buNone/>
-            </a:pPr>
-            <a:r>
-              <a:rPr lang="en-US" sz="1500" b="1" dirty="0">
-                <a:solidFill>
-                  <a:schemeClr val="tx2"/>
-                </a:solidFill>
-              </a:rPr>
-              <a:t>Per-league specialisation</a:t>
-            </a:r>
-            <a:endParaRPr lang="en-US" sz="1500" dirty="0"/>
-          </a:p>
-        </p:txBody>
-      </p:sp>
-      <p:sp>
-        <p:nvSpPr>
-          <p:cNvPr id="23" name="Text 21"/>
-          <p:cNvSpPr txBox="1"/>
-          <p:nvPr/>
-        </p:nvSpPr>
-        <p:spPr>
-          <a:xfrm>
-            <a:off x="1024128" y="4956048"/>
-            <a:ext cx="3017520" cy="640080"/>
-          </a:xfrm>
-          <a:prstGeom prst="rect">
-            <a:avLst/>
-          </a:prstGeom>
-          <a:noFill/>
-          <a:ln/>
-        </p:spPr>
-        <p:txBody>
-          <a:bodyPr wrap="square" lIns="0" tIns="0" rIns="0" bIns="0" rtlCol="0" anchor="t"/>
-          <a:lstStyle/>
-          <a:p>
-            <a:pPr indent="0" marL="0">
-              <a:buNone/>
-            </a:pPr>
-            <a:r>
-              <a:rPr lang="en-US" sz="1250" dirty="0">
-                <a:solidFill>
-                  <a:schemeClr val="accent5"/>
-                </a:solidFill>
-              </a:rPr>
-              <a:t>loses in all six leagues</a:t>
-            </a:r>
-            <a:endParaRPr lang="en-US" sz="1250" dirty="0"/>
-          </a:p>
-        </p:txBody>
-      </p:sp>
-      <p:sp>
-        <p:nvSpPr>
-          <p:cNvPr id="24" name="neg-7"/>
-          <p:cNvSpPr/>
-          <p:nvPr/>
-        </p:nvSpPr>
-        <p:spPr>
-          <a:xfrm>
-            <a:off x="4297680" y="4462272"/>
-            <a:ext cx="237744" cy="237744"/>
-          </a:xfrm>
-          <a:prstGeom prst="ellipse">
-            <a:avLst/>
-          </a:prstGeom>
-          <a:solidFill>
-            <a:schemeClr val="accent4"/>
-          </a:solidFill>
-          <a:ln/>
-        </p:spPr>
-      </p:sp>
-      <p:sp>
-        <p:nvSpPr>
-          <p:cNvPr id="25" name="Text 23"/>
-          <p:cNvSpPr txBox="1"/>
-          <p:nvPr/>
-        </p:nvSpPr>
-        <p:spPr>
-          <a:xfrm>
-            <a:off x="4681728" y="4389120"/>
-            <a:ext cx="3017520" cy="548640"/>
-          </a:xfrm>
-          <a:prstGeom prst="rect">
-            <a:avLst/>
-          </a:prstGeom>
-          <a:noFill/>
-          <a:ln/>
-        </p:spPr>
-        <p:txBody>
-          <a:bodyPr wrap="square" lIns="0" tIns="0" rIns="0" bIns="0" rtlCol="0" anchor="t"/>
-          <a:lstStyle/>
-          <a:p>
-            <a:pPr indent="0" marL="0">
-              <a:buNone/>
-            </a:pPr>
-            <a:r>
-              <a:rPr lang="en-US" sz="1500" b="1" dirty="0">
-                <a:solidFill>
-                  <a:schemeClr val="tx2"/>
-                </a:solidFill>
-              </a:rPr>
-              <a:t>AdaGrad</a:t>
-            </a:r>
-            <a:endParaRPr lang="en-US" sz="1500" dirty="0"/>
-          </a:p>
-        </p:txBody>
-      </p:sp>
-      <p:sp>
-        <p:nvSpPr>
-          <p:cNvPr id="26" name="Text 24"/>
-          <p:cNvSpPr txBox="1"/>
-          <p:nvPr/>
-        </p:nvSpPr>
-        <p:spPr>
-          <a:xfrm>
-            <a:off x="4681728" y="4956048"/>
-            <a:ext cx="3017520" cy="640080"/>
-          </a:xfrm>
-          <a:prstGeom prst="rect">
-            <a:avLst/>
-          </a:prstGeom>
-          <a:noFill/>
-          <a:ln/>
-        </p:spPr>
-        <p:txBody>
-          <a:bodyPr wrap="square" lIns="0" tIns="0" rIns="0" bIns="0" rtlCol="0" anchor="t"/>
-          <a:lstStyle/>
-          <a:p>
-            <a:pPr indent="0" marL="0">
-              <a:buNone/>
-            </a:pPr>
-            <a:r>
-              <a:rPr lang="en-US" sz="1250" dirty="0">
-                <a:solidFill>
-                  <a:schemeClr val="accent5"/>
-                </a:solidFill>
-              </a:rPr>
-              <a:t>recovers 20% at best</a:t>
-            </a:r>
-            <a:endParaRPr lang="en-US" sz="1250" dirty="0"/>
-          </a:p>
-        </p:txBody>
-      </p:sp>
-      <p:sp>
-        <p:nvSpPr>
-          <p:cNvPr id="27" name="neg-8"/>
-          <p:cNvSpPr/>
-          <p:nvPr/>
-        </p:nvSpPr>
-        <p:spPr>
-          <a:xfrm>
-            <a:off x="7955280" y="4462272"/>
-            <a:ext cx="237744" cy="237744"/>
-          </a:xfrm>
-          <a:prstGeom prst="ellipse">
-            <a:avLst/>
-          </a:prstGeom>
-          <a:solidFill>
-            <a:schemeClr val="accent4"/>
-          </a:solidFill>
-          <a:ln/>
-        </p:spPr>
-      </p:sp>
-      <p:sp>
-        <p:nvSpPr>
-          <p:cNvPr id="28" name="Text 26"/>
-          <p:cNvSpPr txBox="1"/>
-          <p:nvPr/>
-        </p:nvSpPr>
-        <p:spPr>
-          <a:xfrm>
-            <a:off x="8339328" y="4389120"/>
-            <a:ext cx="3017520" cy="548640"/>
-          </a:xfrm>
-          <a:prstGeom prst="rect">
-            <a:avLst/>
-          </a:prstGeom>
-          <a:noFill/>
-          <a:ln/>
-        </p:spPr>
-        <p:txBody>
-          <a:bodyPr wrap="square" lIns="0" tIns="0" rIns="0" bIns="0" rtlCol="0" anchor="t"/>
-          <a:lstStyle/>
-          <a:p>
-            <a:pPr indent="0" marL="0">
-              <a:buNone/>
-            </a:pPr>
-            <a:r>
-              <a:rPr lang="en-US" sz="1500" b="1" dirty="0">
-                <a:solidFill>
-                  <a:schemeClr val="tx2"/>
-                </a:solidFill>
-              </a:rPr>
-              <a:t>Joint step + calibration sweep</a:t>
-            </a:r>
-            <a:endParaRPr lang="en-US" sz="1500" dirty="0"/>
-          </a:p>
-        </p:txBody>
-      </p:sp>
-      <p:sp>
-        <p:nvSpPr>
-          <p:cNvPr id="29" name="Text 27"/>
-          <p:cNvSpPr txBox="1"/>
-          <p:nvPr/>
-        </p:nvSpPr>
-        <p:spPr>
-          <a:xfrm>
-            <a:off x="8339328" y="4956048"/>
-            <a:ext cx="3017520" cy="640080"/>
-          </a:xfrm>
-          <a:prstGeom prst="rect">
-            <a:avLst/>
-          </a:prstGeom>
-          <a:noFill/>
-          <a:ln/>
-        </p:spPr>
-        <p:txBody>
-          <a:bodyPr wrap="square" lIns="0" tIns="0" rIns="0" bIns="0" rtlCol="0" anchor="t"/>
-          <a:lstStyle/>
-          <a:p>
-            <a:pPr indent="0" marL="0">
-              <a:buNone/>
-            </a:pPr>
-            <a:r>
-              <a:rPr lang="en-US" sz="1250" dirty="0">
-                <a:solidFill>
-                  <a:schemeClr val="accent5"/>
-                </a:solidFill>
-              </a:rPr>
-              <a:t>no interaction at all</a:t>
-            </a:r>
-            <a:endParaRPr lang="en-US" sz="1250" dirty="0"/>
-          </a:p>
-        </p:txBody>
-      </p:sp>
-      <p:sp>
-        <p:nvSpPr>
-          <p:cNvPr id="30" name="Text 28"/>
-          <p:cNvSpPr txBox="1"/>
-          <p:nvPr/>
-        </p:nvSpPr>
-        <p:spPr>
-          <a:xfrm>
-            <a:off x="640080" y="5852160"/>
-            <a:ext cx="10881360" cy="640080"/>
-          </a:xfrm>
-          <a:prstGeom prst="rect">
-            <a:avLst/>
-          </a:prstGeom>
-          <a:noFill/>
-          <a:ln/>
-        </p:spPr>
-        <p:txBody>
-          <a:bodyPr wrap="square" rtlCol="0" anchor="ctr"/>
-          <a:lstStyle/>
-          <a:p>
-            <a:pPr indent="0" marL="0">
-              <a:buNone/>
-            </a:pPr>
-            <a:r>
-              <a:rPr lang="en-US" sz="1500" dirty="0">
-                <a:solidFill>
-                  <a:schemeClr val="tx1"/>
-                </a:solidFill>
-              </a:rPr>
-              <a:t>One pattern unites them: once the step size is tuned, no further movement of mass over the experts buys anything. The step and the leak control the same quantity.</a:t>
-            </a:r>
-            <a:endParaRPr lang="en-US" sz="1500" dirty="0"/>
-          </a:p>
-        </p:txBody>
-      </p:sp>
-      <p:sp>
-        <p:nvSpPr>
-          <p:cNvPr id="25" name="Slide Number Placeholder 0"/>
-          <p:cNvSpPr>
-            <a:spLocks noGrp="1"/>
-          </p:cNvSpPr>
           <p:nvPr>
-            <p:ph type="sldNum" sz="quarter" idx="4294967295"/>
+            <p:ph idx="101" type="body" hasCustomPrompt="1"/>
           </p:nvPr>
         </p:nvSpPr>
         <p:spPr>
           <a:xfrm>
-            <a:off x="11521440" y="6355080"/>
-            <a:ext cx="800000" cy="300000"/>
-          </a:xfrm>
-          <a:prstGeom prst="rect">
-            <a:avLst/>
-          </a:prstGeom>
-          <a:extLst>
-            <a:ext uri="{C572A759-6A51-4108-AA02-DFA0A04FC94B}">
-              <ma14:wrappingTextBoxFlag xmlns:ma14="http://schemas.microsoft.com/office/mac/drawingml/2011/main" val="0"/>
-            </a:ext>
-          </a:extLst>
-        </p:spPr>
-        <p:txBody>
-          <a:bodyPr/>
-          <a:lstStyle>
-            <a:lvl1pPr>
-              <a:defRPr sz="1100">
-                <a:solidFill>
-                  <a:schemeClr val="accent6"/>
-                </a:solidFill>
-              </a:defRPr>
-            </a:lvl1pPr>
-          </a:lstStyle>
-          <a:p>
-            <a:pPr algn="l"/>
-            <a:fld id="{F7021451-1387-4CA6-816F-3879F97B5CBC}" type="slidenum">
-              <a:rPr b="0" lang="en-US"/>
-              <a:t>14</a:t>
-            </a:fld>
-            <a:endParaRPr lang="en-US"/>
+            <a:off x="914400" y="4114800"/>
+            <a:ext cx="10332720" cy="1645920"/>
+          </a:xfrm>
+          <a:prstGeom prst="rect">
+            <a:avLst/>
+          </a:prstGeom>
+          <a:noFill/>
+          <a:ln/>
+        </p:spPr>
+        <p:txBody>
+          <a:bodyPr wrap="square" rtlCol="0" anchor="t"/>
+          <a:lstStyle/>
+          <a:p>
+            <a:pPr algn="l" indent="0" marL="0">
+              <a:buNone/>
+            </a:pPr>
+            <a:r>
+              <a:rPr lang="en-US" sz="1700" dirty="0">
+                <a:solidFill>
+                  <a:srgbClr val="CBD5E1"/>
+                </a:solidFill>
+              </a:rPr>
+              <a:t>Under the Sleeping Experts reduction the weight vector moves even with a step of ZERO: the projection is re-done onto a simplex of different dimension whenever the awake set changes. A zero-step control separates the two. The number was real; the obvious reading of it was false.</a:t>
+            </a:r>
+            <a:endParaRPr lang="en-US" sz="1700" dirty="0"/>
           </a:p>
         </p:txBody>
       </p:sp>
@@ -7046,7 +6749,7 @@
                   <a:schemeClr val="tx2"/>
                 </a:solidFill>
               </a:rPr>
-              <a:t>Conclusions</a:t>
+              <a:t>Nine ideas tried and rejected</a:t>
             </a:r>
             <a:endParaRPr lang="en-US" sz="3000" dirty="0"/>
           </a:p>
@@ -7054,198 +6757,14 @@
       </p:sp>
       <p:sp>
         <p:nvSpPr>
-          <p:cNvPr id="3" name="cc-0"/>
+          <p:cNvPr id="3" name="neg-0"/>
           <p:cNvSpPr/>
           <p:nvPr/>
         </p:nvSpPr>
         <p:spPr>
           <a:xfrm>
-            <a:off x="640080" y="1554480"/>
-            <a:ext cx="256032" cy="256032"/>
-          </a:xfrm>
-          <a:prstGeom prst="ellipse">
-            <a:avLst/>
-          </a:prstGeom>
-          <a:solidFill>
-            <a:schemeClr val="accent3"/>
-          </a:solidFill>
-          <a:ln/>
-        </p:spPr>
-      </p:sp>
-      <p:sp>
-        <p:nvSpPr>
-          <p:cNvPr id="4" name="Text 2"/>
-          <p:cNvSpPr txBox="1"/>
-          <p:nvPr/>
-        </p:nvSpPr>
-        <p:spPr>
-          <a:xfrm>
-            <a:off x="1078992" y="1463040"/>
-            <a:ext cx="3931920" cy="411480"/>
-          </a:xfrm>
-          <a:prstGeom prst="rect">
-            <a:avLst/>
-          </a:prstGeom>
-          <a:noFill/>
-          <a:ln/>
-        </p:spPr>
-        <p:txBody>
-          <a:bodyPr wrap="square" lIns="0" tIns="0" rIns="0" bIns="0" rtlCol="0" anchor="t"/>
-          <a:lstStyle/>
-          <a:p>
-            <a:pPr indent="0" marL="0">
-              <a:buNone/>
-            </a:pPr>
-            <a:r>
-              <a:rPr lang="en-US" sz="1600" b="1" dirty="0">
-                <a:solidFill>
-                  <a:schemeClr val="tx2"/>
-                </a:solidFill>
-              </a:rPr>
-              <a:t>The framework applies</a:t>
-            </a:r>
-            <a:endParaRPr lang="en-US" sz="1600" dirty="0"/>
-          </a:p>
-        </p:txBody>
-      </p:sp>
-      <p:sp>
-        <p:nvSpPr>
-          <p:cNvPr id="5" name="Text 3"/>
-          <p:cNvSpPr txBox="1"/>
-          <p:nvPr/>
-        </p:nvSpPr>
-        <p:spPr>
-          <a:xfrm>
-            <a:off x="5166360" y="1463040"/>
-            <a:ext cx="6355080" cy="777240"/>
-          </a:xfrm>
-          <a:prstGeom prst="rect">
-            <a:avLst/>
-          </a:prstGeom>
-          <a:noFill/>
-          <a:ln/>
-        </p:spPr>
-        <p:txBody>
-          <a:bodyPr wrap="square" lIns="0" tIns="0" rIns="0" bIns="0" rtlCol="0" anchor="t"/>
-          <a:lstStyle/>
-          <a:p>
-            <a:pPr indent="0" marL="0">
-              <a:buNone/>
-            </a:pPr>
-            <a:r>
-              <a:rPr lang="en-US" sz="1350" dirty="0">
-                <a:solidFill>
-                  <a:schemeClr val="accent5"/>
-                </a:solidFill>
-              </a:rPr>
-              <a:t>An online mixture of published odds beats the uniform average and almost every individual bookmaker, with no distributional assumption.</a:t>
-            </a:r>
-            <a:endParaRPr lang="en-US" sz="1350" dirty="0"/>
-          </a:p>
-        </p:txBody>
-      </p:sp>
-      <p:sp>
-        <p:nvSpPr>
-          <p:cNvPr id="6" name="cc-1"/>
-          <p:cNvSpPr/>
-          <p:nvPr/>
-        </p:nvSpPr>
-        <p:spPr>
-          <a:xfrm>
-            <a:off x="640080" y="2496312"/>
-            <a:ext cx="256032" cy="256032"/>
-          </a:xfrm>
-          <a:prstGeom prst="ellipse">
-            <a:avLst/>
-          </a:prstGeom>
-          <a:solidFill>
-            <a:schemeClr val="accent1"/>
-          </a:solidFill>
-          <a:ln/>
-        </p:spPr>
-      </p:sp>
-      <p:sp>
-        <p:nvSpPr>
-          <p:cNvPr id="7" name="Text 5"/>
-          <p:cNvSpPr txBox="1"/>
-          <p:nvPr/>
-        </p:nvSpPr>
-        <p:spPr>
-          <a:xfrm>
-            <a:off x="1078992" y="2404872"/>
-            <a:ext cx="3931920" cy="411480"/>
-          </a:xfrm>
-          <a:prstGeom prst="rect">
-            <a:avLst/>
-          </a:prstGeom>
-          <a:noFill/>
-          <a:ln/>
-        </p:spPr>
-        <p:txBody>
-          <a:bodyPr wrap="square" lIns="0" tIns="0" rIns="0" bIns="0" rtlCol="0" anchor="t"/>
-          <a:lstStyle/>
-          <a:p>
-            <a:pPr indent="0" marL="0">
-              <a:buNone/>
-            </a:pPr>
-            <a:r>
-              <a:rPr lang="en-US" sz="1600" b="1" dirty="0">
-                <a:solidFill>
-                  <a:schemeClr val="tx2"/>
-                </a:solidFill>
-              </a:rPr>
-              <a:t>It reaches the market's edge</a:t>
-            </a:r>
-            <a:endParaRPr lang="en-US" sz="1600" dirty="0"/>
-          </a:p>
-        </p:txBody>
-      </p:sp>
-      <p:sp>
-        <p:nvSpPr>
-          <p:cNvPr id="8" name="Text 6"/>
-          <p:cNvSpPr txBox="1"/>
-          <p:nvPr/>
-        </p:nvSpPr>
-        <p:spPr>
-          <a:xfrm>
-            <a:off x="5166360" y="2404872"/>
-            <a:ext cx="6355080" cy="777240"/>
-          </a:xfrm>
-          <a:prstGeom prst="rect">
-            <a:avLst/>
-          </a:prstGeom>
-          <a:noFill/>
-          <a:ln/>
-        </p:spPr>
-        <p:txBody>
-          <a:bodyPr wrap="square" lIns="0" tIns="0" rIns="0" bIns="0" rtlCol="0" anchor="t"/>
-          <a:lstStyle/>
-          <a:p>
-            <a:pPr indent="0" marL="0">
-              <a:buNone/>
-            </a:pPr>
-            <a:r>
-              <a:rPr lang="en-US" sz="1350" dirty="0">
-                <a:solidFill>
-                  <a:schemeClr val="accent5"/>
-                </a:solidFill>
-              </a:rPr>
-              <a:t>Level with the sharpest bookmaker, but behind an exchange with no operator margin.</a:t>
-            </a:r>
-            <a:endParaRPr lang="en-US" sz="1350" dirty="0"/>
-          </a:p>
-        </p:txBody>
-      </p:sp>
-      <p:sp>
-        <p:nvSpPr>
-          <p:cNvPr id="9" name="cc-2"/>
-          <p:cNvSpPr/>
-          <p:nvPr/>
-        </p:nvSpPr>
-        <p:spPr>
-          <a:xfrm>
-            <a:off x="640080" y="3438144"/>
-            <a:ext cx="256032" cy="256032"/>
+            <a:off x="640080" y="1719072"/>
+            <a:ext cx="237744" cy="237744"/>
           </a:xfrm>
           <a:prstGeom prst="ellipse">
             <a:avLst/>
@@ -7258,14 +6777,198 @@
       </p:sp>
       <p:sp>
         <p:nvSpPr>
+          <p:cNvPr id="4" name="Text 2"/>
+          <p:cNvSpPr txBox="1"/>
+          <p:nvPr/>
+        </p:nvSpPr>
+        <p:spPr>
+          <a:xfrm>
+            <a:off x="1024128" y="1645920"/>
+            <a:ext cx="3017520" cy="548640"/>
+          </a:xfrm>
+          <a:prstGeom prst="rect">
+            <a:avLst/>
+          </a:prstGeom>
+          <a:noFill/>
+          <a:ln/>
+        </p:spPr>
+        <p:txBody>
+          <a:bodyPr wrap="square" lIns="0" tIns="0" rIns="0" bIns="0" rtlCol="0" anchor="t"/>
+          <a:lstStyle/>
+          <a:p>
+            <a:pPr indent="0" marL="0">
+              <a:buNone/>
+            </a:pPr>
+            <a:r>
+              <a:rPr lang="en-US" sz="1500" b="1" dirty="0">
+                <a:solidFill>
+                  <a:schemeClr val="tx2"/>
+                </a:solidFill>
+              </a:rPr>
+              <a:t>Fixed-Share</a:t>
+            </a:r>
+            <a:endParaRPr lang="en-US" sz="1500" dirty="0"/>
+          </a:p>
+        </p:txBody>
+      </p:sp>
+      <p:sp>
+        <p:nvSpPr>
+          <p:cNvPr id="5" name="Text 3"/>
+          <p:cNvSpPr txBox="1"/>
+          <p:nvPr/>
+        </p:nvSpPr>
+        <p:spPr>
+          <a:xfrm>
+            <a:off x="1024128" y="2212848"/>
+            <a:ext cx="3017520" cy="640080"/>
+          </a:xfrm>
+          <a:prstGeom prst="rect">
+            <a:avLst/>
+          </a:prstGeom>
+          <a:noFill/>
+          <a:ln/>
+        </p:spPr>
+        <p:txBody>
+          <a:bodyPr wrap="square" lIns="0" tIns="0" rIns="0" bIns="0" rtlCol="0" anchor="t"/>
+          <a:lstStyle/>
+          <a:p>
+            <a:pPr indent="0" marL="0">
+              <a:buNone/>
+            </a:pPr>
+            <a:r>
+              <a:rPr lang="en-US" sz="1250" dirty="0">
+                <a:solidFill>
+                  <a:schemeClr val="accent5"/>
+                </a:solidFill>
+              </a:rPr>
+              <a:t>every α &gt; 0 loses</a:t>
+            </a:r>
+            <a:endParaRPr lang="en-US" sz="1250" dirty="0"/>
+          </a:p>
+        </p:txBody>
+      </p:sp>
+      <p:sp>
+        <p:nvSpPr>
+          <p:cNvPr id="6" name="neg-1"/>
+          <p:cNvSpPr/>
+          <p:nvPr/>
+        </p:nvSpPr>
+        <p:spPr>
+          <a:xfrm>
+            <a:off x="4297680" y="1719072"/>
+            <a:ext cx="237744" cy="237744"/>
+          </a:xfrm>
+          <a:prstGeom prst="ellipse">
+            <a:avLst/>
+          </a:prstGeom>
+          <a:solidFill>
+            <a:schemeClr val="accent4"/>
+          </a:solidFill>
+          <a:ln/>
+        </p:spPr>
+      </p:sp>
+      <p:sp>
+        <p:nvSpPr>
+          <p:cNvPr id="7" name="Text 5"/>
+          <p:cNvSpPr txBox="1"/>
+          <p:nvPr/>
+        </p:nvSpPr>
+        <p:spPr>
+          <a:xfrm>
+            <a:off x="4681728" y="1645920"/>
+            <a:ext cx="3017520" cy="548640"/>
+          </a:xfrm>
+          <a:prstGeom prst="rect">
+            <a:avLst/>
+          </a:prstGeom>
+          <a:noFill/>
+          <a:ln/>
+        </p:spPr>
+        <p:txBody>
+          <a:bodyPr wrap="square" lIns="0" tIns="0" rIns="0" bIns="0" rtlCol="0" anchor="t"/>
+          <a:lstStyle/>
+          <a:p>
+            <a:pPr indent="0" marL="0">
+              <a:buNone/>
+            </a:pPr>
+            <a:r>
+              <a:rPr lang="en-US" sz="1500" b="1" dirty="0">
+                <a:solidFill>
+                  <a:schemeClr val="tx2"/>
+                </a:solidFill>
+              </a:rPr>
+              <a:t>Per-expert step clock</a:t>
+            </a:r>
+            <a:endParaRPr lang="en-US" sz="1500" dirty="0"/>
+          </a:p>
+        </p:txBody>
+      </p:sp>
+      <p:sp>
+        <p:nvSpPr>
+          <p:cNvPr id="8" name="Text 6"/>
+          <p:cNvSpPr txBox="1"/>
+          <p:nvPr/>
+        </p:nvSpPr>
+        <p:spPr>
+          <a:xfrm>
+            <a:off x="4681728" y="2212848"/>
+            <a:ext cx="3017520" cy="640080"/>
+          </a:xfrm>
+          <a:prstGeom prst="rect">
+            <a:avLst/>
+          </a:prstGeom>
+          <a:noFill/>
+          <a:ln/>
+        </p:spPr>
+        <p:txBody>
+          <a:bodyPr wrap="square" lIns="0" tIns="0" rIns="0" bIns="0" rtlCol="0" anchor="t"/>
+          <a:lstStyle/>
+          <a:p>
+            <a:pPr indent="0" marL="0">
+              <a:buNone/>
+            </a:pPr>
+            <a:r>
+              <a:rPr lang="en-US" sz="1250" dirty="0">
+                <a:solidFill>
+                  <a:schemeClr val="accent5"/>
+                </a:solidFill>
+              </a:rPr>
+              <a:t>−0.00073 on the tail: overfitting</a:t>
+            </a:r>
+            <a:endParaRPr lang="en-US" sz="1250" dirty="0"/>
+          </a:p>
+        </p:txBody>
+      </p:sp>
+      <p:sp>
+        <p:nvSpPr>
+          <p:cNvPr id="9" name="neg-2"/>
+          <p:cNvSpPr/>
+          <p:nvPr/>
+        </p:nvSpPr>
+        <p:spPr>
+          <a:xfrm>
+            <a:off x="7955280" y="1719072"/>
+            <a:ext cx="237744" cy="237744"/>
+          </a:xfrm>
+          <a:prstGeom prst="ellipse">
+            <a:avLst/>
+          </a:prstGeom>
+          <a:solidFill>
+            <a:schemeClr val="accent4"/>
+          </a:solidFill>
+          <a:ln/>
+        </p:spPr>
+      </p:sp>
+      <p:sp>
+        <p:nvSpPr>
           <p:cNvPr id="10" name="Text 8"/>
           <p:cNvSpPr txBox="1"/>
           <p:nvPr/>
         </p:nvSpPr>
         <p:spPr>
           <a:xfrm>
-            <a:off x="1078992" y="3346704"/>
-            <a:ext cx="3931920" cy="411480"/>
+            <a:off x="8339328" y="1645920"/>
+            <a:ext cx="3017520" cy="548640"/>
           </a:xfrm>
           <a:prstGeom prst="rect">
             <a:avLst/>
@@ -7281,14 +6984,14 @@
               <a:buNone/>
             </a:pPr>
             <a:r>
-              <a:rPr lang="en-US" sz="1600" b="1" dirty="0">
+              <a:rPr lang="en-US" sz="1500" b="1" dirty="0">
                 <a:solidFill>
                   <a:schemeClr val="tx2"/>
                 </a:solidFill>
               </a:rPr>
-              <a:t>Part of the gain is geometry</a:t>
-            </a:r>
-            <a:endParaRPr lang="en-US" sz="1600" dirty="0"/>
+              <a:t>Markov kernels on the weights</a:t>
+            </a:r>
+            <a:endParaRPr lang="en-US" sz="1500" dirty="0"/>
           </a:p>
         </p:txBody>
       </p:sp>
@@ -7300,8 +7003,8 @@
         </p:nvSpPr>
         <p:spPr>
           <a:xfrm>
-            <a:off x="5166360" y="3346704"/>
-            <a:ext cx="6355080" cy="777240"/>
+            <a:off x="8339328" y="2212848"/>
+            <a:ext cx="3017520" cy="640080"/>
           </a:xfrm>
           <a:prstGeom prst="rect">
             <a:avLst/>
@@ -7317,33 +7020,33 @@
               <a:buNone/>
             </a:pPr>
             <a:r>
-              <a:rPr lang="en-US" sz="1350" dirty="0">
+              <a:rPr lang="en-US" sz="1250" dirty="0">
                 <a:solidFill>
                   <a:schemeClr val="accent5"/>
                 </a:solidFill>
               </a:rPr>
-              <a:t>42% of the margin over uniform, isolated with a zero-step control.</a:t>
-            </a:r>
-            <a:endParaRPr lang="en-US" sz="1350" dirty="0"/>
-          </a:p>
-        </p:txBody>
-      </p:sp>
-      <p:sp>
-        <p:nvSpPr>
-          <p:cNvPr id="12" name="cc-3"/>
+              <a:t>every kernel selects α = 0</a:t>
+            </a:r>
+            <a:endParaRPr lang="en-US" sz="1250" dirty="0"/>
+          </a:p>
+        </p:txBody>
+      </p:sp>
+      <p:sp>
+        <p:nvSpPr>
+          <p:cNvPr id="12" name="neg-3"/>
           <p:cNvSpPr/>
           <p:nvPr/>
         </p:nvSpPr>
         <p:spPr>
           <a:xfrm>
-            <a:off x="640080" y="4379976"/>
-            <a:ext cx="256032" cy="256032"/>
+            <a:off x="640080" y="3090672"/>
+            <a:ext cx="237744" cy="237744"/>
           </a:xfrm>
           <a:prstGeom prst="ellipse">
             <a:avLst/>
           </a:prstGeom>
           <a:solidFill>
-            <a:schemeClr val="accent1"/>
+            <a:schemeClr val="accent4"/>
           </a:solidFill>
           <a:ln/>
         </p:spPr>
@@ -7356,8 +7059,8 @@
         </p:nvSpPr>
         <p:spPr>
           <a:xfrm>
-            <a:off x="1078992" y="4288536"/>
-            <a:ext cx="3931920" cy="411480"/>
+            <a:off x="1024128" y="3017520"/>
+            <a:ext cx="3017520" cy="548640"/>
           </a:xfrm>
           <a:prstGeom prst="rect">
             <a:avLst/>
@@ -7373,14 +7076,14 @@
               <a:buNone/>
             </a:pPr>
             <a:r>
-              <a:rPr lang="en-US" sz="1600" b="1" dirty="0">
+              <a:rPr lang="en-US" sz="1500" b="1" dirty="0">
                 <a:solidFill>
                   <a:schemeClr val="tx2"/>
                 </a:solidFill>
               </a:rPr>
-              <a:t>Heterogeneity is a precondition</a:t>
-            </a:r>
-            <a:endParaRPr lang="en-US" sz="1600" dirty="0"/>
+              <a:t>Latent market regimes</a:t>
+            </a:r>
+            <a:endParaRPr lang="en-US" sz="1500" dirty="0"/>
           </a:p>
         </p:txBody>
       </p:sp>
@@ -7392,8 +7095,8 @@
         </p:nvSpPr>
         <p:spPr>
           <a:xfrm>
-            <a:off x="5166360" y="4288536"/>
-            <a:ext cx="6355080" cy="777240"/>
+            <a:off x="1024128" y="3584448"/>
+            <a:ext cx="3017520" cy="640080"/>
           </a:xfrm>
           <a:prstGeom prst="rect">
             <a:avLst/>
@@ -7409,33 +7112,33 @@
               <a:buNone/>
             </a:pPr>
             <a:r>
-              <a:rPr lang="en-US" sz="1350" dirty="0">
+              <a:rPr lang="en-US" sz="1250" dirty="0">
                 <a:solidFill>
                   <a:schemeClr val="accent5"/>
                 </a:solidFill>
               </a:rPr>
-              <a:t>Learned weighting pays only when the experts come from different processes.</a:t>
-            </a:r>
-            <a:endParaRPr lang="en-US" sz="1350" dirty="0"/>
-          </a:p>
-        </p:txBody>
-      </p:sp>
-      <p:sp>
-        <p:nvSpPr>
-          <p:cNvPr id="15" name="cc-4"/>
+              <a:t>belief sd 0.0000: it does nothing</a:t>
+            </a:r>
+            <a:endParaRPr lang="en-US" sz="1250" dirty="0"/>
+          </a:p>
+        </p:txBody>
+      </p:sp>
+      <p:sp>
+        <p:nvSpPr>
+          <p:cNvPr id="15" name="neg-4"/>
           <p:cNvSpPr/>
           <p:nvPr/>
         </p:nvSpPr>
         <p:spPr>
           <a:xfrm>
-            <a:off x="640080" y="5321808"/>
-            <a:ext cx="256032" cy="256032"/>
+            <a:off x="4297680" y="3090672"/>
+            <a:ext cx="237744" cy="237744"/>
           </a:xfrm>
           <a:prstGeom prst="ellipse">
             <a:avLst/>
           </a:prstGeom>
           <a:solidFill>
-            <a:schemeClr val="accent2"/>
+            <a:schemeClr val="accent4"/>
           </a:solidFill>
           <a:ln/>
         </p:spPr>
@@ -7448,8 +7151,8 @@
         </p:nvSpPr>
         <p:spPr>
           <a:xfrm>
-            <a:off x="1078992" y="5230368"/>
-            <a:ext cx="3931920" cy="411480"/>
+            <a:off x="4681728" y="3017520"/>
+            <a:ext cx="3017520" cy="548640"/>
           </a:xfrm>
           <a:prstGeom prst="rect">
             <a:avLst/>
@@ -7465,14 +7168,14 @@
               <a:buNone/>
             </a:pPr>
             <a:r>
-              <a:rPr lang="en-US" sz="1600" b="1" dirty="0">
+              <a:rPr lang="en-US" sz="1500" b="1" dirty="0">
                 <a:solidFill>
                   <a:schemeClr val="tx2"/>
                 </a:solidFill>
               </a:rPr>
-              <a:t>Better prediction is not profit</a:t>
-            </a:r>
-            <a:endParaRPr lang="en-US" sz="1600" dirty="0"/>
+              <a:t>Bandit, one-point estimator</a:t>
+            </a:r>
+            <a:endParaRPr lang="en-US" sz="1500" dirty="0"/>
           </a:p>
         </p:txBody>
       </p:sp>
@@ -7484,8 +7187,8 @@
         </p:nvSpPr>
         <p:spPr>
           <a:xfrm>
-            <a:off x="5166360" y="5230368"/>
-            <a:ext cx="6355080" cy="777240"/>
+            <a:off x="4681728" y="3584448"/>
+            <a:ext cx="3017520" cy="640080"/>
           </a:xfrm>
           <a:prstGeom prst="rect">
             <a:avLst/>
@@ -7501,14 +7204,418 @@
               <a:buNone/>
             </a:pPr>
             <a:r>
-              <a:rPr lang="en-US" sz="1350" dirty="0">
+              <a:rPr lang="en-US" sz="1250" dirty="0">
                 <a:solidFill>
                   <a:schemeClr val="accent5"/>
                 </a:solidFill>
               </a:rPr>
-              <a:t>The quality gained falls short of the margin, and the edge sits where access is controlled.</a:t>
-            </a:r>
-            <a:endParaRPr lang="en-US" sz="1350" dirty="0"/>
+              <a:t>the horizon is too short</a:t>
+            </a:r>
+            <a:endParaRPr lang="en-US" sz="1250" dirty="0"/>
+          </a:p>
+        </p:txBody>
+      </p:sp>
+      <p:sp>
+        <p:nvSpPr>
+          <p:cNvPr id="18" name="neg-5"/>
+          <p:cNvSpPr/>
+          <p:nvPr/>
+        </p:nvSpPr>
+        <p:spPr>
+          <a:xfrm>
+            <a:off x="7955280" y="3090672"/>
+            <a:ext cx="237744" cy="237744"/>
+          </a:xfrm>
+          <a:prstGeom prst="ellipse">
+            <a:avLst/>
+          </a:prstGeom>
+          <a:solidFill>
+            <a:schemeClr val="accent4"/>
+          </a:solidFill>
+          <a:ln/>
+        </p:spPr>
+      </p:sp>
+      <p:sp>
+        <p:nvSpPr>
+          <p:cNvPr id="19" name="Text 17"/>
+          <p:cNvSpPr txBox="1"/>
+          <p:nvPr/>
+        </p:nvSpPr>
+        <p:spPr>
+          <a:xfrm>
+            <a:off x="8339328" y="3017520"/>
+            <a:ext cx="3017520" cy="548640"/>
+          </a:xfrm>
+          <a:prstGeom prst="rect">
+            <a:avLst/>
+          </a:prstGeom>
+          <a:noFill/>
+          <a:ln/>
+        </p:spPr>
+        <p:txBody>
+          <a:bodyPr wrap="square" lIns="0" tIns="0" rIns="0" bIns="0" rtlCol="0" anchor="t"/>
+          <a:lstStyle/>
+          <a:p>
+            <a:pPr indent="0" marL="0">
+              <a:buNone/>
+            </a:pPr>
+            <a:r>
+              <a:rPr lang="en-US" sz="1500" b="1" dirty="0">
+                <a:solidFill>
+                  <a:schemeClr val="tx2"/>
+                </a:solidFill>
+              </a:rPr>
+              <a:t>Bayesian / MCMC Kelly</a:t>
+            </a:r>
+            <a:endParaRPr lang="en-US" sz="1500" dirty="0"/>
+          </a:p>
+        </p:txBody>
+      </p:sp>
+      <p:sp>
+        <p:nvSpPr>
+          <p:cNvPr id="20" name="Text 18"/>
+          <p:cNvSpPr txBox="1"/>
+          <p:nvPr/>
+        </p:nvSpPr>
+        <p:spPr>
+          <a:xfrm>
+            <a:off x="8339328" y="3584448"/>
+            <a:ext cx="3017520" cy="640080"/>
+          </a:xfrm>
+          <a:prstGeom prst="rect">
+            <a:avLst/>
+          </a:prstGeom>
+          <a:noFill/>
+          <a:ln/>
+        </p:spPr>
+        <p:txBody>
+          <a:bodyPr wrap="square" lIns="0" tIns="0" rIns="0" bIns="0" rtlCol="0" anchor="t"/>
+          <a:lstStyle/>
+          <a:p>
+            <a:pPr indent="0" marL="0">
+              <a:buNone/>
+            </a:pPr>
+            <a:r>
+              <a:rPr lang="en-US" sz="1250" dirty="0">
+                <a:solidFill>
+                  <a:schemeClr val="accent5"/>
+                </a:solidFill>
+              </a:rPr>
+              <a:t>6 ties, 2 losses, zero wins</a:t>
+            </a:r>
+            <a:endParaRPr lang="en-US" sz="1250" dirty="0"/>
+          </a:p>
+        </p:txBody>
+      </p:sp>
+      <p:sp>
+        <p:nvSpPr>
+          <p:cNvPr id="21" name="neg-6"/>
+          <p:cNvSpPr/>
+          <p:nvPr/>
+        </p:nvSpPr>
+        <p:spPr>
+          <a:xfrm>
+            <a:off x="640080" y="4462272"/>
+            <a:ext cx="237744" cy="237744"/>
+          </a:xfrm>
+          <a:prstGeom prst="ellipse">
+            <a:avLst/>
+          </a:prstGeom>
+          <a:solidFill>
+            <a:schemeClr val="accent4"/>
+          </a:solidFill>
+          <a:ln/>
+        </p:spPr>
+      </p:sp>
+      <p:sp>
+        <p:nvSpPr>
+          <p:cNvPr id="22" name="Text 20"/>
+          <p:cNvSpPr txBox="1"/>
+          <p:nvPr/>
+        </p:nvSpPr>
+        <p:spPr>
+          <a:xfrm>
+            <a:off x="1024128" y="4389120"/>
+            <a:ext cx="3017520" cy="548640"/>
+          </a:xfrm>
+          <a:prstGeom prst="rect">
+            <a:avLst/>
+          </a:prstGeom>
+          <a:noFill/>
+          <a:ln/>
+        </p:spPr>
+        <p:txBody>
+          <a:bodyPr wrap="square" lIns="0" tIns="0" rIns="0" bIns="0" rtlCol="0" anchor="t"/>
+          <a:lstStyle/>
+          <a:p>
+            <a:pPr indent="0" marL="0">
+              <a:buNone/>
+            </a:pPr>
+            <a:r>
+              <a:rPr lang="en-US" sz="1500" b="1" dirty="0">
+                <a:solidFill>
+                  <a:schemeClr val="tx2"/>
+                </a:solidFill>
+              </a:rPr>
+              <a:t>Per-league specialisation</a:t>
+            </a:r>
+            <a:endParaRPr lang="en-US" sz="1500" dirty="0"/>
+          </a:p>
+        </p:txBody>
+      </p:sp>
+      <p:sp>
+        <p:nvSpPr>
+          <p:cNvPr id="23" name="Text 21"/>
+          <p:cNvSpPr txBox="1"/>
+          <p:nvPr/>
+        </p:nvSpPr>
+        <p:spPr>
+          <a:xfrm>
+            <a:off x="1024128" y="4956048"/>
+            <a:ext cx="3017520" cy="640080"/>
+          </a:xfrm>
+          <a:prstGeom prst="rect">
+            <a:avLst/>
+          </a:prstGeom>
+          <a:noFill/>
+          <a:ln/>
+        </p:spPr>
+        <p:txBody>
+          <a:bodyPr wrap="square" lIns="0" tIns="0" rIns="0" bIns="0" rtlCol="0" anchor="t"/>
+          <a:lstStyle/>
+          <a:p>
+            <a:pPr indent="0" marL="0">
+              <a:buNone/>
+            </a:pPr>
+            <a:r>
+              <a:rPr lang="en-US" sz="1250" dirty="0">
+                <a:solidFill>
+                  <a:schemeClr val="accent5"/>
+                </a:solidFill>
+              </a:rPr>
+              <a:t>loses in all six leagues</a:t>
+            </a:r>
+            <a:endParaRPr lang="en-US" sz="1250" dirty="0"/>
+          </a:p>
+        </p:txBody>
+      </p:sp>
+      <p:sp>
+        <p:nvSpPr>
+          <p:cNvPr id="24" name="neg-7"/>
+          <p:cNvSpPr/>
+          <p:nvPr/>
+        </p:nvSpPr>
+        <p:spPr>
+          <a:xfrm>
+            <a:off x="4297680" y="4462272"/>
+            <a:ext cx="237744" cy="237744"/>
+          </a:xfrm>
+          <a:prstGeom prst="ellipse">
+            <a:avLst/>
+          </a:prstGeom>
+          <a:solidFill>
+            <a:schemeClr val="accent4"/>
+          </a:solidFill>
+          <a:ln/>
+        </p:spPr>
+      </p:sp>
+      <p:sp>
+        <p:nvSpPr>
+          <p:cNvPr id="25" name="Text 23"/>
+          <p:cNvSpPr txBox="1"/>
+          <p:nvPr/>
+        </p:nvSpPr>
+        <p:spPr>
+          <a:xfrm>
+            <a:off x="4681728" y="4389120"/>
+            <a:ext cx="3017520" cy="548640"/>
+          </a:xfrm>
+          <a:prstGeom prst="rect">
+            <a:avLst/>
+          </a:prstGeom>
+          <a:noFill/>
+          <a:ln/>
+        </p:spPr>
+        <p:txBody>
+          <a:bodyPr wrap="square" lIns="0" tIns="0" rIns="0" bIns="0" rtlCol="0" anchor="t"/>
+          <a:lstStyle/>
+          <a:p>
+            <a:pPr indent="0" marL="0">
+              <a:buNone/>
+            </a:pPr>
+            <a:r>
+              <a:rPr lang="en-US" sz="1500" b="1" dirty="0">
+                <a:solidFill>
+                  <a:schemeClr val="tx2"/>
+                </a:solidFill>
+              </a:rPr>
+              <a:t>AdaGrad</a:t>
+            </a:r>
+            <a:endParaRPr lang="en-US" sz="1500" dirty="0"/>
+          </a:p>
+        </p:txBody>
+      </p:sp>
+      <p:sp>
+        <p:nvSpPr>
+          <p:cNvPr id="26" name="Text 24"/>
+          <p:cNvSpPr txBox="1"/>
+          <p:nvPr/>
+        </p:nvSpPr>
+        <p:spPr>
+          <a:xfrm>
+            <a:off x="4681728" y="4956048"/>
+            <a:ext cx="3017520" cy="640080"/>
+          </a:xfrm>
+          <a:prstGeom prst="rect">
+            <a:avLst/>
+          </a:prstGeom>
+          <a:noFill/>
+          <a:ln/>
+        </p:spPr>
+        <p:txBody>
+          <a:bodyPr wrap="square" lIns="0" tIns="0" rIns="0" bIns="0" rtlCol="0" anchor="t"/>
+          <a:lstStyle/>
+          <a:p>
+            <a:pPr indent="0" marL="0">
+              <a:buNone/>
+            </a:pPr>
+            <a:r>
+              <a:rPr lang="en-US" sz="1250" dirty="0">
+                <a:solidFill>
+                  <a:schemeClr val="accent5"/>
+                </a:solidFill>
+              </a:rPr>
+              <a:t>recovers 20% at best</a:t>
+            </a:r>
+            <a:endParaRPr lang="en-US" sz="1250" dirty="0"/>
+          </a:p>
+        </p:txBody>
+      </p:sp>
+      <p:sp>
+        <p:nvSpPr>
+          <p:cNvPr id="27" name="neg-8"/>
+          <p:cNvSpPr/>
+          <p:nvPr/>
+        </p:nvSpPr>
+        <p:spPr>
+          <a:xfrm>
+            <a:off x="7955280" y="4462272"/>
+            <a:ext cx="237744" cy="237744"/>
+          </a:xfrm>
+          <a:prstGeom prst="ellipse">
+            <a:avLst/>
+          </a:prstGeom>
+          <a:solidFill>
+            <a:schemeClr val="accent4"/>
+          </a:solidFill>
+          <a:ln/>
+        </p:spPr>
+      </p:sp>
+      <p:sp>
+        <p:nvSpPr>
+          <p:cNvPr id="28" name="Text 26"/>
+          <p:cNvSpPr txBox="1"/>
+          <p:nvPr/>
+        </p:nvSpPr>
+        <p:spPr>
+          <a:xfrm>
+            <a:off x="8339328" y="4389120"/>
+            <a:ext cx="3017520" cy="548640"/>
+          </a:xfrm>
+          <a:prstGeom prst="rect">
+            <a:avLst/>
+          </a:prstGeom>
+          <a:noFill/>
+          <a:ln/>
+        </p:spPr>
+        <p:txBody>
+          <a:bodyPr wrap="square" lIns="0" tIns="0" rIns="0" bIns="0" rtlCol="0" anchor="t"/>
+          <a:lstStyle/>
+          <a:p>
+            <a:pPr indent="0" marL="0">
+              <a:buNone/>
+            </a:pPr>
+            <a:r>
+              <a:rPr lang="en-US" sz="1500" b="1" dirty="0">
+                <a:solidFill>
+                  <a:schemeClr val="tx2"/>
+                </a:solidFill>
+              </a:rPr>
+              <a:t>Joint step + calibration sweep</a:t>
+            </a:r>
+            <a:endParaRPr lang="en-US" sz="1500" dirty="0"/>
+          </a:p>
+        </p:txBody>
+      </p:sp>
+      <p:sp>
+        <p:nvSpPr>
+          <p:cNvPr id="29" name="Text 27"/>
+          <p:cNvSpPr txBox="1"/>
+          <p:nvPr/>
+        </p:nvSpPr>
+        <p:spPr>
+          <a:xfrm>
+            <a:off x="8339328" y="4956048"/>
+            <a:ext cx="3017520" cy="640080"/>
+          </a:xfrm>
+          <a:prstGeom prst="rect">
+            <a:avLst/>
+          </a:prstGeom>
+          <a:noFill/>
+          <a:ln/>
+        </p:spPr>
+        <p:txBody>
+          <a:bodyPr wrap="square" lIns="0" tIns="0" rIns="0" bIns="0" rtlCol="0" anchor="t"/>
+          <a:lstStyle/>
+          <a:p>
+            <a:pPr indent="0" marL="0">
+              <a:buNone/>
+            </a:pPr>
+            <a:r>
+              <a:rPr lang="en-US" sz="1250" dirty="0">
+                <a:solidFill>
+                  <a:schemeClr val="accent5"/>
+                </a:solidFill>
+              </a:rPr>
+              <a:t>no interaction at all</a:t>
+            </a:r>
+            <a:endParaRPr lang="en-US" sz="1250" dirty="0"/>
+          </a:p>
+        </p:txBody>
+      </p:sp>
+      <p:sp>
+        <p:nvSpPr>
+          <p:cNvPr id="30" name="Text 28"/>
+          <p:cNvSpPr txBox="1"/>
+          <p:nvPr/>
+        </p:nvSpPr>
+        <p:spPr>
+          <a:xfrm>
+            <a:off x="640080" y="5852160"/>
+            <a:ext cx="10881360" cy="640080"/>
+          </a:xfrm>
+          <a:prstGeom prst="rect">
+            <a:avLst/>
+          </a:prstGeom>
+          <a:noFill/>
+          <a:ln/>
+        </p:spPr>
+        <p:txBody>
+          <a:bodyPr wrap="square" rtlCol="0" anchor="ctr"/>
+          <a:lstStyle/>
+          <a:p>
+            <a:pPr indent="0" marL="0">
+              <a:buNone/>
+            </a:pPr>
+            <a:r>
+              <a:rPr lang="en-US" sz="1500" dirty="0">
+                <a:solidFill>
+                  <a:schemeClr val="tx1"/>
+                </a:solidFill>
+              </a:rPr>
+              <a:t>One pattern unites them: once the step size is tuned, no further movement of mass over the experts buys anything. The step and the leak control the same quantity.</a:t>
+            </a:r>
+            <a:endParaRPr lang="en-US" sz="1500" dirty="0"/>
           </a:p>
         </p:txBody>
       </p:sp>
@@ -7614,7 +7721,7 @@
                   <a:schemeClr val="tx2"/>
                 </a:solidFill>
               </a:rPr>
-              <a:t>Future work</a:t>
+              <a:t>Conclusions</a:t>
             </a:r>
             <a:endParaRPr lang="en-US" sz="3000" dirty="0"/>
           </a:p>
@@ -7622,14 +7729,106 @@
       </p:sp>
       <p:sp>
         <p:nvSpPr>
-          <p:cNvPr id="3" name="circle-1"/>
+          <p:cNvPr id="3" name="cc-0"/>
           <p:cNvSpPr/>
           <p:nvPr/>
         </p:nvSpPr>
         <p:spPr>
           <a:xfrm>
-            <a:off x="640080" y="1691640"/>
-            <a:ext cx="566928" cy="566928"/>
+            <a:off x="640080" y="1554480"/>
+            <a:ext cx="256032" cy="256032"/>
+          </a:xfrm>
+          <a:prstGeom prst="ellipse">
+            <a:avLst/>
+          </a:prstGeom>
+          <a:solidFill>
+            <a:schemeClr val="accent3"/>
+          </a:solidFill>
+          <a:ln/>
+        </p:spPr>
+      </p:sp>
+      <p:sp>
+        <p:nvSpPr>
+          <p:cNvPr id="4" name="Text 2"/>
+          <p:cNvSpPr txBox="1"/>
+          <p:nvPr/>
+        </p:nvSpPr>
+        <p:spPr>
+          <a:xfrm>
+            <a:off x="1078992" y="1463040"/>
+            <a:ext cx="3931920" cy="411480"/>
+          </a:xfrm>
+          <a:prstGeom prst="rect">
+            <a:avLst/>
+          </a:prstGeom>
+          <a:noFill/>
+          <a:ln/>
+        </p:spPr>
+        <p:txBody>
+          <a:bodyPr wrap="square" lIns="0" tIns="0" rIns="0" bIns="0" rtlCol="0" anchor="t"/>
+          <a:lstStyle/>
+          <a:p>
+            <a:pPr indent="0" marL="0">
+              <a:buNone/>
+            </a:pPr>
+            <a:r>
+              <a:rPr lang="en-US" sz="1600" b="1" dirty="0">
+                <a:solidFill>
+                  <a:schemeClr val="tx2"/>
+                </a:solidFill>
+              </a:rPr>
+              <a:t>The framework applies</a:t>
+            </a:r>
+            <a:endParaRPr lang="en-US" sz="1600" dirty="0"/>
+          </a:p>
+        </p:txBody>
+      </p:sp>
+      <p:sp>
+        <p:nvSpPr>
+          <p:cNvPr id="5" name="Text 3"/>
+          <p:cNvSpPr txBox="1"/>
+          <p:nvPr/>
+        </p:nvSpPr>
+        <p:spPr>
+          <a:xfrm>
+            <a:off x="5166360" y="1463040"/>
+            <a:ext cx="6355080" cy="777240"/>
+          </a:xfrm>
+          <a:prstGeom prst="rect">
+            <a:avLst/>
+          </a:prstGeom>
+          <a:noFill/>
+          <a:ln/>
+        </p:spPr>
+        <p:txBody>
+          <a:bodyPr wrap="square" lIns="0" tIns="0" rIns="0" bIns="0" rtlCol="0" anchor="t"/>
+          <a:lstStyle/>
+          <a:p>
+            <a:pPr indent="0" marL="0">
+              <a:buNone/>
+            </a:pPr>
+            <a:r>
+              <a:rPr lang="en-US" sz="1350" dirty="0">
+                <a:solidFill>
+                  <a:schemeClr val="accent5"/>
+                </a:solidFill>
+              </a:rPr>
+              <a:t>An online mixture of published odds beats the uniform average and almost every individual bookmaker, with no distributional assumption.</a:t>
+            </a:r>
+            <a:endParaRPr lang="en-US" sz="1350" dirty="0"/>
+          </a:p>
+        </p:txBody>
+      </p:sp>
+      <p:sp>
+        <p:nvSpPr>
+          <p:cNvPr id="6" name="cc-1"/>
+          <p:cNvSpPr/>
+          <p:nvPr/>
+        </p:nvSpPr>
+        <p:spPr>
+          <a:xfrm>
+            <a:off x="640080" y="2496312"/>
+            <a:ext cx="256032" cy="256032"/>
           </a:xfrm>
           <a:prstGeom prst="ellipse">
             <a:avLst/>
@@ -7642,50 +7841,50 @@
       </p:sp>
       <p:sp>
         <p:nvSpPr>
-          <p:cNvPr id="4" name="Text 2"/>
+          <p:cNvPr id="7" name="Text 5"/>
           <p:cNvSpPr txBox="1"/>
           <p:nvPr/>
         </p:nvSpPr>
         <p:spPr>
           <a:xfrm>
-            <a:off x="640080" y="1691640"/>
-            <a:ext cx="566928" cy="566928"/>
-          </a:xfrm>
-          <a:prstGeom prst="rect">
-            <a:avLst/>
-          </a:prstGeom>
-          <a:noFill/>
-          <a:ln/>
-        </p:spPr>
-        <p:txBody>
-          <a:bodyPr wrap="square" lIns="0" tIns="0" rIns="0" bIns="0" rtlCol="0" anchor="ctr"/>
-          <a:lstStyle/>
-          <a:p>
-            <a:pPr algn="ctr" indent="0" marL="0">
-              <a:buNone/>
-            </a:pPr>
-            <a:r>
-              <a:rPr lang="en-US" sz="2000" b="1" dirty="0">
-                <a:solidFill>
-                  <a:srgbClr val="FFFFFF"/>
-                </a:solidFill>
-              </a:rPr>
-              <a:t>1</a:t>
-            </a:r>
-            <a:endParaRPr lang="en-US" sz="2000" dirty="0"/>
-          </a:p>
-        </p:txBody>
-      </p:sp>
-      <p:sp>
-        <p:nvSpPr>
-          <p:cNvPr id="5" name="Text 3"/>
+            <a:off x="1078992" y="2404872"/>
+            <a:ext cx="3931920" cy="411480"/>
+          </a:xfrm>
+          <a:prstGeom prst="rect">
+            <a:avLst/>
+          </a:prstGeom>
+          <a:noFill/>
+          <a:ln/>
+        </p:spPr>
+        <p:txBody>
+          <a:bodyPr wrap="square" lIns="0" tIns="0" rIns="0" bIns="0" rtlCol="0" anchor="t"/>
+          <a:lstStyle/>
+          <a:p>
+            <a:pPr indent="0" marL="0">
+              <a:buNone/>
+            </a:pPr>
+            <a:r>
+              <a:rPr lang="en-US" sz="1600" b="1" dirty="0">
+                <a:solidFill>
+                  <a:schemeClr val="tx2"/>
+                </a:solidFill>
+              </a:rPr>
+              <a:t>It reaches the market's edge</a:t>
+            </a:r>
+            <a:endParaRPr lang="en-US" sz="1600" dirty="0"/>
+          </a:p>
+        </p:txBody>
+      </p:sp>
+      <p:sp>
+        <p:nvSpPr>
+          <p:cNvPr id="8" name="Text 6"/>
           <p:cNvSpPr txBox="1"/>
           <p:nvPr/>
         </p:nvSpPr>
         <p:spPr>
           <a:xfrm>
-            <a:off x="1508760" y="1645920"/>
-            <a:ext cx="10058400" cy="411480"/>
+            <a:off x="5166360" y="2404872"/>
+            <a:ext cx="6355080" cy="777240"/>
           </a:xfrm>
           <a:prstGeom prst="rect">
             <a:avLst/>
@@ -7701,27 +7900,83 @@
               <a:buNone/>
             </a:pPr>
             <a:r>
-              <a:rPr lang="en-US" sz="1800" b="1" dirty="0">
+              <a:rPr lang="en-US" sz="1350" dirty="0">
+                <a:solidFill>
+                  <a:schemeClr val="accent5"/>
+                </a:solidFill>
+              </a:rPr>
+              <a:t>Level with the sharpest bookmaker, but behind an exchange with no operator margin.</a:t>
+            </a:r>
+            <a:endParaRPr lang="en-US" sz="1350" dirty="0"/>
+          </a:p>
+        </p:txBody>
+      </p:sp>
+      <p:sp>
+        <p:nvSpPr>
+          <p:cNvPr id="9" name="cc-2"/>
+          <p:cNvSpPr/>
+          <p:nvPr/>
+        </p:nvSpPr>
+        <p:spPr>
+          <a:xfrm>
+            <a:off x="640080" y="3438144"/>
+            <a:ext cx="256032" cy="256032"/>
+          </a:xfrm>
+          <a:prstGeom prst="ellipse">
+            <a:avLst/>
+          </a:prstGeom>
+          <a:solidFill>
+            <a:schemeClr val="accent4"/>
+          </a:solidFill>
+          <a:ln/>
+        </p:spPr>
+      </p:sp>
+      <p:sp>
+        <p:nvSpPr>
+          <p:cNvPr id="10" name="Text 8"/>
+          <p:cNvSpPr txBox="1"/>
+          <p:nvPr/>
+        </p:nvSpPr>
+        <p:spPr>
+          <a:xfrm>
+            <a:off x="1078992" y="3346704"/>
+            <a:ext cx="3931920" cy="411480"/>
+          </a:xfrm>
+          <a:prstGeom prst="rect">
+            <a:avLst/>
+          </a:prstGeom>
+          <a:noFill/>
+          <a:ln/>
+        </p:spPr>
+        <p:txBody>
+          <a:bodyPr wrap="square" lIns="0" tIns="0" rIns="0" bIns="0" rtlCol="0" anchor="t"/>
+          <a:lstStyle/>
+          <a:p>
+            <a:pPr indent="0" marL="0">
+              <a:buNone/>
+            </a:pPr>
+            <a:r>
+              <a:rPr lang="en-US" sz="1600" b="1" dirty="0">
                 <a:solidFill>
                   <a:schemeClr val="tx2"/>
                 </a:solidFill>
               </a:rPr>
-              <a:t>A live odds feed</a:t>
-            </a:r>
-            <a:endParaRPr lang="en-US" sz="1800" dirty="0"/>
-          </a:p>
-        </p:txBody>
-      </p:sp>
-      <p:sp>
-        <p:nvSpPr>
-          <p:cNvPr id="6" name="Text 4"/>
+              <a:t>Part of the gain is geometry</a:t>
+            </a:r>
+            <a:endParaRPr lang="en-US" sz="1600" dirty="0"/>
+          </a:p>
+        </p:txBody>
+      </p:sp>
+      <p:sp>
+        <p:nvSpPr>
+          <p:cNvPr id="11" name="Text 9"/>
           <p:cNvSpPr txBox="1"/>
           <p:nvPr/>
         </p:nvSpPr>
         <p:spPr>
           <a:xfrm>
-            <a:off x="1508760" y="2066544"/>
-            <a:ext cx="10058400" cy="960120"/>
+            <a:off x="5166360" y="3346704"/>
+            <a:ext cx="6355080" cy="777240"/>
           </a:xfrm>
           <a:prstGeom prst="rect">
             <a:avLst/>
@@ -7742,7 +7997,7 @@
                   <a:schemeClr val="accent5"/>
                 </a:solidFill>
               </a:rPr>
-              <a:t>Every result here says what the method WOULD have done. The three stages are online and causal and the state is one weight vector plus two scalars, so it runs in real time against a streaming API. That turns a statistical edge into an exploitable one.</a:t>
+              <a:t>42% of the margin over uniform, isolated with a zero-step control.</a:t>
             </a:r>
             <a:endParaRPr lang="en-US" sz="1350" dirty="0"/>
           </a:p>
@@ -7750,14 +8005,14 @@
       </p:sp>
       <p:sp>
         <p:nvSpPr>
-          <p:cNvPr id="7" name="circle-2"/>
+          <p:cNvPr id="12" name="cc-3"/>
           <p:cNvSpPr/>
           <p:nvPr/>
         </p:nvSpPr>
         <p:spPr>
           <a:xfrm>
-            <a:off x="640080" y="3200400"/>
-            <a:ext cx="566928" cy="566928"/>
+            <a:off x="640080" y="4379976"/>
+            <a:ext cx="256032" cy="256032"/>
           </a:xfrm>
           <a:prstGeom prst="ellipse">
             <a:avLst/>
@@ -7770,178 +8025,14 @@
       </p:sp>
       <p:sp>
         <p:nvSpPr>
-          <p:cNvPr id="8" name="Text 6"/>
-          <p:cNvSpPr txBox="1"/>
-          <p:nvPr/>
-        </p:nvSpPr>
-        <p:spPr>
-          <a:xfrm>
-            <a:off x="640080" y="3200400"/>
-            <a:ext cx="566928" cy="566928"/>
-          </a:xfrm>
-          <a:prstGeom prst="rect">
-            <a:avLst/>
-          </a:prstGeom>
-          <a:noFill/>
-          <a:ln/>
-        </p:spPr>
-        <p:txBody>
-          <a:bodyPr wrap="square" lIns="0" tIns="0" rIns="0" bIns="0" rtlCol="0" anchor="ctr"/>
-          <a:lstStyle/>
-          <a:p>
-            <a:pPr algn="ctr" indent="0" marL="0">
-              <a:buNone/>
-            </a:pPr>
-            <a:r>
-              <a:rPr lang="en-US" sz="2000" b="1" dirty="0">
-                <a:solidFill>
-                  <a:srgbClr val="FFFFFF"/>
-                </a:solidFill>
-              </a:rPr>
-              <a:t>2</a:t>
-            </a:r>
-            <a:endParaRPr lang="en-US" sz="2000" dirty="0"/>
-          </a:p>
-        </p:txBody>
-      </p:sp>
-      <p:sp>
-        <p:nvSpPr>
-          <p:cNvPr id="9" name="Text 7"/>
-          <p:cNvSpPr txBox="1"/>
-          <p:nvPr/>
-        </p:nvSpPr>
-        <p:spPr>
-          <a:xfrm>
-            <a:off x="1508760" y="3154680"/>
-            <a:ext cx="10058400" cy="411480"/>
-          </a:xfrm>
-          <a:prstGeom prst="rect">
-            <a:avLst/>
-          </a:prstGeom>
-          <a:noFill/>
-          <a:ln/>
-        </p:spPr>
-        <p:txBody>
-          <a:bodyPr wrap="square" lIns="0" tIns="0" rIns="0" bIns="0" rtlCol="0" anchor="t"/>
-          <a:lstStyle/>
-          <a:p>
-            <a:pPr indent="0" marL="0">
-              <a:buNone/>
-            </a:pPr>
-            <a:r>
-              <a:rPr lang="en-US" sz="1800" b="1" dirty="0">
-                <a:solidFill>
-                  <a:schemeClr val="tx2"/>
-                </a:solidFill>
-              </a:rPr>
-              <a:t>A second sport</a:t>
-            </a:r>
-            <a:endParaRPr lang="en-US" sz="1800" dirty="0"/>
-          </a:p>
-        </p:txBody>
-      </p:sp>
-      <p:sp>
-        <p:nvSpPr>
-          <p:cNvPr id="10" name="Text 8"/>
-          <p:cNvSpPr txBox="1"/>
-          <p:nvPr/>
-        </p:nvSpPr>
-        <p:spPr>
-          <a:xfrm>
-            <a:off x="1508760" y="3575304"/>
-            <a:ext cx="10058400" cy="960120"/>
-          </a:xfrm>
-          <a:prstGeom prst="rect">
-            <a:avLst/>
-          </a:prstGeom>
-          <a:noFill/>
-          <a:ln/>
-        </p:spPr>
-        <p:txBody>
-          <a:bodyPr wrap="square" lIns="0" tIns="0" rIns="0" bIns="0" rtlCol="0" anchor="t"/>
-          <a:lstStyle/>
-          <a:p>
-            <a:pPr indent="0" marL="0">
-              <a:buNone/>
-            </a:pPr>
-            <a:r>
-              <a:rPr lang="en-US" sz="1350" dirty="0">
-                <a:solidFill>
-                  <a:schemeClr val="accent5"/>
-                </a:solidFill>
-              </a:rPr>
-              <a:t>Basketball or tennis would show whether the framework generalises. The cost is a data pipeline; the algorithms do not change.</a:t>
-            </a:r>
-            <a:endParaRPr lang="en-US" sz="1350" dirty="0"/>
-          </a:p>
-        </p:txBody>
-      </p:sp>
-      <p:sp>
-        <p:nvSpPr>
-          <p:cNvPr id="11" name="circle-3"/>
-          <p:cNvSpPr/>
-          <p:nvPr/>
-        </p:nvSpPr>
-        <p:spPr>
-          <a:xfrm>
-            <a:off x="640080" y="4709160"/>
-            <a:ext cx="566928" cy="566928"/>
-          </a:xfrm>
-          <a:prstGeom prst="ellipse">
-            <a:avLst/>
-          </a:prstGeom>
-          <a:solidFill>
-            <a:schemeClr val="accent1"/>
-          </a:solidFill>
-          <a:ln/>
-        </p:spPr>
-      </p:sp>
-      <p:sp>
-        <p:nvSpPr>
-          <p:cNvPr id="12" name="Text 10"/>
-          <p:cNvSpPr txBox="1"/>
-          <p:nvPr/>
-        </p:nvSpPr>
-        <p:spPr>
-          <a:xfrm>
-            <a:off x="640080" y="4709160"/>
-            <a:ext cx="566928" cy="566928"/>
-          </a:xfrm>
-          <a:prstGeom prst="rect">
-            <a:avLst/>
-          </a:prstGeom>
-          <a:noFill/>
-          <a:ln/>
-        </p:spPr>
-        <p:txBody>
-          <a:bodyPr wrap="square" lIns="0" tIns="0" rIns="0" bIns="0" rtlCol="0" anchor="ctr"/>
-          <a:lstStyle/>
-          <a:p>
-            <a:pPr algn="ctr" indent="0" marL="0">
-              <a:buNone/>
-            </a:pPr>
-            <a:r>
-              <a:rPr lang="en-US" sz="2000" b="1" dirty="0">
-                <a:solidFill>
-                  <a:srgbClr val="FFFFFF"/>
-                </a:solidFill>
-              </a:rPr>
-              <a:t>3</a:t>
-            </a:r>
-            <a:endParaRPr lang="en-US" sz="2000" dirty="0"/>
-          </a:p>
-        </p:txBody>
-      </p:sp>
-      <p:sp>
-        <p:nvSpPr>
           <p:cNvPr id="13" name="Text 11"/>
           <p:cNvSpPr txBox="1"/>
           <p:nvPr/>
         </p:nvSpPr>
         <p:spPr>
           <a:xfrm>
-            <a:off x="1508760" y="4663440"/>
-            <a:ext cx="10058400" cy="411480"/>
+            <a:off x="1078992" y="4288536"/>
+            <a:ext cx="3931920" cy="411480"/>
           </a:xfrm>
           <a:prstGeom prst="rect">
             <a:avLst/>
@@ -7957,14 +8048,14 @@
               <a:buNone/>
             </a:pPr>
             <a:r>
-              <a:rPr lang="en-US" sz="1800" b="1" dirty="0">
+              <a:rPr lang="en-US" sz="1600" b="1" dirty="0">
                 <a:solidFill>
                   <a:schemeClr val="tx2"/>
                 </a:solidFill>
               </a:rPr>
-              <a:t>Bayesian Model Averaging as a baseline</a:t>
-            </a:r>
-            <a:endParaRPr lang="en-US" sz="1800" dirty="0"/>
+              <a:t>Heterogeneity is a precondition</a:t>
+            </a:r>
+            <a:endParaRPr lang="en-US" sz="1600" dirty="0"/>
           </a:p>
         </p:txBody>
       </p:sp>
@@ -7976,8 +8067,8 @@
         </p:nvSpPr>
         <p:spPr>
           <a:xfrm>
-            <a:off x="1508760" y="5084064"/>
-            <a:ext cx="10058400" cy="960120"/>
+            <a:off x="5166360" y="4288536"/>
+            <a:ext cx="6355080" cy="777240"/>
           </a:xfrm>
           <a:prstGeom prst="rect">
             <a:avLst/>
@@ -7998,7 +8089,99 @@
                   <a:schemeClr val="accent5"/>
                 </a:solidFill>
               </a:rPr>
-              <a:t>An empirical comparison against the online algorithms, and more light on why the Aggregating Algorithm underperforms here.</a:t>
+              <a:t>Learned weighting pays only when the experts come from different processes.</a:t>
+            </a:r>
+            <a:endParaRPr lang="en-US" sz="1350" dirty="0"/>
+          </a:p>
+        </p:txBody>
+      </p:sp>
+      <p:sp>
+        <p:nvSpPr>
+          <p:cNvPr id="15" name="cc-4"/>
+          <p:cNvSpPr/>
+          <p:nvPr/>
+        </p:nvSpPr>
+        <p:spPr>
+          <a:xfrm>
+            <a:off x="640080" y="5321808"/>
+            <a:ext cx="256032" cy="256032"/>
+          </a:xfrm>
+          <a:prstGeom prst="ellipse">
+            <a:avLst/>
+          </a:prstGeom>
+          <a:solidFill>
+            <a:schemeClr val="accent2"/>
+          </a:solidFill>
+          <a:ln/>
+        </p:spPr>
+      </p:sp>
+      <p:sp>
+        <p:nvSpPr>
+          <p:cNvPr id="16" name="Text 14"/>
+          <p:cNvSpPr txBox="1"/>
+          <p:nvPr/>
+        </p:nvSpPr>
+        <p:spPr>
+          <a:xfrm>
+            <a:off x="1078992" y="5230368"/>
+            <a:ext cx="3931920" cy="411480"/>
+          </a:xfrm>
+          <a:prstGeom prst="rect">
+            <a:avLst/>
+          </a:prstGeom>
+          <a:noFill/>
+          <a:ln/>
+        </p:spPr>
+        <p:txBody>
+          <a:bodyPr wrap="square" lIns="0" tIns="0" rIns="0" bIns="0" rtlCol="0" anchor="t"/>
+          <a:lstStyle/>
+          <a:p>
+            <a:pPr indent="0" marL="0">
+              <a:buNone/>
+            </a:pPr>
+            <a:r>
+              <a:rPr lang="en-US" sz="1600" b="1" dirty="0">
+                <a:solidFill>
+                  <a:schemeClr val="tx2"/>
+                </a:solidFill>
+              </a:rPr>
+              <a:t>Better prediction is not profit</a:t>
+            </a:r>
+            <a:endParaRPr lang="en-US" sz="1600" dirty="0"/>
+          </a:p>
+        </p:txBody>
+      </p:sp>
+      <p:sp>
+        <p:nvSpPr>
+          <p:cNvPr id="17" name="Text 15"/>
+          <p:cNvSpPr txBox="1"/>
+          <p:nvPr/>
+        </p:nvSpPr>
+        <p:spPr>
+          <a:xfrm>
+            <a:off x="5166360" y="5230368"/>
+            <a:ext cx="6355080" cy="777240"/>
+          </a:xfrm>
+          <a:prstGeom prst="rect">
+            <a:avLst/>
+          </a:prstGeom>
+          <a:noFill/>
+          <a:ln/>
+        </p:spPr>
+        <p:txBody>
+          <a:bodyPr wrap="square" lIns="0" tIns="0" rIns="0" bIns="0" rtlCol="0" anchor="t"/>
+          <a:lstStyle/>
+          <a:p>
+            <a:pPr indent="0" marL="0">
+              <a:buNone/>
+            </a:pPr>
+            <a:r>
+              <a:rPr lang="en-US" sz="1350" dirty="0">
+                <a:solidFill>
+                  <a:schemeClr val="accent5"/>
+                </a:solidFill>
+              </a:rPr>
+              <a:t>The quality gained falls short of the margin, and the edge sits where access is controlled.</a:t>
             </a:r>
             <a:endParaRPr lang="en-US" sz="1350" dirty="0"/>
           </a:p>
@@ -8060,6 +8243,498 @@
 <file path=ppt/slides/slide17.xml><?xml version="1.0" encoding="utf-8"?>
 <p:sld xmlns:a="http://schemas.openxmlformats.org/drawingml/2006/main" xmlns:r="http://schemas.openxmlformats.org/officeDocument/2006/relationships" xmlns:p="http://schemas.openxmlformats.org/presentationml/2006/main">
   <p:cSld name="Slide 17">
+    <p:spTree>
+      <p:nvGrpSpPr>
+        <p:cNvPr id="1" name=""/>
+        <p:cNvGrpSpPr/>
+        <p:nvPr/>
+      </p:nvGrpSpPr>
+      <p:grpSpPr>
+        <a:xfrm>
+          <a:off x="0" y="0"/>
+          <a:ext cx="0" cy="0"/>
+          <a:chOff x="0" y="0"/>
+          <a:chExt cx="0" cy="0"/>
+        </a:xfrm>
+      </p:grpSpPr>
+      <p:sp>
+        <p:nvSpPr>
+          <p:cNvPr id="2" name="Text 0"/>
+          <p:cNvSpPr/>
+          <p:nvPr>
+            <p:ph idx="100" type="title" hasCustomPrompt="1"/>
+          </p:nvPr>
+        </p:nvSpPr>
+        <p:spPr>
+          <a:xfrm>
+            <a:off x="640080" y="411480"/>
+            <a:ext cx="10881360" cy="777240"/>
+          </a:xfrm>
+          <a:prstGeom prst="rect">
+            <a:avLst/>
+          </a:prstGeom>
+          <a:noFill/>
+          <a:ln/>
+        </p:spPr>
+        <p:txBody>
+          <a:bodyPr wrap="square" rtlCol="0" anchor="ctr"/>
+          <a:lstStyle/>
+          <a:p>
+            <a:pPr algn="l" indent="0" marL="0">
+              <a:buNone/>
+            </a:pPr>
+            <a:r>
+              <a:rPr lang="en-US" sz="3000" b="1" dirty="0">
+                <a:solidFill>
+                  <a:schemeClr val="tx2"/>
+                </a:solidFill>
+              </a:rPr>
+              <a:t>Future work</a:t>
+            </a:r>
+            <a:endParaRPr lang="en-US" sz="3000" dirty="0"/>
+          </a:p>
+        </p:txBody>
+      </p:sp>
+      <p:sp>
+        <p:nvSpPr>
+          <p:cNvPr id="3" name="circle-1"/>
+          <p:cNvSpPr/>
+          <p:nvPr/>
+        </p:nvSpPr>
+        <p:spPr>
+          <a:xfrm>
+            <a:off x="640080" y="1691640"/>
+            <a:ext cx="566928" cy="566928"/>
+          </a:xfrm>
+          <a:prstGeom prst="ellipse">
+            <a:avLst/>
+          </a:prstGeom>
+          <a:solidFill>
+            <a:schemeClr val="accent1"/>
+          </a:solidFill>
+          <a:ln/>
+        </p:spPr>
+      </p:sp>
+      <p:sp>
+        <p:nvSpPr>
+          <p:cNvPr id="4" name="Text 2"/>
+          <p:cNvSpPr txBox="1"/>
+          <p:nvPr/>
+        </p:nvSpPr>
+        <p:spPr>
+          <a:xfrm>
+            <a:off x="640080" y="1691640"/>
+            <a:ext cx="566928" cy="566928"/>
+          </a:xfrm>
+          <a:prstGeom prst="rect">
+            <a:avLst/>
+          </a:prstGeom>
+          <a:noFill/>
+          <a:ln/>
+        </p:spPr>
+        <p:txBody>
+          <a:bodyPr wrap="square" lIns="0" tIns="0" rIns="0" bIns="0" rtlCol="0" anchor="ctr"/>
+          <a:lstStyle/>
+          <a:p>
+            <a:pPr algn="ctr" indent="0" marL="0">
+              <a:buNone/>
+            </a:pPr>
+            <a:r>
+              <a:rPr lang="en-US" sz="2000" b="1" dirty="0">
+                <a:solidFill>
+                  <a:srgbClr val="FFFFFF"/>
+                </a:solidFill>
+              </a:rPr>
+              <a:t>1</a:t>
+            </a:r>
+            <a:endParaRPr lang="en-US" sz="2000" dirty="0"/>
+          </a:p>
+        </p:txBody>
+      </p:sp>
+      <p:sp>
+        <p:nvSpPr>
+          <p:cNvPr id="5" name="Text 3"/>
+          <p:cNvSpPr txBox="1"/>
+          <p:nvPr/>
+        </p:nvSpPr>
+        <p:spPr>
+          <a:xfrm>
+            <a:off x="1508760" y="1645920"/>
+            <a:ext cx="10058400" cy="411480"/>
+          </a:xfrm>
+          <a:prstGeom prst="rect">
+            <a:avLst/>
+          </a:prstGeom>
+          <a:noFill/>
+          <a:ln/>
+        </p:spPr>
+        <p:txBody>
+          <a:bodyPr wrap="square" lIns="0" tIns="0" rIns="0" bIns="0" rtlCol="0" anchor="t"/>
+          <a:lstStyle/>
+          <a:p>
+            <a:pPr indent="0" marL="0">
+              <a:buNone/>
+            </a:pPr>
+            <a:r>
+              <a:rPr lang="en-US" sz="1800" b="1" dirty="0">
+                <a:solidFill>
+                  <a:schemeClr val="tx2"/>
+                </a:solidFill>
+              </a:rPr>
+              <a:t>A live odds feed</a:t>
+            </a:r>
+            <a:endParaRPr lang="en-US" sz="1800" dirty="0"/>
+          </a:p>
+        </p:txBody>
+      </p:sp>
+      <p:sp>
+        <p:nvSpPr>
+          <p:cNvPr id="6" name="Text 4"/>
+          <p:cNvSpPr txBox="1"/>
+          <p:nvPr/>
+        </p:nvSpPr>
+        <p:spPr>
+          <a:xfrm>
+            <a:off x="1508760" y="2066544"/>
+            <a:ext cx="10058400" cy="960120"/>
+          </a:xfrm>
+          <a:prstGeom prst="rect">
+            <a:avLst/>
+          </a:prstGeom>
+          <a:noFill/>
+          <a:ln/>
+        </p:spPr>
+        <p:txBody>
+          <a:bodyPr wrap="square" lIns="0" tIns="0" rIns="0" bIns="0" rtlCol="0" anchor="t"/>
+          <a:lstStyle/>
+          <a:p>
+            <a:pPr indent="0" marL="0">
+              <a:buNone/>
+            </a:pPr>
+            <a:r>
+              <a:rPr lang="en-US" sz="1350" dirty="0">
+                <a:solidFill>
+                  <a:schemeClr val="accent5"/>
+                </a:solidFill>
+              </a:rPr>
+              <a:t>Every result here says what the method WOULD have done. The three stages are online and causal and the state is one weight vector plus two scalars, so it runs in real time against a streaming API. That turns a statistical edge into an exploitable one.</a:t>
+            </a:r>
+            <a:endParaRPr lang="en-US" sz="1350" dirty="0"/>
+          </a:p>
+        </p:txBody>
+      </p:sp>
+      <p:sp>
+        <p:nvSpPr>
+          <p:cNvPr id="7" name="circle-2"/>
+          <p:cNvSpPr/>
+          <p:nvPr/>
+        </p:nvSpPr>
+        <p:spPr>
+          <a:xfrm>
+            <a:off x="640080" y="3200400"/>
+            <a:ext cx="566928" cy="566928"/>
+          </a:xfrm>
+          <a:prstGeom prst="ellipse">
+            <a:avLst/>
+          </a:prstGeom>
+          <a:solidFill>
+            <a:schemeClr val="accent1"/>
+          </a:solidFill>
+          <a:ln/>
+        </p:spPr>
+      </p:sp>
+      <p:sp>
+        <p:nvSpPr>
+          <p:cNvPr id="8" name="Text 6"/>
+          <p:cNvSpPr txBox="1"/>
+          <p:nvPr/>
+        </p:nvSpPr>
+        <p:spPr>
+          <a:xfrm>
+            <a:off x="640080" y="3200400"/>
+            <a:ext cx="566928" cy="566928"/>
+          </a:xfrm>
+          <a:prstGeom prst="rect">
+            <a:avLst/>
+          </a:prstGeom>
+          <a:noFill/>
+          <a:ln/>
+        </p:spPr>
+        <p:txBody>
+          <a:bodyPr wrap="square" lIns="0" tIns="0" rIns="0" bIns="0" rtlCol="0" anchor="ctr"/>
+          <a:lstStyle/>
+          <a:p>
+            <a:pPr algn="ctr" indent="0" marL="0">
+              <a:buNone/>
+            </a:pPr>
+            <a:r>
+              <a:rPr lang="en-US" sz="2000" b="1" dirty="0">
+                <a:solidFill>
+                  <a:srgbClr val="FFFFFF"/>
+                </a:solidFill>
+              </a:rPr>
+              <a:t>2</a:t>
+            </a:r>
+            <a:endParaRPr lang="en-US" sz="2000" dirty="0"/>
+          </a:p>
+        </p:txBody>
+      </p:sp>
+      <p:sp>
+        <p:nvSpPr>
+          <p:cNvPr id="9" name="Text 7"/>
+          <p:cNvSpPr txBox="1"/>
+          <p:nvPr/>
+        </p:nvSpPr>
+        <p:spPr>
+          <a:xfrm>
+            <a:off x="1508760" y="3154680"/>
+            <a:ext cx="10058400" cy="411480"/>
+          </a:xfrm>
+          <a:prstGeom prst="rect">
+            <a:avLst/>
+          </a:prstGeom>
+          <a:noFill/>
+          <a:ln/>
+        </p:spPr>
+        <p:txBody>
+          <a:bodyPr wrap="square" lIns="0" tIns="0" rIns="0" bIns="0" rtlCol="0" anchor="t"/>
+          <a:lstStyle/>
+          <a:p>
+            <a:pPr indent="0" marL="0">
+              <a:buNone/>
+            </a:pPr>
+            <a:r>
+              <a:rPr lang="en-US" sz="1800" b="1" dirty="0">
+                <a:solidFill>
+                  <a:schemeClr val="tx2"/>
+                </a:solidFill>
+              </a:rPr>
+              <a:t>A second sport</a:t>
+            </a:r>
+            <a:endParaRPr lang="en-US" sz="1800" dirty="0"/>
+          </a:p>
+        </p:txBody>
+      </p:sp>
+      <p:sp>
+        <p:nvSpPr>
+          <p:cNvPr id="10" name="Text 8"/>
+          <p:cNvSpPr txBox="1"/>
+          <p:nvPr/>
+        </p:nvSpPr>
+        <p:spPr>
+          <a:xfrm>
+            <a:off x="1508760" y="3575304"/>
+            <a:ext cx="10058400" cy="960120"/>
+          </a:xfrm>
+          <a:prstGeom prst="rect">
+            <a:avLst/>
+          </a:prstGeom>
+          <a:noFill/>
+          <a:ln/>
+        </p:spPr>
+        <p:txBody>
+          <a:bodyPr wrap="square" lIns="0" tIns="0" rIns="0" bIns="0" rtlCol="0" anchor="t"/>
+          <a:lstStyle/>
+          <a:p>
+            <a:pPr indent="0" marL="0">
+              <a:buNone/>
+            </a:pPr>
+            <a:r>
+              <a:rPr lang="en-US" sz="1350" dirty="0">
+                <a:solidFill>
+                  <a:schemeClr val="accent5"/>
+                </a:solidFill>
+              </a:rPr>
+              <a:t>Basketball or tennis would show whether the framework generalises. The cost is a data pipeline; the algorithms do not change.</a:t>
+            </a:r>
+            <a:endParaRPr lang="en-US" sz="1350" dirty="0"/>
+          </a:p>
+        </p:txBody>
+      </p:sp>
+      <p:sp>
+        <p:nvSpPr>
+          <p:cNvPr id="11" name="circle-3"/>
+          <p:cNvSpPr/>
+          <p:nvPr/>
+        </p:nvSpPr>
+        <p:spPr>
+          <a:xfrm>
+            <a:off x="640080" y="4709160"/>
+            <a:ext cx="566928" cy="566928"/>
+          </a:xfrm>
+          <a:prstGeom prst="ellipse">
+            <a:avLst/>
+          </a:prstGeom>
+          <a:solidFill>
+            <a:schemeClr val="accent1"/>
+          </a:solidFill>
+          <a:ln/>
+        </p:spPr>
+      </p:sp>
+      <p:sp>
+        <p:nvSpPr>
+          <p:cNvPr id="12" name="Text 10"/>
+          <p:cNvSpPr txBox="1"/>
+          <p:nvPr/>
+        </p:nvSpPr>
+        <p:spPr>
+          <a:xfrm>
+            <a:off x="640080" y="4709160"/>
+            <a:ext cx="566928" cy="566928"/>
+          </a:xfrm>
+          <a:prstGeom prst="rect">
+            <a:avLst/>
+          </a:prstGeom>
+          <a:noFill/>
+          <a:ln/>
+        </p:spPr>
+        <p:txBody>
+          <a:bodyPr wrap="square" lIns="0" tIns="0" rIns="0" bIns="0" rtlCol="0" anchor="ctr"/>
+          <a:lstStyle/>
+          <a:p>
+            <a:pPr algn="ctr" indent="0" marL="0">
+              <a:buNone/>
+            </a:pPr>
+            <a:r>
+              <a:rPr lang="en-US" sz="2000" b="1" dirty="0">
+                <a:solidFill>
+                  <a:srgbClr val="FFFFFF"/>
+                </a:solidFill>
+              </a:rPr>
+              <a:t>3</a:t>
+            </a:r>
+            <a:endParaRPr lang="en-US" sz="2000" dirty="0"/>
+          </a:p>
+        </p:txBody>
+      </p:sp>
+      <p:sp>
+        <p:nvSpPr>
+          <p:cNvPr id="13" name="Text 11"/>
+          <p:cNvSpPr txBox="1"/>
+          <p:nvPr/>
+        </p:nvSpPr>
+        <p:spPr>
+          <a:xfrm>
+            <a:off x="1508760" y="4663440"/>
+            <a:ext cx="10058400" cy="411480"/>
+          </a:xfrm>
+          <a:prstGeom prst="rect">
+            <a:avLst/>
+          </a:prstGeom>
+          <a:noFill/>
+          <a:ln/>
+        </p:spPr>
+        <p:txBody>
+          <a:bodyPr wrap="square" lIns="0" tIns="0" rIns="0" bIns="0" rtlCol="0" anchor="t"/>
+          <a:lstStyle/>
+          <a:p>
+            <a:pPr indent="0" marL="0">
+              <a:buNone/>
+            </a:pPr>
+            <a:r>
+              <a:rPr lang="en-US" sz="1800" b="1" dirty="0">
+                <a:solidFill>
+                  <a:schemeClr val="tx2"/>
+                </a:solidFill>
+              </a:rPr>
+              <a:t>Bayesian Model Averaging as a baseline</a:t>
+            </a:r>
+            <a:endParaRPr lang="en-US" sz="1800" dirty="0"/>
+          </a:p>
+        </p:txBody>
+      </p:sp>
+      <p:sp>
+        <p:nvSpPr>
+          <p:cNvPr id="14" name="Text 12"/>
+          <p:cNvSpPr txBox="1"/>
+          <p:nvPr/>
+        </p:nvSpPr>
+        <p:spPr>
+          <a:xfrm>
+            <a:off x="1508760" y="5084064"/>
+            <a:ext cx="10058400" cy="960120"/>
+          </a:xfrm>
+          <a:prstGeom prst="rect">
+            <a:avLst/>
+          </a:prstGeom>
+          <a:noFill/>
+          <a:ln/>
+        </p:spPr>
+        <p:txBody>
+          <a:bodyPr wrap="square" lIns="0" tIns="0" rIns="0" bIns="0" rtlCol="0" anchor="t"/>
+          <a:lstStyle/>
+          <a:p>
+            <a:pPr indent="0" marL="0">
+              <a:buNone/>
+            </a:pPr>
+            <a:r>
+              <a:rPr lang="en-US" sz="1350" dirty="0">
+                <a:solidFill>
+                  <a:schemeClr val="accent5"/>
+                </a:solidFill>
+              </a:rPr>
+              <a:t>An empirical comparison against the online algorithms, and more light on why the Aggregating Algorithm underperforms here.</a:t>
+            </a:r>
+            <a:endParaRPr lang="en-US" sz="1350" dirty="0"/>
+          </a:p>
+        </p:txBody>
+      </p:sp>
+      <p:sp>
+        <p:nvSpPr>
+          <p:cNvPr id="25" name="Slide Number Placeholder 0"/>
+          <p:cNvSpPr>
+            <a:spLocks noGrp="1"/>
+          </p:cNvSpPr>
+          <p:nvPr>
+            <p:ph type="sldNum" sz="quarter" idx="4294967295"/>
+          </p:nvPr>
+        </p:nvSpPr>
+        <p:spPr>
+          <a:xfrm>
+            <a:off x="11521440" y="6355080"/>
+            <a:ext cx="800000" cy="300000"/>
+          </a:xfrm>
+          <a:prstGeom prst="rect">
+            <a:avLst/>
+          </a:prstGeom>
+          <a:extLst>
+            <a:ext uri="{C572A759-6A51-4108-AA02-DFA0A04FC94B}">
+              <ma14:wrappingTextBoxFlag xmlns:ma14="http://schemas.microsoft.com/office/mac/drawingml/2011/main" val="0"/>
+            </a:ext>
+          </a:extLst>
+        </p:spPr>
+        <p:txBody>
+          <a:bodyPr/>
+          <a:lstStyle>
+            <a:lvl1pPr>
+              <a:defRPr sz="1100">
+                <a:solidFill>
+                  <a:schemeClr val="accent6"/>
+                </a:solidFill>
+              </a:defRPr>
+            </a:lvl1pPr>
+          </a:lstStyle>
+          <a:p>
+            <a:pPr algn="l"/>
+            <a:fld id="{F7021451-1387-4CA6-816F-3879F97B5CBC}" type="slidenum">
+              <a:rPr b="0" lang="en-US"/>
+              <a:t>17</a:t>
+            </a:fld>
+            <a:endParaRPr lang="en-US"/>
+          </a:p>
+        </p:txBody>
+      </p:sp>
+    </p:spTree>
+  </p:cSld>
+  <p:clrMapOvr>
+    <a:masterClrMapping/>
+  </p:clrMapOvr>
+</p:sld>
+</file>
+
+<file path=ppt/slides/slide18.xml><?xml version="1.0" encoding="utf-8"?>
+<p:sld xmlns:a="http://schemas.openxmlformats.org/drawingml/2006/main" xmlns:r="http://schemas.openxmlformats.org/officeDocument/2006/relationships" xmlns:p="http://schemas.openxmlformats.org/presentationml/2006/main">
+  <p:cSld name="Slide 18">
     <p:spTree>
       <p:nvGrpSpPr>
         <p:cNvPr id="1" name=""/>

</xml_diff>

<commit_message>
Short defence deck and script: Hedge results
Ranking, heterogeneity, line movement (now 42-fold), deployment and
value betting carry the specialists-Hedge numbers; slide 16 shows the
regret bound used as a test.

Co-Authored-By: Claude Opus 5.5 <noreply@anthropic.com>
</commit_message>
<xml_diff>
--- a/docs/defense_presentation_short.pptx
+++ b/docs/defense_presentation_short.pptx
@@ -24,9 +24,10 @@
     <p:sldId id="272" r:id="rId18"/>
     <p:sldId id="273" r:id="rId19"/>
     <p:sldId id="274" r:id="rId20"/>
+    <p:sldId id="275" r:id="rId21"/>
   </p:sldIdLst>
   <p:notesMasterIdLst>
-    <p:notesMasterId r:id="rId21"/>
+    <p:notesMasterId r:id="rId22"/>
   </p:notesMasterIdLst>
   <p:sldSz cx="12192000" cy="6858000"/>
   <p:notesSz cx="6858000" cy="12192000"/>
@@ -125,7 +126,7 @@
   <p:extLst>
     <p:ext uri="{521415D9-36F7-43E2-AB2F-B90AF26B5E84}">
       <p14:sectionLst xmlns:p14="http://schemas.microsoft.com/office/powerpoint/2010/main">
-        <p14:section name="Talk" id="{9e8378e7-8c6e-cd92-6a73-2e8a5346d29b}">
+        <p14:section name="Talk" id="{f134a6ee-a5ae-6aed-35cc-7f79dcbe38eb}">
           <p14:sldIdLst>
             <p14:sldId id="256"/>
             <p14:sldId id="257"/>
@@ -146,6 +147,7 @@
             <p14:sldId id="272"/>
             <p14:sldId id="273"/>
             <p14:sldId id="274"/>
+            <p14:sldId id="275"/>
           </p14:sldIdLst>
         </p14:section>
       </p14:sectionLst>
@@ -550,7 +552,7 @@
           </c:tx>
           <c:spPr>
             <a:solidFill>
-              <a:srgbClr val="C1121F"/>
+              <a:srgbClr val="0F4C81"/>
             </a:solidFill>
             <a:effectLst/>
           </c:spPr>
@@ -585,7 +587,7 @@
             <c:bubble3D val="0"/>
             <c:spPr>
               <a:solidFill>
-                <a:srgbClr val="C1121F"/>
+                <a:srgbClr val="0F4C81"/>
               </a:solidFill>
               <a:effectLst/>
             </c:spPr>
@@ -596,7 +598,7 @@
             <c:bubble3D val="0"/>
             <c:spPr>
               <a:solidFill>
-                <a:srgbClr val="0F4C81"/>
+                <a:srgbClr val="C1121F"/>
               </a:solidFill>
               <a:effectLst/>
             </c:spPr>
@@ -685,13 +687,13 @@
                 <c:ptCount val="9"/>
                 <c:lvl>
                   <c:pt idx="0">
+                    <c:v>Hedge</c:v>
+                  </c:pt>
+                  <c:pt idx="1">
                     <c:v>PSC</c:v>
                   </c:pt>
-                  <c:pt idx="1">
+                  <c:pt idx="2">
                     <c:v>OGD</c:v>
-                  </c:pt>
-                  <c:pt idx="2">
-                    <c:v>Hedge</c:v>
                   </c:pt>
                   <c:pt idx="3">
                     <c:v>FTRL</c:v>
@@ -722,13 +724,13 @@
                 <c:formatCode>General</c:formatCode>
                 <c:ptCount val="9"/>
                 <c:pt idx="0">
+                  <c:v>0.99656</c:v>
+                </c:pt>
+                <c:pt idx="1">
                   <c:v>0.99685</c:v>
                 </c:pt>
-                <c:pt idx="1">
+                <c:pt idx="2">
                   <c:v>0.99693</c:v>
-                </c:pt>
-                <c:pt idx="2">
-                  <c:v>0.99772</c:v>
                 </c:pt>
                 <c:pt idx="3">
                   <c:v>0.99773</c:v>
@@ -828,7 +830,7 @@
         <c:scaling>
           <c:orientation val="minMax"/>
           <c:max val="1.0012"/>
-          <c:min val="0.9965"/>
+          <c:min val="0.996"/>
         </c:scaling>
         <c:delete val="0"/>
         <c:axPos val="b"/>
@@ -988,7 +990,7 @@
                   <c:v>1.00076</c:v>
                 </c:pt>
                 <c:pt idx="1">
-                  <c:v>1.00078</c:v>
+                  <c:v>1.00019</c:v>
                 </c:pt>
                 <c:pt idx="2">
                   <c:v>1.00078</c:v>
@@ -1077,7 +1079,7 @@
                   <c:v>0.99746</c:v>
                 </c:pt>
                 <c:pt idx="1">
-                  <c:v>0.99839</c:v>
+                  <c:v>0.9969</c:v>
                 </c:pt>
                 <c:pt idx="2">
                   <c:v>0.99841</c:v>
@@ -1166,7 +1168,7 @@
                   <c:v>0.99723</c:v>
                 </c:pt>
                 <c:pt idx="1">
-                  <c:v>0.99762</c:v>
+                  <c:v>0.99711</c:v>
                 </c:pt>
                 <c:pt idx="2">
                   <c:v>0.99761</c:v>
@@ -1491,19 +1493,19 @@
                 <c:formatCode>General</c:formatCode>
                 <c:ptCount val="5"/>
                 <c:pt idx="0">
-                  <c:v>0.0004455286072115</c:v>
+                  <c:v>0.0002706918386334</c:v>
                 </c:pt>
                 <c:pt idx="1">
-                  <c:v>0.0006720359451092</c:v>
+                  <c:v>0.0005100357630526</c:v>
                 </c:pt>
                 <c:pt idx="2">
-                  <c:v>0.0020182809653802</c:v>
+                  <c:v>0.001442340715369</c:v>
                 </c:pt>
                 <c:pt idx="3">
-                  <c:v>0.0042176873941862</c:v>
+                  <c:v>0.0040835425690032</c:v>
                 </c:pt>
                 <c:pt idx="4">
-                  <c:v>0.0117989748500138</c:v>
+                  <c:v>0.0115173289615689</c:v>
                 </c:pt>
               </c:numCache>
             </c:numRef>
@@ -1826,13 +1828,13 @@
                     <c:v>BWC</c:v>
                   </c:pt>
                   <c:pt idx="3">
-                    <c:v>WH</c:v>
+                    <c:v>BW</c:v>
                   </c:pt>
                   <c:pt idx="4">
-                    <c:v>BW</c:v>
+                    <c:v>VC_BVC</c:v>
                   </c:pt>
                   <c:pt idx="5">
-                    <c:v>VC_BVC</c:v>
+                    <c:v>WH</c:v>
                   </c:pt>
                   <c:pt idx="6">
                     <c:v>B365C</c:v>
@@ -1854,31 +1856,31 @@
                 <c:formatCode>General</c:formatCode>
                 <c:ptCount val="9"/>
                 <c:pt idx="0">
-                  <c:v>1.596</c:v>
+                  <c:v>1.932</c:v>
                 </c:pt>
                 <c:pt idx="1">
-                  <c:v>0.897</c:v>
+                  <c:v>1.378</c:v>
                 </c:pt>
                 <c:pt idx="2">
+                  <c:v>0.428</c:v>
+                </c:pt>
+                <c:pt idx="3">
+                  <c:v>0.303</c:v>
+                </c:pt>
+                <c:pt idx="4">
+                  <c:v>0.283</c:v>
+                </c:pt>
+                <c:pt idx="5">
                   <c:v>0.204</c:v>
                 </c:pt>
-                <c:pt idx="3">
-                  <c:v>0.146</c:v>
-                </c:pt>
-                <c:pt idx="4">
-                  <c:v>0.1</c:v>
-                </c:pt>
-                <c:pt idx="5">
-                  <c:v>-0.155</c:v>
-                </c:pt>
                 <c:pt idx="6">
-                  <c:v>-0.292</c:v>
+                  <c:v>0.185</c:v>
                 </c:pt>
                 <c:pt idx="7">
-                  <c:v>-0.602</c:v>
+                  <c:v>-0.678</c:v>
                 </c:pt>
                 <c:pt idx="8">
-                  <c:v>-3.699</c:v>
+                  <c:v>-3.097</c:v>
                 </c:pt>
               </c:numCache>
             </c:numRef>
@@ -2895,7 +2897,7 @@
           <a:p>
             <a:r>
               <a:rPr lang="en-US" dirty="0"/>
-              <a:t>The edge sits at the soft houses and is absent at the sharp one. That is the thesis's uncomfortable finding.</a:t>
+              <a:t>The edge sits at the soft houses and is absent at the sharp one. With Hedge, the better forecaster, the profits grow (WHC 39x to 86x, IW 8x to 24x) and Hedge bets significantly better than OGD against four of the eleven targets, never worse; the Pinnacle losses remain.</a:t>
             </a:r>
             <a:endParaRPr lang="en-US" dirty="0"/>
           </a:p>
@@ -3071,7 +3073,7 @@
           <a:p>
             <a:r>
               <a:rPr lang="en-US" dirty="0"/>
-              <a:t>Fast slide. The pattern matters more than the list.</a:t>
+              <a:t>The second methodological finding of the same kind as the 42%: a number from theory, checked against the data, exposed an implementation that looked right. The earlier explanation of the Aggregating Algorithm's failure (Pinnacle disappearing) was wrong.</a:t>
             </a:r>
             <a:endParaRPr lang="en-US" dirty="0"/>
           </a:p>
@@ -3159,7 +3161,7 @@
           <a:p>
             <a:r>
               <a:rPr lang="en-US" dirty="0"/>
-              <a:t>Five points, about twelve seconds each. Nothing new here.</a:t>
+              <a:t>Fast slide. The pattern matters more than the list.</a:t>
             </a:r>
             <a:endParaRPr lang="en-US" dirty="0"/>
           </a:p>
@@ -3247,7 +3249,7 @@
           <a:p>
             <a:r>
               <a:rPr lang="en-US" dirty="0"/>
-              <a:t>The live feed answers the thesis's own main limitation.</a:t>
+              <a:t>Five points, about twelve seconds each. Nothing new here.</a:t>
             </a:r>
             <a:endParaRPr lang="en-US" dirty="0"/>
           </a:p>
@@ -3335,7 +3337,7 @@
           <a:p>
             <a:r>
               <a:rPr lang="en-US" dirty="0"/>
-              <a:t>Stop talking. Let them ask.</a:t>
+              <a:t>The live feed answers the thesis's own main limitation.</a:t>
             </a:r>
             <a:endParaRPr lang="en-US" dirty="0"/>
           </a:p>
@@ -3465,6 +3467,94 @@
 </p:notes>
 </file>
 
+<file path=ppt/notesSlides/notesSlide20.xml><?xml version="1.0" encoding="utf-8"?>
+<p:notes xmlns:a="http://schemas.openxmlformats.org/drawingml/2006/main" xmlns:r="http://schemas.openxmlformats.org/officeDocument/2006/relationships" xmlns:p="http://schemas.openxmlformats.org/presentationml/2006/main">
+  <p:cSld>
+    <p:spTree>
+      <p:nvGrpSpPr>
+        <p:cNvPr id="1" name=""/>
+        <p:cNvGrpSpPr/>
+        <p:nvPr/>
+      </p:nvGrpSpPr>
+      <p:grpSpPr>
+        <a:xfrm>
+          <a:off x="0" y="0"/>
+          <a:ext cx="0" cy="0"/>
+          <a:chOff x="0" y="0"/>
+          <a:chExt cx="0" cy="0"/>
+        </a:xfrm>
+      </p:grpSpPr>
+      <p:sp>
+        <p:nvSpPr>
+          <p:cNvPr id="2" name="Slide Image Placeholder 1"/>
+          <p:cNvSpPr>
+            <a:spLocks noGrp="1" noRot="1" noChangeAspect="1"/>
+          </p:cNvSpPr>
+          <p:nvPr>
+            <p:ph type="sldImg"/>
+          </p:nvPr>
+        </p:nvSpPr>
+        <p:spPr/>
+      </p:sp>
+      <p:sp>
+        <p:nvSpPr>
+          <p:cNvPr id="3" name="Notes Placeholder 2"/>
+          <p:cNvSpPr>
+            <a:spLocks noGrp="1"/>
+          </p:cNvSpPr>
+          <p:nvPr>
+            <p:ph type="body" idx="1"/>
+          </p:nvPr>
+        </p:nvSpPr>
+        <p:spPr/>
+        <p:txBody>
+          <a:bodyPr/>
+          <a:lstStyle/>
+          <a:p>
+            <a:r>
+              <a:rPr lang="en-US" dirty="0"/>
+              <a:t>Stop talking. Let them ask.</a:t>
+            </a:r>
+            <a:endParaRPr lang="en-US" dirty="0"/>
+          </a:p>
+        </p:txBody>
+      </p:sp>
+      <p:sp>
+        <p:nvSpPr>
+          <p:cNvPr id="4" name="Slide Number Placeholder 3"/>
+          <p:cNvSpPr>
+            <a:spLocks noGrp="1"/>
+          </p:cNvSpPr>
+          <p:nvPr>
+            <p:ph type="sldNum" sz="quarter" idx="10"/>
+          </p:nvPr>
+        </p:nvSpPr>
+        <p:spPr/>
+        <p:txBody>
+          <a:bodyPr/>
+          <a:lstStyle/>
+          <a:p>
+            <a:fld id="{F7021451-1387-4CA6-816F-3879F97B5CBC}" type="slidenum">
+              <a:rPr lang="en-US"/>
+              <a:t>20</a:t>
+            </a:fld>
+            <a:endParaRPr lang="en-US"/>
+          </a:p>
+        </p:txBody>
+      </p:sp>
+    </p:spTree>
+    <p:extLst>
+      <p:ext uri="{BB962C8B-B14F-4D97-AF65-F5344CB8AC3E}">
+        <p14:creationId xmlns:p14="http://schemas.microsoft.com/office/powerpoint/2010/main" val="1024086991"/>
+      </p:ext>
+    </p:extLst>
+  </p:cSld>
+  <p:clrMapOvr>
+    <a:masterClrMapping/>
+  </p:clrMapOvr>
+</p:notes>
+</file>
+
 <file path=ppt/notesSlides/notesSlide3.xml><?xml version="1.0" encoding="utf-8"?>
 <p:notes xmlns:a="http://schemas.openxmlformats.org/drawingml/2006/main" xmlns:r="http://schemas.openxmlformats.org/officeDocument/2006/relationships" xmlns:p="http://schemas.openxmlformats.org/presentationml/2006/main">
   <p:cSld>
@@ -3687,7 +3777,7 @@
           <a:p>
             <a:r>
               <a:rPr lang="en-US" dirty="0"/>
-              <a:t>Blue cells are quotes. Point at a gap: that expert's weight does not move while it sleeps.</a:t>
+              <a:t>Blue cells are quotes. Point at a gap: that expert's weight does not move while it sleeps. For Hedge the awake group is rescaled back to its previous total mass after each update: that rescaling is what the guarantee rests on (slide 16).</a:t>
             </a:r>
             <a:endParaRPr lang="en-US" dirty="0"/>
           </a:p>
@@ -3951,7 +4041,7 @@
           <a:p>
             <a:r>
               <a:rPr lang="en-US" dirty="0"/>
-              <a:t>Where eta sits decides the direction: one gradient for OGD, an exponent over one loss for Hedge.</a:t>
+              <a:t>Where eta sits decides the direction: one gradient for OGD, the whole accumulated loss for FTRL.</a:t>
             </a:r>
             <a:endParaRPr lang="en-US" dirty="0"/>
           </a:p>
@@ -4978,7 +5068,7 @@
                   <a:schemeClr val="tx2"/>
                 </a:solidFill>
               </a:rPr>
-              <a:t>Learning pays only where the experts differ</a:t>
+              <a:t>Learning pays most where the experts differ</a:t>
             </a:r>
             <a:endParaRPr lang="en-US" sz="3000" dirty="0"/>
           </a:p>
@@ -5057,7 +5147,7 @@
                   <a:schemeClr val="accent2"/>
                 </a:solidFill>
               </a:rPr>
-              <a:t>The reversal</a:t>
+              <a:t>The gain shrinks</a:t>
             </a:r>
             <a:endParaRPr lang="en-US" sz="1800" dirty="0"/>
           </a:p>
@@ -5093,7 +5183,7 @@
                   <a:schemeClr val="tx1"/>
                 </a:solidFill>
               </a:rPr>
-              <a:t>On the FULL panel all three algorithms beat the plain average significantly.</a:t>
+              <a:t>FULL panel: all three beat the plain average, Hedge by 0.0020 and OGD by 0.0014.</a:t>
             </a:r>
             <a:endParaRPr lang="en-US" sz="1400" dirty="0"/>
           </a:p>
@@ -5113,7 +5203,7 @@
                   <a:schemeClr val="tx1"/>
                 </a:solidFill>
               </a:rPr>
-              <a:t>On the HOMOGENEOUS closing panel, Hedge and FTRL LOSE to it, in 4 tests out of 4; on the opening one all three tie.</a:t>
+              <a:t>HOMOGENEOUS panels: OGD falls to 0.0003 on closing and a tie on opening; FTRL loses on closing. Only Hedge still wins on both, by 0.0004 to 0.0006.</a:t>
             </a:r>
             <a:endParaRPr lang="en-US" sz="1400" dirty="0"/>
           </a:p>
@@ -5149,7 +5239,7 @@
                   <a:schemeClr val="accent5"/>
                 </a:solidFill>
               </a:rPr>
-              <a:t>Remove the quality spread and adaptation buys nothing.</a:t>
+              <a:t>A quality spread is what learning feeds on. Remove it and most of the gain goes.</a:t>
             </a:r>
             <a:endParaRPr lang="en-US" sz="1350" dirty="0"/>
           </a:p>
@@ -5336,7 +5426,7 @@
                   <a:schemeClr val="accent1"/>
                 </a:solidFill>
               </a:rPr>
-              <a:t>A 26-fold gradient</a:t>
+              <a:t>A 42-fold gradient</a:t>
             </a:r>
             <a:endParaRPr lang="en-US" sz="1800" dirty="0"/>
           </a:p>
@@ -5372,7 +5462,7 @@
                   <a:schemeClr val="tx1"/>
                 </a:solidFill>
               </a:rPr>
-              <a:t>Microstructure predicts the closing advantage should concentrate where the line moved. It does: 0.00045 in the quiet fifth, 0.01180 in the noisy one.</a:t>
+              <a:t>Microstructure predicts the closing advantage should concentrate where the line moved. It does: 0.00027 in the quiet fifth, 0.01152 in the noisy one.</a:t>
             </a:r>
             <a:endParaRPr lang="en-US" sz="1400" dirty="0"/>
           </a:p>
@@ -5408,7 +5498,7 @@
                   <a:schemeClr val="accent2"/>
                 </a:solidFill>
               </a:rPr>
-              <a:t>In Q1 it is only just significant (p = 0.048).</a:t>
+              <a:t>In Q1 and Q2 it is not even significant (p = 0.27, 0.14).</a:t>
             </a:r>
             <a:endParaRPr lang="en-US" sz="1400" dirty="0"/>
           </a:p>
@@ -5723,7 +5813,7 @@
                   <a:schemeClr val="accent5"/>
                 </a:solidFill>
               </a:rPr>
-              <a:t>−0.0018 to −0.0029, all p ≤ 0.011</a:t>
+              <a:t>−0.0018 to −0.0030, all p ≤ 0.006</a:t>
             </a:r>
             <a:endParaRPr lang="en-US" sz="1350" dirty="0"/>
           </a:p>
@@ -5858,7 +5948,7 @@
                   <a:schemeClr val="accent5"/>
                 </a:solidFill>
               </a:rPr>
-              <a:t>B365C and BWC tie with every variant, p from 0.263 to 0.892 · PSC ties too, on its own rounds</a:t>
+              <a:t>B365C and BWC tie with every variant, p from 0.211 to 0.730 · PSC ties too, on its own rounds</a:t>
             </a:r>
             <a:endParaRPr lang="en-US" sz="1350" dirty="0"/>
           </a:p>
@@ -5993,7 +6083,7 @@
                   <a:schemeClr val="accent5"/>
                 </a:solidFill>
               </a:rPr>
-              <a:t>+0.00078 to +0.00143, p ≤ 0.026 · an exchange, a market price with no operator margin, and Pinnacle has stopped quoting</a:t>
+              <a:t>+0.00070 to +0.00141, p ≤ 0.019 · an exchange, a market price with no operator margin, and Pinnacle has stopped quoting</a:t>
             </a:r>
             <a:endParaRPr lang="en-US" sz="1350" dirty="0"/>
           </a:p>
@@ -6614,7 +6704,7 @@
                   <a:schemeClr val="tx2"/>
                 </a:solidFill>
               </a:rPr>
-              <a:t>The optimal step is a property of the panel: with nobody asleep, Hedge and FTRL select steps 30 to 1000 times the textbook one, not smaller.</a:t>
+              <a:t>The optimal step is a property of the panel: FTRL wants ×0.05 when experts come and go, and 30 to 1000 times the textbook step when nobody is asleep.</a:t>
             </a:r>
             <a:endParaRPr lang="en-US" sz="1500" dirty="0"/>
           </a:p>
@@ -6837,7 +6927,7 @@
                   <a:schemeClr val="tx1"/>
                 </a:solidFill>
               </a:rPr>
-              <a:t>Significant gains against WHC (p=0.001) and IW (p=0.008), both recreational-facing houses. Significant LOSSES against both Pinnacle prices (PS p=0.050, PSC p&lt;0.001), the best forecaster in the panel, i.e. exactly the opponent an inferior model should lose to.</a:t>
+              <a:t>Significant gains against WHC (85.6×) and IW (23.9×), both recreational-facing houses, p &lt; 0.001; significant LOSSES against both Pinnacle prices (PS p = 0.040, PSC p = 0.001), the best forecaster in the panel.</a:t>
             </a:r>
             <a:endParaRPr lang="en-US" sz="1350" dirty="0"/>
           </a:p>
@@ -6873,7 +6963,7 @@
                   <a:schemeClr val="accent5"/>
                 </a:solidFill>
               </a:rPr>
-              <a:t>The quality gained is smaller than the margin charged.</a:t>
+              <a:t>Hedge bets significantly better than OGD against 4 of the 11 targets, and worse against none.</a:t>
             </a:r>
             <a:endParaRPr lang="en-US" sz="1350" dirty="0"/>
           </a:p>
@@ -6909,7 +6999,7 @@
                   <a:schemeClr val="accent5"/>
                 </a:solidFill>
               </a:rPr>
-              <a:t>0 = break even · +1 = a ten-fold bankroll · green = significant profit · red = significant loss</a:t>
+              <a:t>Hedge mixture · 0 = break even · +1 = a ten-fold bankroll · green = significant profit · red = significant loss</a:t>
             </a:r>
             <a:endParaRPr lang="en-US" sz="1200" dirty="0"/>
           </a:p>
@@ -7017,7 +7107,7 @@
                   <a:schemeClr val="bg1"/>
                 </a:solidFill>
               </a:rPr>
-              <a:t>42% of the margin over the uniform average is not learning</a:t>
+              <a:t>42% of OGD's margin over the uniform average is not learning</a:t>
             </a:r>
             <a:endParaRPr lang="en-US" sz="3400" dirty="0"/>
           </a:p>
@@ -7055,7 +7145,7 @@
                   <a:srgbClr val="CBD5E1"/>
                 </a:solidFill>
               </a:rPr>
-              <a:t>Under the Sleeping Experts reduction the weight vector moves even with a step of ZERO: the projection is re-done onto a simplex of different dimension whenever the awake set changes. A zero-step control separates the two. The number was real; the obvious reading of it was false.</a:t>
+              <a:t>Under the Sleeping Experts reduction OGD's weight vector moves even with a step of ZERO: the projection is re-done onto a simplex of different dimension whenever the awake set changes. A zero-step control separates the two. The number was real; the obvious reading of it was false.</a:t>
             </a:r>
             <a:endParaRPr lang="en-US" sz="1700" dirty="0"/>
           </a:p>
@@ -7118,7 +7208,7 @@
                   <a:schemeClr val="tx2"/>
                 </a:solidFill>
               </a:rPr>
-              <a:t>Nine ideas tried and rejected</a:t>
+              <a:t>A regret bound, used as a test</a:t>
             </a:r>
             <a:endParaRPr lang="en-US" sz="3000" dirty="0"/>
           </a:p>
@@ -7126,59 +7216,66 @@
       </p:sp>
       <p:sp>
         <p:nvSpPr>
-          <p:cNvPr id="3" name="neg-0"/>
+          <p:cNvPr id="3" name="Text 1"/>
+          <p:cNvSpPr txBox="1"/>
+          <p:nvPr/>
+        </p:nvSpPr>
+        <p:spPr>
+          <a:xfrm>
+            <a:off x="640080" y="1325880"/>
+            <a:ext cx="10881360" cy="685800"/>
+          </a:xfrm>
+          <a:prstGeom prst="rect">
+            <a:avLst/>
+          </a:prstGeom>
+          <a:noFill/>
+          <a:ln/>
+        </p:spPr>
+        <p:txBody>
+          <a:bodyPr wrap="square" rtlCol="0" anchor="ctr"/>
+          <a:lstStyle/>
+          <a:p>
+            <a:pPr indent="0" marL="0">
+              <a:buNone/>
+            </a:pPr>
+            <a:r>
+              <a:rPr lang="en-US" sz="1500" dirty="0">
+                <a:solidFill>
+                  <a:schemeClr val="tx1"/>
+                </a:solidFill>
+              </a:rPr>
+              <a:t>Hedge with step 1 is the Aggregating Algorithm. Its guarantee: on every expert's own awake rounds, the mixture trails that expert by at most ln 26 = 3.26 in total.</a:t>
+            </a:r>
+            <a:endParaRPr lang="en-US" sz="1500" dirty="0"/>
+          </a:p>
+        </p:txBody>
+      </p:sp>
+      <p:sp>
+        <p:nvSpPr>
+          <p:cNvPr id="4" name="bound-0"/>
           <p:cNvSpPr/>
           <p:nvPr/>
         </p:nvSpPr>
         <p:spPr>
           <a:xfrm>
-            <a:off x="640080" y="1719072"/>
-            <a:ext cx="237744" cy="237744"/>
-          </a:xfrm>
-          <a:prstGeom prst="ellipse">
-            <a:avLst/>
+            <a:off x="640080" y="2194560"/>
+            <a:ext cx="3429000" cy="2103120"/>
+          </a:xfrm>
+          <a:prstGeom prst="roundRect">
+            <a:avLst>
+              <a:gd name="adj" fmla="val 3478"/>
+            </a:avLst>
           </a:prstGeom>
           <a:solidFill>
-            <a:schemeClr val="accent4"/>
+            <a:srgbClr val="F2F5F9"/>
           </a:solidFill>
-          <a:ln/>
-        </p:spPr>
-      </p:sp>
-      <p:sp>
-        <p:nvSpPr>
-          <p:cNvPr id="4" name="Text 2"/>
-          <p:cNvSpPr txBox="1"/>
-          <p:nvPr/>
-        </p:nvSpPr>
-        <p:spPr>
-          <a:xfrm>
-            <a:off x="1024128" y="1645920"/>
-            <a:ext cx="3017520" cy="548640"/>
-          </a:xfrm>
-          <a:prstGeom prst="rect">
-            <a:avLst/>
-          </a:prstGeom>
-          <a:noFill/>
-          <a:ln/>
-        </p:spPr>
-        <p:txBody>
-          <a:bodyPr wrap="square" lIns="0" tIns="0" rIns="0" bIns="0" rtlCol="0" anchor="t"/>
-          <a:lstStyle/>
-          <a:p>
-            <a:pPr indent="0" marL="0">
-              <a:buNone/>
-            </a:pPr>
-            <a:r>
-              <a:rPr lang="en-US" sz="1500" b="1" dirty="0">
-                <a:solidFill>
-                  <a:schemeClr val="tx2"/>
-                </a:solidFill>
-              </a:rPr>
-              <a:t>Fixed-Share</a:t>
-            </a:r>
-            <a:endParaRPr lang="en-US" sz="1500" dirty="0"/>
-          </a:p>
-        </p:txBody>
+          <a:ln w="12700">
+            <a:solidFill>
+              <a:srgbClr val="E2E8F0"/>
+            </a:solidFill>
+            <a:prstDash val="solid"/>
+          </a:ln>
+        </p:spPr>
       </p:sp>
       <p:sp>
         <p:nvSpPr>
@@ -7188,8 +7285,44 @@
         </p:nvSpPr>
         <p:spPr>
           <a:xfrm>
-            <a:off x="1024128" y="2212848"/>
-            <a:ext cx="3017520" cy="640080"/>
+            <a:off x="914400" y="2377440"/>
+            <a:ext cx="2926080" cy="822960"/>
+          </a:xfrm>
+          <a:prstGeom prst="rect">
+            <a:avLst/>
+          </a:prstGeom>
+          <a:noFill/>
+          <a:ln/>
+        </p:spPr>
+        <p:txBody>
+          <a:bodyPr wrap="square" lIns="0" tIns="0" rIns="0" bIns="0" rtlCol="0" anchor="b"/>
+          <a:lstStyle/>
+          <a:p>
+            <a:pPr indent="0" marL="0">
+              <a:buNone/>
+            </a:pPr>
+            <a:r>
+              <a:rPr lang="en-US" sz="4400" b="1" dirty="0">
+                <a:solidFill>
+                  <a:schemeClr val="accent2"/>
+                </a:solidFill>
+              </a:rPr>
+              <a:t>165</a:t>
+            </a:r>
+            <a:endParaRPr lang="en-US" sz="4400" dirty="0"/>
+          </a:p>
+        </p:txBody>
+      </p:sp>
+      <p:sp>
+        <p:nvSpPr>
+          <p:cNvPr id="6" name="Text 4"/>
+          <p:cNvSpPr txBox="1"/>
+          <p:nvPr/>
+        </p:nvSpPr>
+        <p:spPr>
+          <a:xfrm>
+            <a:off x="914400" y="3291840"/>
+            <a:ext cx="2926080" cy="868680"/>
           </a:xfrm>
           <a:prstGeom prst="rect">
             <a:avLst/>
@@ -7205,72 +7338,43 @@
               <a:buNone/>
             </a:pPr>
             <a:r>
-              <a:rPr lang="en-US" sz="1250" dirty="0">
+              <a:rPr lang="en-US" sz="1300" dirty="0">
                 <a:solidFill>
                   <a:schemeClr val="accent5"/>
                 </a:solidFill>
               </a:rPr>
-              <a:t>every α &gt; 0 loses</a:t>
-            </a:r>
-            <a:endParaRPr lang="en-US" sz="1250" dirty="0"/>
-          </a:p>
-        </p:txBody>
-      </p:sp>
-      <p:sp>
-        <p:nvSpPr>
-          <p:cNvPr id="6" name="neg-1"/>
+              <a:t>first implementation: sleepers frozen, awake group losing mass every round</a:t>
+            </a:r>
+            <a:endParaRPr lang="en-US" sz="1300" dirty="0"/>
+          </a:p>
+        </p:txBody>
+      </p:sp>
+      <p:sp>
+        <p:nvSpPr>
+          <p:cNvPr id="7" name="bound-1"/>
           <p:cNvSpPr/>
           <p:nvPr/>
         </p:nvSpPr>
         <p:spPr>
           <a:xfrm>
-            <a:off x="4297680" y="1719072"/>
-            <a:ext cx="237744" cy="237744"/>
-          </a:xfrm>
-          <a:prstGeom prst="ellipse">
-            <a:avLst/>
+            <a:off x="4297680" y="2194560"/>
+            <a:ext cx="3429000" cy="2103120"/>
+          </a:xfrm>
+          <a:prstGeom prst="roundRect">
+            <a:avLst>
+              <a:gd name="adj" fmla="val 3478"/>
+            </a:avLst>
           </a:prstGeom>
           <a:solidFill>
-            <a:schemeClr val="accent4"/>
+            <a:srgbClr val="F2F5F9"/>
           </a:solidFill>
-          <a:ln/>
-        </p:spPr>
-      </p:sp>
-      <p:sp>
-        <p:nvSpPr>
-          <p:cNvPr id="7" name="Text 5"/>
-          <p:cNvSpPr txBox="1"/>
-          <p:nvPr/>
-        </p:nvSpPr>
-        <p:spPr>
-          <a:xfrm>
-            <a:off x="4681728" y="1645920"/>
-            <a:ext cx="3017520" cy="548640"/>
-          </a:xfrm>
-          <a:prstGeom prst="rect">
-            <a:avLst/>
-          </a:prstGeom>
-          <a:noFill/>
-          <a:ln/>
-        </p:spPr>
-        <p:txBody>
-          <a:bodyPr wrap="square" lIns="0" tIns="0" rIns="0" bIns="0" rtlCol="0" anchor="t"/>
-          <a:lstStyle/>
-          <a:p>
-            <a:pPr indent="0" marL="0">
-              <a:buNone/>
-            </a:pPr>
-            <a:r>
-              <a:rPr lang="en-US" sz="1500" b="1" dirty="0">
-                <a:solidFill>
-                  <a:schemeClr val="tx2"/>
-                </a:solidFill>
-              </a:rPr>
-              <a:t>Per-expert step clock</a:t>
-            </a:r>
-            <a:endParaRPr lang="en-US" sz="1500" dirty="0"/>
-          </a:p>
-        </p:txBody>
+          <a:ln w="12700">
+            <a:solidFill>
+              <a:srgbClr val="E2E8F0"/>
+            </a:solidFill>
+            <a:prstDash val="solid"/>
+          </a:ln>
+        </p:spPr>
       </p:sp>
       <p:sp>
         <p:nvSpPr>
@@ -7280,8 +7384,44 @@
         </p:nvSpPr>
         <p:spPr>
           <a:xfrm>
-            <a:off x="4681728" y="2212848"/>
-            <a:ext cx="3017520" cy="640080"/>
+            <a:off x="4572000" y="2377440"/>
+            <a:ext cx="2926080" cy="822960"/>
+          </a:xfrm>
+          <a:prstGeom prst="rect">
+            <a:avLst/>
+          </a:prstGeom>
+          <a:noFill/>
+          <a:ln/>
+        </p:spPr>
+        <p:txBody>
+          <a:bodyPr wrap="square" lIns="0" tIns="0" rIns="0" bIns="0" rtlCol="0" anchor="b"/>
+          <a:lstStyle/>
+          <a:p>
+            <a:pPr indent="0" marL="0">
+              <a:buNone/>
+            </a:pPr>
+            <a:r>
+              <a:rPr lang="en-US" sz="4400" b="1" dirty="0">
+                <a:solidFill>
+                  <a:schemeClr val="accent5"/>
+                </a:solidFill>
+              </a:rPr>
+              <a:t>3.26</a:t>
+            </a:r>
+            <a:endParaRPr lang="en-US" sz="4400" dirty="0"/>
+          </a:p>
+        </p:txBody>
+      </p:sp>
+      <p:sp>
+        <p:nvSpPr>
+          <p:cNvPr id="9" name="Text 7"/>
+          <p:cNvSpPr txBox="1"/>
+          <p:nvPr/>
+        </p:nvSpPr>
+        <p:spPr>
+          <a:xfrm>
+            <a:off x="4572000" y="3291840"/>
+            <a:ext cx="2926080" cy="868680"/>
           </a:xfrm>
           <a:prstGeom prst="rect">
             <a:avLst/>
@@ -7297,72 +7437,43 @@
               <a:buNone/>
             </a:pPr>
             <a:r>
-              <a:rPr lang="en-US" sz="1250" dirty="0">
+              <a:rPr lang="en-US" sz="1300" dirty="0">
                 <a:solidFill>
                   <a:schemeClr val="accent5"/>
                 </a:solidFill>
               </a:rPr>
-              <a:t>−0.00073 on the tail: overfitting</a:t>
-            </a:r>
-            <a:endParaRPr lang="en-US" sz="1250" dirty="0"/>
-          </a:p>
-        </p:txBody>
-      </p:sp>
-      <p:sp>
-        <p:nvSpPr>
-          <p:cNvPr id="9" name="neg-2"/>
+              <a:t>the bound</a:t>
+            </a:r>
+            <a:endParaRPr lang="en-US" sz="1300" dirty="0"/>
+          </a:p>
+        </p:txBody>
+      </p:sp>
+      <p:sp>
+        <p:nvSpPr>
+          <p:cNvPr id="10" name="bound-2"/>
           <p:cNvSpPr/>
           <p:nvPr/>
         </p:nvSpPr>
         <p:spPr>
           <a:xfrm>
-            <a:off x="7955280" y="1719072"/>
-            <a:ext cx="237744" cy="237744"/>
-          </a:xfrm>
-          <a:prstGeom prst="ellipse">
-            <a:avLst/>
+            <a:off x="7955280" y="2194560"/>
+            <a:ext cx="3429000" cy="2103120"/>
+          </a:xfrm>
+          <a:prstGeom prst="roundRect">
+            <a:avLst>
+              <a:gd name="adj" fmla="val 3478"/>
+            </a:avLst>
           </a:prstGeom>
           <a:solidFill>
-            <a:schemeClr val="accent4"/>
+            <a:srgbClr val="F2F5F9"/>
           </a:solidFill>
-          <a:ln/>
-        </p:spPr>
-      </p:sp>
-      <p:sp>
-        <p:nvSpPr>
-          <p:cNvPr id="10" name="Text 8"/>
-          <p:cNvSpPr txBox="1"/>
-          <p:nvPr/>
-        </p:nvSpPr>
-        <p:spPr>
-          <a:xfrm>
-            <a:off x="8339328" y="1645920"/>
-            <a:ext cx="3017520" cy="548640"/>
-          </a:xfrm>
-          <a:prstGeom prst="rect">
-            <a:avLst/>
-          </a:prstGeom>
-          <a:noFill/>
-          <a:ln/>
-        </p:spPr>
-        <p:txBody>
-          <a:bodyPr wrap="square" lIns="0" tIns="0" rIns="0" bIns="0" rtlCol="0" anchor="t"/>
-          <a:lstStyle/>
-          <a:p>
-            <a:pPr indent="0" marL="0">
-              <a:buNone/>
-            </a:pPr>
-            <a:r>
-              <a:rPr lang="en-US" sz="1500" b="1" dirty="0">
-                <a:solidFill>
-                  <a:schemeClr val="tx2"/>
-                </a:solidFill>
-              </a:rPr>
-              <a:t>Markov kernels on the weights</a:t>
-            </a:r>
-            <a:endParaRPr lang="en-US" sz="1500" dirty="0"/>
-          </a:p>
-        </p:txBody>
+          <a:ln w="12700">
+            <a:solidFill>
+              <a:srgbClr val="E2E8F0"/>
+            </a:solidFill>
+            <a:prstDash val="solid"/>
+          </a:ln>
+        </p:spPr>
       </p:sp>
       <p:sp>
         <p:nvSpPr>
@@ -7372,8 +7483,44 @@
         </p:nvSpPr>
         <p:spPr>
           <a:xfrm>
-            <a:off x="8339328" y="2212848"/>
-            <a:ext cx="3017520" cy="640080"/>
+            <a:off x="8229600" y="2377440"/>
+            <a:ext cx="2926080" cy="822960"/>
+          </a:xfrm>
+          <a:prstGeom prst="rect">
+            <a:avLst/>
+          </a:prstGeom>
+          <a:noFill/>
+          <a:ln/>
+        </p:spPr>
+        <p:txBody>
+          <a:bodyPr wrap="square" lIns="0" tIns="0" rIns="0" bIns="0" rtlCol="0" anchor="b"/>
+          <a:lstStyle/>
+          <a:p>
+            <a:pPr indent="0" marL="0">
+              <a:buNone/>
+            </a:pPr>
+            <a:r>
+              <a:rPr lang="en-US" sz="4400" b="1" dirty="0">
+                <a:solidFill>
+                  <a:schemeClr val="accent3"/>
+                </a:solidFill>
+              </a:rPr>
+              <a:t>1.8</a:t>
+            </a:r>
+            <a:endParaRPr lang="en-US" sz="4400" dirty="0"/>
+          </a:p>
+        </p:txBody>
+      </p:sp>
+      <p:sp>
+        <p:nvSpPr>
+          <p:cNvPr id="12" name="Text 10"/>
+          <p:cNvSpPr txBox="1"/>
+          <p:nvPr/>
+        </p:nvSpPr>
+        <p:spPr>
+          <a:xfrm>
+            <a:off x="8229600" y="3291840"/>
+            <a:ext cx="2926080" cy="868680"/>
           </a:xfrm>
           <a:prstGeom prst="rect">
             <a:avLst/>
@@ -7389,36 +7536,16 @@
               <a:buNone/>
             </a:pPr>
             <a:r>
-              <a:rPr lang="en-US" sz="1250" dirty="0">
+              <a:rPr lang="en-US" sz="1300" dirty="0">
                 <a:solidFill>
                   <a:schemeClr val="accent5"/>
                 </a:solidFill>
               </a:rPr>
-              <a:t>every kernel selects α = 0</a:t>
-            </a:r>
-            <a:endParaRPr lang="en-US" sz="1250" dirty="0"/>
-          </a:p>
-        </p:txBody>
-      </p:sp>
-      <p:sp>
-        <p:nvSpPr>
-          <p:cNvPr id="12" name="neg-3"/>
-          <p:cNvSpPr/>
-          <p:nvPr/>
-        </p:nvSpPr>
-        <p:spPr>
-          <a:xfrm>
-            <a:off x="640080" y="3090672"/>
-            <a:ext cx="237744" cy="237744"/>
-          </a:xfrm>
-          <a:prstGeom prst="ellipse">
-            <a:avLst/>
-          </a:prstGeom>
-          <a:solidFill>
-            <a:schemeClr val="accent4"/>
-          </a:solidFill>
-          <a:ln/>
-        </p:spPr>
+              <a:t>specialists update: the awake group keeps its total mass</a:t>
+            </a:r>
+            <a:endParaRPr lang="en-US" sz="1300" dirty="0"/>
+          </a:p>
+        </p:txBody>
       </p:sp>
       <p:sp>
         <p:nvSpPr>
@@ -7428,17 +7555,17 @@
         </p:nvSpPr>
         <p:spPr>
           <a:xfrm>
-            <a:off x="1024128" y="3017520"/>
-            <a:ext cx="3017520" cy="548640"/>
-          </a:xfrm>
-          <a:prstGeom prst="rect">
-            <a:avLst/>
-          </a:prstGeom>
-          <a:noFill/>
-          <a:ln/>
-        </p:spPr>
-        <p:txBody>
-          <a:bodyPr wrap="square" lIns="0" tIns="0" rIns="0" bIns="0" rtlCol="0" anchor="t"/>
+            <a:off x="640080" y="4617720"/>
+            <a:ext cx="10881360" cy="731520"/>
+          </a:xfrm>
+          <a:prstGeom prst="rect">
+            <a:avLst/>
+          </a:prstGeom>
+          <a:noFill/>
+          <a:ln/>
+        </p:spPr>
+        <p:txBody>
+          <a:bodyPr wrap="square" rtlCol="0" anchor="ctr"/>
           <a:lstStyle/>
           <a:p>
             <a:pPr indent="0" marL="0">
@@ -7450,7 +7577,7 @@
                   <a:schemeClr val="tx2"/>
                 </a:solidFill>
               </a:rPr>
-              <a:t>Latent market regimes</a:t>
+              <a:t>A one-line difference, invisible whenever nobody is asleep. Fixed, Hedge goes from third to first and draws level with Pinnacle over the whole decade.</a:t>
             </a:r>
             <a:endParaRPr lang="en-US" sz="1500" dirty="0"/>
           </a:p>
@@ -7464,527 +7591,31 @@
         </p:nvSpPr>
         <p:spPr>
           <a:xfrm>
-            <a:off x="1024128" y="3584448"/>
-            <a:ext cx="3017520" cy="640080"/>
-          </a:xfrm>
-          <a:prstGeom prst="rect">
-            <a:avLst/>
-          </a:prstGeom>
-          <a:noFill/>
-          <a:ln/>
-        </p:spPr>
-        <p:txBody>
-          <a:bodyPr wrap="square" lIns="0" tIns="0" rIns="0" bIns="0" rtlCol="0" anchor="t"/>
+            <a:off x="640080" y="5440680"/>
+            <a:ext cx="10881360" cy="320040"/>
+          </a:xfrm>
+          <a:prstGeom prst="rect">
+            <a:avLst/>
+          </a:prstGeom>
+          <a:noFill/>
+          <a:ln/>
+        </p:spPr>
+        <p:txBody>
+          <a:bodyPr wrap="square" rtlCol="0" anchor="ctr"/>
           <a:lstStyle/>
           <a:p>
             <a:pPr indent="0" marL="0">
               <a:buNone/>
             </a:pPr>
             <a:r>
-              <a:rPr lang="en-US" sz="1250" dirty="0">
+              <a:rPr lang="en-US" sz="1200" i="1" dirty="0">
                 <a:solidFill>
                   <a:schemeClr val="accent5"/>
                 </a:solidFill>
               </a:rPr>
-              <a:t>belief sd 0.0000: it does nothing</a:t>
-            </a:r>
-            <a:endParaRPr lang="en-US" sz="1250" dirty="0"/>
-          </a:p>
-        </p:txBody>
-      </p:sp>
-      <p:sp>
-        <p:nvSpPr>
-          <p:cNvPr id="15" name="neg-4"/>
-          <p:cNvSpPr/>
-          <p:nvPr/>
-        </p:nvSpPr>
-        <p:spPr>
-          <a:xfrm>
-            <a:off x="4297680" y="3090672"/>
-            <a:ext cx="237744" cy="237744"/>
-          </a:xfrm>
-          <a:prstGeom prst="ellipse">
-            <a:avLst/>
-          </a:prstGeom>
-          <a:solidFill>
-            <a:schemeClr val="accent4"/>
-          </a:solidFill>
-          <a:ln/>
-        </p:spPr>
-      </p:sp>
-      <p:sp>
-        <p:nvSpPr>
-          <p:cNvPr id="16" name="Text 14"/>
-          <p:cNvSpPr txBox="1"/>
-          <p:nvPr/>
-        </p:nvSpPr>
-        <p:spPr>
-          <a:xfrm>
-            <a:off x="4681728" y="3017520"/>
-            <a:ext cx="3017520" cy="548640"/>
-          </a:xfrm>
-          <a:prstGeom prst="rect">
-            <a:avLst/>
-          </a:prstGeom>
-          <a:noFill/>
-          <a:ln/>
-        </p:spPr>
-        <p:txBody>
-          <a:bodyPr wrap="square" lIns="0" tIns="0" rIns="0" bIns="0" rtlCol="0" anchor="t"/>
-          <a:lstStyle/>
-          <a:p>
-            <a:pPr indent="0" marL="0">
-              <a:buNone/>
-            </a:pPr>
-            <a:r>
-              <a:rPr lang="en-US" sz="1500" b="1" dirty="0">
-                <a:solidFill>
-                  <a:schemeClr val="tx2"/>
-                </a:solidFill>
-              </a:rPr>
-              <a:t>Bandit, one-point estimator</a:t>
-            </a:r>
-            <a:endParaRPr lang="en-US" sz="1500" dirty="0"/>
-          </a:p>
-        </p:txBody>
-      </p:sp>
-      <p:sp>
-        <p:nvSpPr>
-          <p:cNvPr id="17" name="Text 15"/>
-          <p:cNvSpPr txBox="1"/>
-          <p:nvPr/>
-        </p:nvSpPr>
-        <p:spPr>
-          <a:xfrm>
-            <a:off x="4681728" y="3584448"/>
-            <a:ext cx="3017520" cy="640080"/>
-          </a:xfrm>
-          <a:prstGeom prst="rect">
-            <a:avLst/>
-          </a:prstGeom>
-          <a:noFill/>
-          <a:ln/>
-        </p:spPr>
-        <p:txBody>
-          <a:bodyPr wrap="square" lIns="0" tIns="0" rIns="0" bIns="0" rtlCol="0" anchor="t"/>
-          <a:lstStyle/>
-          <a:p>
-            <a:pPr indent="0" marL="0">
-              <a:buNone/>
-            </a:pPr>
-            <a:r>
-              <a:rPr lang="en-US" sz="1250" dirty="0">
-                <a:solidFill>
-                  <a:schemeClr val="accent5"/>
-                </a:solidFill>
-              </a:rPr>
-              <a:t>the horizon is too short</a:t>
-            </a:r>
-            <a:endParaRPr lang="en-US" sz="1250" dirty="0"/>
-          </a:p>
-        </p:txBody>
-      </p:sp>
-      <p:sp>
-        <p:nvSpPr>
-          <p:cNvPr id="18" name="neg-5"/>
-          <p:cNvSpPr/>
-          <p:nvPr/>
-        </p:nvSpPr>
-        <p:spPr>
-          <a:xfrm>
-            <a:off x="7955280" y="3090672"/>
-            <a:ext cx="237744" cy="237744"/>
-          </a:xfrm>
-          <a:prstGeom prst="ellipse">
-            <a:avLst/>
-          </a:prstGeom>
-          <a:solidFill>
-            <a:schemeClr val="accent4"/>
-          </a:solidFill>
-          <a:ln/>
-        </p:spPr>
-      </p:sp>
-      <p:sp>
-        <p:nvSpPr>
-          <p:cNvPr id="19" name="Text 17"/>
-          <p:cNvSpPr txBox="1"/>
-          <p:nvPr/>
-        </p:nvSpPr>
-        <p:spPr>
-          <a:xfrm>
-            <a:off x="8339328" y="3017520"/>
-            <a:ext cx="3017520" cy="548640"/>
-          </a:xfrm>
-          <a:prstGeom prst="rect">
-            <a:avLst/>
-          </a:prstGeom>
-          <a:noFill/>
-          <a:ln/>
-        </p:spPr>
-        <p:txBody>
-          <a:bodyPr wrap="square" lIns="0" tIns="0" rIns="0" bIns="0" rtlCol="0" anchor="t"/>
-          <a:lstStyle/>
-          <a:p>
-            <a:pPr indent="0" marL="0">
-              <a:buNone/>
-            </a:pPr>
-            <a:r>
-              <a:rPr lang="en-US" sz="1500" b="1" dirty="0">
-                <a:solidFill>
-                  <a:schemeClr val="tx2"/>
-                </a:solidFill>
-              </a:rPr>
-              <a:t>Bayesian / MCMC Kelly</a:t>
-            </a:r>
-            <a:endParaRPr lang="en-US" sz="1500" dirty="0"/>
-          </a:p>
-        </p:txBody>
-      </p:sp>
-      <p:sp>
-        <p:nvSpPr>
-          <p:cNvPr id="20" name="Text 18"/>
-          <p:cNvSpPr txBox="1"/>
-          <p:nvPr/>
-        </p:nvSpPr>
-        <p:spPr>
-          <a:xfrm>
-            <a:off x="8339328" y="3584448"/>
-            <a:ext cx="3017520" cy="640080"/>
-          </a:xfrm>
-          <a:prstGeom prst="rect">
-            <a:avLst/>
-          </a:prstGeom>
-          <a:noFill/>
-          <a:ln/>
-        </p:spPr>
-        <p:txBody>
-          <a:bodyPr wrap="square" lIns="0" tIns="0" rIns="0" bIns="0" rtlCol="0" anchor="t"/>
-          <a:lstStyle/>
-          <a:p>
-            <a:pPr indent="0" marL="0">
-              <a:buNone/>
-            </a:pPr>
-            <a:r>
-              <a:rPr lang="en-US" sz="1250" dirty="0">
-                <a:solidFill>
-                  <a:schemeClr val="accent5"/>
-                </a:solidFill>
-              </a:rPr>
-              <a:t>6 ties, 2 losses, zero wins</a:t>
-            </a:r>
-            <a:endParaRPr lang="en-US" sz="1250" dirty="0"/>
-          </a:p>
-        </p:txBody>
-      </p:sp>
-      <p:sp>
-        <p:nvSpPr>
-          <p:cNvPr id="21" name="neg-6"/>
-          <p:cNvSpPr/>
-          <p:nvPr/>
-        </p:nvSpPr>
-        <p:spPr>
-          <a:xfrm>
-            <a:off x="640080" y="4462272"/>
-            <a:ext cx="237744" cy="237744"/>
-          </a:xfrm>
-          <a:prstGeom prst="ellipse">
-            <a:avLst/>
-          </a:prstGeom>
-          <a:solidFill>
-            <a:schemeClr val="accent4"/>
-          </a:solidFill>
-          <a:ln/>
-        </p:spPr>
-      </p:sp>
-      <p:sp>
-        <p:nvSpPr>
-          <p:cNvPr id="22" name="Text 20"/>
-          <p:cNvSpPr txBox="1"/>
-          <p:nvPr/>
-        </p:nvSpPr>
-        <p:spPr>
-          <a:xfrm>
-            <a:off x="1024128" y="4389120"/>
-            <a:ext cx="3017520" cy="548640"/>
-          </a:xfrm>
-          <a:prstGeom prst="rect">
-            <a:avLst/>
-          </a:prstGeom>
-          <a:noFill/>
-          <a:ln/>
-        </p:spPr>
-        <p:txBody>
-          <a:bodyPr wrap="square" lIns="0" tIns="0" rIns="0" bIns="0" rtlCol="0" anchor="t"/>
-          <a:lstStyle/>
-          <a:p>
-            <a:pPr indent="0" marL="0">
-              <a:buNone/>
-            </a:pPr>
-            <a:r>
-              <a:rPr lang="en-US" sz="1500" b="1" dirty="0">
-                <a:solidFill>
-                  <a:schemeClr val="tx2"/>
-                </a:solidFill>
-              </a:rPr>
-              <a:t>Per-league specialisation</a:t>
-            </a:r>
-            <a:endParaRPr lang="en-US" sz="1500" dirty="0"/>
-          </a:p>
-        </p:txBody>
-      </p:sp>
-      <p:sp>
-        <p:nvSpPr>
-          <p:cNvPr id="23" name="Text 21"/>
-          <p:cNvSpPr txBox="1"/>
-          <p:nvPr/>
-        </p:nvSpPr>
-        <p:spPr>
-          <a:xfrm>
-            <a:off x="1024128" y="4956048"/>
-            <a:ext cx="3017520" cy="640080"/>
-          </a:xfrm>
-          <a:prstGeom prst="rect">
-            <a:avLst/>
-          </a:prstGeom>
-          <a:noFill/>
-          <a:ln/>
-        </p:spPr>
-        <p:txBody>
-          <a:bodyPr wrap="square" lIns="0" tIns="0" rIns="0" bIns="0" rtlCol="0" anchor="t"/>
-          <a:lstStyle/>
-          <a:p>
-            <a:pPr indent="0" marL="0">
-              <a:buNone/>
-            </a:pPr>
-            <a:r>
-              <a:rPr lang="en-US" sz="1250" dirty="0">
-                <a:solidFill>
-                  <a:schemeClr val="accent5"/>
-                </a:solidFill>
-              </a:rPr>
-              <a:t>loses in all six leagues</a:t>
-            </a:r>
-            <a:endParaRPr lang="en-US" sz="1250" dirty="0"/>
-          </a:p>
-        </p:txBody>
-      </p:sp>
-      <p:sp>
-        <p:nvSpPr>
-          <p:cNvPr id="24" name="neg-7"/>
-          <p:cNvSpPr/>
-          <p:nvPr/>
-        </p:nvSpPr>
-        <p:spPr>
-          <a:xfrm>
-            <a:off x="4297680" y="4462272"/>
-            <a:ext cx="237744" cy="237744"/>
-          </a:xfrm>
-          <a:prstGeom prst="ellipse">
-            <a:avLst/>
-          </a:prstGeom>
-          <a:solidFill>
-            <a:schemeClr val="accent4"/>
-          </a:solidFill>
-          <a:ln/>
-        </p:spPr>
-      </p:sp>
-      <p:sp>
-        <p:nvSpPr>
-          <p:cNvPr id="25" name="Text 23"/>
-          <p:cNvSpPr txBox="1"/>
-          <p:nvPr/>
-        </p:nvSpPr>
-        <p:spPr>
-          <a:xfrm>
-            <a:off x="4681728" y="4389120"/>
-            <a:ext cx="3017520" cy="548640"/>
-          </a:xfrm>
-          <a:prstGeom prst="rect">
-            <a:avLst/>
-          </a:prstGeom>
-          <a:noFill/>
-          <a:ln/>
-        </p:spPr>
-        <p:txBody>
-          <a:bodyPr wrap="square" lIns="0" tIns="0" rIns="0" bIns="0" rtlCol="0" anchor="t"/>
-          <a:lstStyle/>
-          <a:p>
-            <a:pPr indent="0" marL="0">
-              <a:buNone/>
-            </a:pPr>
-            <a:r>
-              <a:rPr lang="en-US" sz="1500" b="1" dirty="0">
-                <a:solidFill>
-                  <a:schemeClr val="tx2"/>
-                </a:solidFill>
-              </a:rPr>
-              <a:t>AdaGrad</a:t>
-            </a:r>
-            <a:endParaRPr lang="en-US" sz="1500" dirty="0"/>
-          </a:p>
-        </p:txBody>
-      </p:sp>
-      <p:sp>
-        <p:nvSpPr>
-          <p:cNvPr id="26" name="Text 24"/>
-          <p:cNvSpPr txBox="1"/>
-          <p:nvPr/>
-        </p:nvSpPr>
-        <p:spPr>
-          <a:xfrm>
-            <a:off x="4681728" y="4956048"/>
-            <a:ext cx="3017520" cy="640080"/>
-          </a:xfrm>
-          <a:prstGeom prst="rect">
-            <a:avLst/>
-          </a:prstGeom>
-          <a:noFill/>
-          <a:ln/>
-        </p:spPr>
-        <p:txBody>
-          <a:bodyPr wrap="square" lIns="0" tIns="0" rIns="0" bIns="0" rtlCol="0" anchor="t"/>
-          <a:lstStyle/>
-          <a:p>
-            <a:pPr indent="0" marL="0">
-              <a:buNone/>
-            </a:pPr>
-            <a:r>
-              <a:rPr lang="en-US" sz="1250" dirty="0">
-                <a:solidFill>
-                  <a:schemeClr val="accent5"/>
-                </a:solidFill>
-              </a:rPr>
-              <a:t>recovers 20% at best</a:t>
-            </a:r>
-            <a:endParaRPr lang="en-US" sz="1250" dirty="0"/>
-          </a:p>
-        </p:txBody>
-      </p:sp>
-      <p:sp>
-        <p:nvSpPr>
-          <p:cNvPr id="27" name="neg-8"/>
-          <p:cNvSpPr/>
-          <p:nvPr/>
-        </p:nvSpPr>
-        <p:spPr>
-          <a:xfrm>
-            <a:off x="7955280" y="4462272"/>
-            <a:ext cx="237744" cy="237744"/>
-          </a:xfrm>
-          <a:prstGeom prst="ellipse">
-            <a:avLst/>
-          </a:prstGeom>
-          <a:solidFill>
-            <a:schemeClr val="accent4"/>
-          </a:solidFill>
-          <a:ln/>
-        </p:spPr>
-      </p:sp>
-      <p:sp>
-        <p:nvSpPr>
-          <p:cNvPr id="28" name="Text 26"/>
-          <p:cNvSpPr txBox="1"/>
-          <p:nvPr/>
-        </p:nvSpPr>
-        <p:spPr>
-          <a:xfrm>
-            <a:off x="8339328" y="4389120"/>
-            <a:ext cx="3017520" cy="548640"/>
-          </a:xfrm>
-          <a:prstGeom prst="rect">
-            <a:avLst/>
-          </a:prstGeom>
-          <a:noFill/>
-          <a:ln/>
-        </p:spPr>
-        <p:txBody>
-          <a:bodyPr wrap="square" lIns="0" tIns="0" rIns="0" bIns="0" rtlCol="0" anchor="t"/>
-          <a:lstStyle/>
-          <a:p>
-            <a:pPr indent="0" marL="0">
-              <a:buNone/>
-            </a:pPr>
-            <a:r>
-              <a:rPr lang="en-US" sz="1500" b="1" dirty="0">
-                <a:solidFill>
-                  <a:schemeClr val="tx2"/>
-                </a:solidFill>
-              </a:rPr>
-              <a:t>Joint step + calibration sweep</a:t>
-            </a:r>
-            <a:endParaRPr lang="en-US" sz="1500" dirty="0"/>
-          </a:p>
-        </p:txBody>
-      </p:sp>
-      <p:sp>
-        <p:nvSpPr>
-          <p:cNvPr id="29" name="Text 27"/>
-          <p:cNvSpPr txBox="1"/>
-          <p:nvPr/>
-        </p:nvSpPr>
-        <p:spPr>
-          <a:xfrm>
-            <a:off x="8339328" y="4956048"/>
-            <a:ext cx="3017520" cy="640080"/>
-          </a:xfrm>
-          <a:prstGeom prst="rect">
-            <a:avLst/>
-          </a:prstGeom>
-          <a:noFill/>
-          <a:ln/>
-        </p:spPr>
-        <p:txBody>
-          <a:bodyPr wrap="square" lIns="0" tIns="0" rIns="0" bIns="0" rtlCol="0" anchor="t"/>
-          <a:lstStyle/>
-          <a:p>
-            <a:pPr indent="0" marL="0">
-              <a:buNone/>
-            </a:pPr>
-            <a:r>
-              <a:rPr lang="en-US" sz="1250" dirty="0">
-                <a:solidFill>
-                  <a:schemeClr val="accent5"/>
-                </a:solidFill>
-              </a:rPr>
-              <a:t>no interaction at all</a:t>
-            </a:r>
-            <a:endParaRPr lang="en-US" sz="1250" dirty="0"/>
-          </a:p>
-        </p:txBody>
-      </p:sp>
-      <p:sp>
-        <p:nvSpPr>
-          <p:cNvPr id="30" name="Text 28"/>
-          <p:cNvSpPr txBox="1"/>
-          <p:nvPr/>
-        </p:nvSpPr>
-        <p:spPr>
-          <a:xfrm>
-            <a:off x="640080" y="5852160"/>
-            <a:ext cx="10881360" cy="640080"/>
-          </a:xfrm>
-          <a:prstGeom prst="rect">
-            <a:avLst/>
-          </a:prstGeom>
-          <a:noFill/>
-          <a:ln/>
-        </p:spPr>
-        <p:txBody>
-          <a:bodyPr wrap="square" rtlCol="0" anchor="ctr"/>
-          <a:lstStyle/>
-          <a:p>
-            <a:pPr indent="0" marL="0">
-              <a:buNone/>
-            </a:pPr>
-            <a:r>
-              <a:rPr lang="en-US" sz="1500" dirty="0">
-                <a:solidFill>
-                  <a:schemeClr val="tx1"/>
-                </a:solidFill>
-              </a:rPr>
-              <a:t>One pattern unites them: once the step size is tuned, no further movement of mass over the experts buys anything. The step and the leak control the same quantity.</a:t>
-            </a:r>
-            <a:endParaRPr lang="en-US" sz="1500" dirty="0"/>
+              <a:t>excess over PSC on PSC's own rounds, total nats, step 1</a:t>
+            </a:r>
+            <a:endParaRPr lang="en-US" sz="1200" dirty="0"/>
           </a:p>
         </p:txBody>
       </p:sp>
@@ -8090,7 +7721,7 @@
                   <a:schemeClr val="tx2"/>
                 </a:solidFill>
               </a:rPr>
-              <a:t>Conclusions</a:t>
+              <a:t>Nine ideas tried and rejected</a:t>
             </a:r>
             <a:endParaRPr lang="en-US" sz="3000" dirty="0"/>
           </a:p>
@@ -8098,198 +7729,14 @@
       </p:sp>
       <p:sp>
         <p:nvSpPr>
-          <p:cNvPr id="3" name="cc-0"/>
+          <p:cNvPr id="3" name="neg-0"/>
           <p:cNvSpPr/>
           <p:nvPr/>
         </p:nvSpPr>
         <p:spPr>
           <a:xfrm>
-            <a:off x="640080" y="1554480"/>
-            <a:ext cx="256032" cy="256032"/>
-          </a:xfrm>
-          <a:prstGeom prst="ellipse">
-            <a:avLst/>
-          </a:prstGeom>
-          <a:solidFill>
-            <a:schemeClr val="accent3"/>
-          </a:solidFill>
-          <a:ln/>
-        </p:spPr>
-      </p:sp>
-      <p:sp>
-        <p:nvSpPr>
-          <p:cNvPr id="4" name="Text 2"/>
-          <p:cNvSpPr txBox="1"/>
-          <p:nvPr/>
-        </p:nvSpPr>
-        <p:spPr>
-          <a:xfrm>
-            <a:off x="1078992" y="1463040"/>
-            <a:ext cx="3931920" cy="411480"/>
-          </a:xfrm>
-          <a:prstGeom prst="rect">
-            <a:avLst/>
-          </a:prstGeom>
-          <a:noFill/>
-          <a:ln/>
-        </p:spPr>
-        <p:txBody>
-          <a:bodyPr wrap="square" lIns="0" tIns="0" rIns="0" bIns="0" rtlCol="0" anchor="t"/>
-          <a:lstStyle/>
-          <a:p>
-            <a:pPr indent="0" marL="0">
-              <a:buNone/>
-            </a:pPr>
-            <a:r>
-              <a:rPr lang="en-US" sz="1600" b="1" dirty="0">
-                <a:solidFill>
-                  <a:schemeClr val="tx2"/>
-                </a:solidFill>
-              </a:rPr>
-              <a:t>The framework applies</a:t>
-            </a:r>
-            <a:endParaRPr lang="en-US" sz="1600" dirty="0"/>
-          </a:p>
-        </p:txBody>
-      </p:sp>
-      <p:sp>
-        <p:nvSpPr>
-          <p:cNvPr id="5" name="Text 3"/>
-          <p:cNvSpPr txBox="1"/>
-          <p:nvPr/>
-        </p:nvSpPr>
-        <p:spPr>
-          <a:xfrm>
-            <a:off x="5166360" y="1463040"/>
-            <a:ext cx="6355080" cy="777240"/>
-          </a:xfrm>
-          <a:prstGeom prst="rect">
-            <a:avLst/>
-          </a:prstGeom>
-          <a:noFill/>
-          <a:ln/>
-        </p:spPr>
-        <p:txBody>
-          <a:bodyPr wrap="square" lIns="0" tIns="0" rIns="0" bIns="0" rtlCol="0" anchor="t"/>
-          <a:lstStyle/>
-          <a:p>
-            <a:pPr indent="0" marL="0">
-              <a:buNone/>
-            </a:pPr>
-            <a:r>
-              <a:rPr lang="en-US" sz="1350" dirty="0">
-                <a:solidFill>
-                  <a:schemeClr val="accent5"/>
-                </a:solidFill>
-              </a:rPr>
-              <a:t>An online mixture of published odds beats the uniform average and almost every individual bookmaker, with no distributional assumption.</a:t>
-            </a:r>
-            <a:endParaRPr lang="en-US" sz="1350" dirty="0"/>
-          </a:p>
-        </p:txBody>
-      </p:sp>
-      <p:sp>
-        <p:nvSpPr>
-          <p:cNvPr id="6" name="cc-1"/>
-          <p:cNvSpPr/>
-          <p:nvPr/>
-        </p:nvSpPr>
-        <p:spPr>
-          <a:xfrm>
-            <a:off x="640080" y="2496312"/>
-            <a:ext cx="256032" cy="256032"/>
-          </a:xfrm>
-          <a:prstGeom prst="ellipse">
-            <a:avLst/>
-          </a:prstGeom>
-          <a:solidFill>
-            <a:schemeClr val="accent1"/>
-          </a:solidFill>
-          <a:ln/>
-        </p:spPr>
-      </p:sp>
-      <p:sp>
-        <p:nvSpPr>
-          <p:cNvPr id="7" name="Text 5"/>
-          <p:cNvSpPr txBox="1"/>
-          <p:nvPr/>
-        </p:nvSpPr>
-        <p:spPr>
-          <a:xfrm>
-            <a:off x="1078992" y="2404872"/>
-            <a:ext cx="3931920" cy="411480"/>
-          </a:xfrm>
-          <a:prstGeom prst="rect">
-            <a:avLst/>
-          </a:prstGeom>
-          <a:noFill/>
-          <a:ln/>
-        </p:spPr>
-        <p:txBody>
-          <a:bodyPr wrap="square" lIns="0" tIns="0" rIns="0" bIns="0" rtlCol="0" anchor="t"/>
-          <a:lstStyle/>
-          <a:p>
-            <a:pPr indent="0" marL="0">
-              <a:buNone/>
-            </a:pPr>
-            <a:r>
-              <a:rPr lang="en-US" sz="1600" b="1" dirty="0">
-                <a:solidFill>
-                  <a:schemeClr val="tx2"/>
-                </a:solidFill>
-              </a:rPr>
-              <a:t>It reaches the market's edge</a:t>
-            </a:r>
-            <a:endParaRPr lang="en-US" sz="1600" dirty="0"/>
-          </a:p>
-        </p:txBody>
-      </p:sp>
-      <p:sp>
-        <p:nvSpPr>
-          <p:cNvPr id="8" name="Text 6"/>
-          <p:cNvSpPr txBox="1"/>
-          <p:nvPr/>
-        </p:nvSpPr>
-        <p:spPr>
-          <a:xfrm>
-            <a:off x="5166360" y="2404872"/>
-            <a:ext cx="6355080" cy="777240"/>
-          </a:xfrm>
-          <a:prstGeom prst="rect">
-            <a:avLst/>
-          </a:prstGeom>
-          <a:noFill/>
-          <a:ln/>
-        </p:spPr>
-        <p:txBody>
-          <a:bodyPr wrap="square" lIns="0" tIns="0" rIns="0" bIns="0" rtlCol="0" anchor="t"/>
-          <a:lstStyle/>
-          <a:p>
-            <a:pPr indent="0" marL="0">
-              <a:buNone/>
-            </a:pPr>
-            <a:r>
-              <a:rPr lang="en-US" sz="1350" dirty="0">
-                <a:solidFill>
-                  <a:schemeClr val="accent5"/>
-                </a:solidFill>
-              </a:rPr>
-              <a:t>Level with the sharpest bookmaker, but behind an exchange with no operator margin.</a:t>
-            </a:r>
-            <a:endParaRPr lang="en-US" sz="1350" dirty="0"/>
-          </a:p>
-        </p:txBody>
-      </p:sp>
-      <p:sp>
-        <p:nvSpPr>
-          <p:cNvPr id="9" name="cc-2"/>
-          <p:cNvSpPr/>
-          <p:nvPr/>
-        </p:nvSpPr>
-        <p:spPr>
-          <a:xfrm>
-            <a:off x="640080" y="3438144"/>
-            <a:ext cx="256032" cy="256032"/>
+            <a:off x="640080" y="1719072"/>
+            <a:ext cx="237744" cy="237744"/>
           </a:xfrm>
           <a:prstGeom prst="ellipse">
             <a:avLst/>
@@ -8302,14 +7749,198 @@
       </p:sp>
       <p:sp>
         <p:nvSpPr>
+          <p:cNvPr id="4" name="Text 2"/>
+          <p:cNvSpPr txBox="1"/>
+          <p:nvPr/>
+        </p:nvSpPr>
+        <p:spPr>
+          <a:xfrm>
+            <a:off x="1024128" y="1645920"/>
+            <a:ext cx="3017520" cy="548640"/>
+          </a:xfrm>
+          <a:prstGeom prst="rect">
+            <a:avLst/>
+          </a:prstGeom>
+          <a:noFill/>
+          <a:ln/>
+        </p:spPr>
+        <p:txBody>
+          <a:bodyPr wrap="square" lIns="0" tIns="0" rIns="0" bIns="0" rtlCol="0" anchor="t"/>
+          <a:lstStyle/>
+          <a:p>
+            <a:pPr indent="0" marL="0">
+              <a:buNone/>
+            </a:pPr>
+            <a:r>
+              <a:rPr lang="en-US" sz="1500" b="1" dirty="0">
+                <a:solidFill>
+                  <a:schemeClr val="tx2"/>
+                </a:solidFill>
+              </a:rPr>
+              <a:t>Fixed-Share</a:t>
+            </a:r>
+            <a:endParaRPr lang="en-US" sz="1500" dirty="0"/>
+          </a:p>
+        </p:txBody>
+      </p:sp>
+      <p:sp>
+        <p:nvSpPr>
+          <p:cNvPr id="5" name="Text 3"/>
+          <p:cNvSpPr txBox="1"/>
+          <p:nvPr/>
+        </p:nvSpPr>
+        <p:spPr>
+          <a:xfrm>
+            <a:off x="1024128" y="2212848"/>
+            <a:ext cx="3017520" cy="640080"/>
+          </a:xfrm>
+          <a:prstGeom prst="rect">
+            <a:avLst/>
+          </a:prstGeom>
+          <a:noFill/>
+          <a:ln/>
+        </p:spPr>
+        <p:txBody>
+          <a:bodyPr wrap="square" lIns="0" tIns="0" rIns="0" bIns="0" rtlCol="0" anchor="t"/>
+          <a:lstStyle/>
+          <a:p>
+            <a:pPr indent="0" marL="0">
+              <a:buNone/>
+            </a:pPr>
+            <a:r>
+              <a:rPr lang="en-US" sz="1250" dirty="0">
+                <a:solidFill>
+                  <a:schemeClr val="accent5"/>
+                </a:solidFill>
+              </a:rPr>
+              <a:t>every α &gt; 0 loses</a:t>
+            </a:r>
+            <a:endParaRPr lang="en-US" sz="1250" dirty="0"/>
+          </a:p>
+        </p:txBody>
+      </p:sp>
+      <p:sp>
+        <p:nvSpPr>
+          <p:cNvPr id="6" name="neg-1"/>
+          <p:cNvSpPr/>
+          <p:nvPr/>
+        </p:nvSpPr>
+        <p:spPr>
+          <a:xfrm>
+            <a:off x="4297680" y="1719072"/>
+            <a:ext cx="237744" cy="237744"/>
+          </a:xfrm>
+          <a:prstGeom prst="ellipse">
+            <a:avLst/>
+          </a:prstGeom>
+          <a:solidFill>
+            <a:schemeClr val="accent4"/>
+          </a:solidFill>
+          <a:ln/>
+        </p:spPr>
+      </p:sp>
+      <p:sp>
+        <p:nvSpPr>
+          <p:cNvPr id="7" name="Text 5"/>
+          <p:cNvSpPr txBox="1"/>
+          <p:nvPr/>
+        </p:nvSpPr>
+        <p:spPr>
+          <a:xfrm>
+            <a:off x="4681728" y="1645920"/>
+            <a:ext cx="3017520" cy="548640"/>
+          </a:xfrm>
+          <a:prstGeom prst="rect">
+            <a:avLst/>
+          </a:prstGeom>
+          <a:noFill/>
+          <a:ln/>
+        </p:spPr>
+        <p:txBody>
+          <a:bodyPr wrap="square" lIns="0" tIns="0" rIns="0" bIns="0" rtlCol="0" anchor="t"/>
+          <a:lstStyle/>
+          <a:p>
+            <a:pPr indent="0" marL="0">
+              <a:buNone/>
+            </a:pPr>
+            <a:r>
+              <a:rPr lang="en-US" sz="1500" b="1" dirty="0">
+                <a:solidFill>
+                  <a:schemeClr val="tx2"/>
+                </a:solidFill>
+              </a:rPr>
+              <a:t>Per-expert step clock</a:t>
+            </a:r>
+            <a:endParaRPr lang="en-US" sz="1500" dirty="0"/>
+          </a:p>
+        </p:txBody>
+      </p:sp>
+      <p:sp>
+        <p:nvSpPr>
+          <p:cNvPr id="8" name="Text 6"/>
+          <p:cNvSpPr txBox="1"/>
+          <p:nvPr/>
+        </p:nvSpPr>
+        <p:spPr>
+          <a:xfrm>
+            <a:off x="4681728" y="2212848"/>
+            <a:ext cx="3017520" cy="640080"/>
+          </a:xfrm>
+          <a:prstGeom prst="rect">
+            <a:avLst/>
+          </a:prstGeom>
+          <a:noFill/>
+          <a:ln/>
+        </p:spPr>
+        <p:txBody>
+          <a:bodyPr wrap="square" lIns="0" tIns="0" rIns="0" bIns="0" rtlCol="0" anchor="t"/>
+          <a:lstStyle/>
+          <a:p>
+            <a:pPr indent="0" marL="0">
+              <a:buNone/>
+            </a:pPr>
+            <a:r>
+              <a:rPr lang="en-US" sz="1250" dirty="0">
+                <a:solidFill>
+                  <a:schemeClr val="accent5"/>
+                </a:solidFill>
+              </a:rPr>
+              <a:t>−0.00073 on the tail: overfitting</a:t>
+            </a:r>
+            <a:endParaRPr lang="en-US" sz="1250" dirty="0"/>
+          </a:p>
+        </p:txBody>
+      </p:sp>
+      <p:sp>
+        <p:nvSpPr>
+          <p:cNvPr id="9" name="neg-2"/>
+          <p:cNvSpPr/>
+          <p:nvPr/>
+        </p:nvSpPr>
+        <p:spPr>
+          <a:xfrm>
+            <a:off x="7955280" y="1719072"/>
+            <a:ext cx="237744" cy="237744"/>
+          </a:xfrm>
+          <a:prstGeom prst="ellipse">
+            <a:avLst/>
+          </a:prstGeom>
+          <a:solidFill>
+            <a:schemeClr val="accent4"/>
+          </a:solidFill>
+          <a:ln/>
+        </p:spPr>
+      </p:sp>
+      <p:sp>
+        <p:nvSpPr>
           <p:cNvPr id="10" name="Text 8"/>
           <p:cNvSpPr txBox="1"/>
           <p:nvPr/>
         </p:nvSpPr>
         <p:spPr>
           <a:xfrm>
-            <a:off x="1078992" y="3346704"/>
-            <a:ext cx="3931920" cy="411480"/>
+            <a:off x="8339328" y="1645920"/>
+            <a:ext cx="3017520" cy="548640"/>
           </a:xfrm>
           <a:prstGeom prst="rect">
             <a:avLst/>
@@ -8325,14 +7956,14 @@
               <a:buNone/>
             </a:pPr>
             <a:r>
-              <a:rPr lang="en-US" sz="1600" b="1" dirty="0">
+              <a:rPr lang="en-US" sz="1500" b="1" dirty="0">
                 <a:solidFill>
                   <a:schemeClr val="tx2"/>
                 </a:solidFill>
               </a:rPr>
-              <a:t>Part of the gain is geometry</a:t>
-            </a:r>
-            <a:endParaRPr lang="en-US" sz="1600" dirty="0"/>
+              <a:t>Markov kernels on the weights</a:t>
+            </a:r>
+            <a:endParaRPr lang="en-US" sz="1500" dirty="0"/>
           </a:p>
         </p:txBody>
       </p:sp>
@@ -8344,8 +7975,8 @@
         </p:nvSpPr>
         <p:spPr>
           <a:xfrm>
-            <a:off x="5166360" y="3346704"/>
-            <a:ext cx="6355080" cy="777240"/>
+            <a:off x="8339328" y="2212848"/>
+            <a:ext cx="3017520" cy="640080"/>
           </a:xfrm>
           <a:prstGeom prst="rect">
             <a:avLst/>
@@ -8361,33 +7992,33 @@
               <a:buNone/>
             </a:pPr>
             <a:r>
-              <a:rPr lang="en-US" sz="1350" dirty="0">
+              <a:rPr lang="en-US" sz="1250" dirty="0">
                 <a:solidFill>
                   <a:schemeClr val="accent5"/>
                 </a:solidFill>
               </a:rPr>
-              <a:t>42% of the margin over uniform, isolated with a zero-step control.</a:t>
-            </a:r>
-            <a:endParaRPr lang="en-US" sz="1350" dirty="0"/>
-          </a:p>
-        </p:txBody>
-      </p:sp>
-      <p:sp>
-        <p:nvSpPr>
-          <p:cNvPr id="12" name="cc-3"/>
+              <a:t>every kernel selects α = 0</a:t>
+            </a:r>
+            <a:endParaRPr lang="en-US" sz="1250" dirty="0"/>
+          </a:p>
+        </p:txBody>
+      </p:sp>
+      <p:sp>
+        <p:nvSpPr>
+          <p:cNvPr id="12" name="neg-3"/>
           <p:cNvSpPr/>
           <p:nvPr/>
         </p:nvSpPr>
         <p:spPr>
           <a:xfrm>
-            <a:off x="640080" y="4379976"/>
-            <a:ext cx="256032" cy="256032"/>
+            <a:off x="640080" y="3090672"/>
+            <a:ext cx="237744" cy="237744"/>
           </a:xfrm>
           <a:prstGeom prst="ellipse">
             <a:avLst/>
           </a:prstGeom>
           <a:solidFill>
-            <a:schemeClr val="accent1"/>
+            <a:schemeClr val="accent4"/>
           </a:solidFill>
           <a:ln/>
         </p:spPr>
@@ -8400,8 +8031,8 @@
         </p:nvSpPr>
         <p:spPr>
           <a:xfrm>
-            <a:off x="1078992" y="4288536"/>
-            <a:ext cx="3931920" cy="411480"/>
+            <a:off x="1024128" y="3017520"/>
+            <a:ext cx="3017520" cy="548640"/>
           </a:xfrm>
           <a:prstGeom prst="rect">
             <a:avLst/>
@@ -8417,14 +8048,14 @@
               <a:buNone/>
             </a:pPr>
             <a:r>
-              <a:rPr lang="en-US" sz="1600" b="1" dirty="0">
+              <a:rPr lang="en-US" sz="1500" b="1" dirty="0">
                 <a:solidFill>
                   <a:schemeClr val="tx2"/>
                 </a:solidFill>
               </a:rPr>
-              <a:t>Heterogeneity is a precondition</a:t>
-            </a:r>
-            <a:endParaRPr lang="en-US" sz="1600" dirty="0"/>
+              <a:t>Latent market regimes</a:t>
+            </a:r>
+            <a:endParaRPr lang="en-US" sz="1500" dirty="0"/>
           </a:p>
         </p:txBody>
       </p:sp>
@@ -8436,8 +8067,8 @@
         </p:nvSpPr>
         <p:spPr>
           <a:xfrm>
-            <a:off x="5166360" y="4288536"/>
-            <a:ext cx="6355080" cy="777240"/>
+            <a:off x="1024128" y="3584448"/>
+            <a:ext cx="3017520" cy="640080"/>
           </a:xfrm>
           <a:prstGeom prst="rect">
             <a:avLst/>
@@ -8453,33 +8084,33 @@
               <a:buNone/>
             </a:pPr>
             <a:r>
-              <a:rPr lang="en-US" sz="1350" dirty="0">
+              <a:rPr lang="en-US" sz="1250" dirty="0">
                 <a:solidFill>
                   <a:schemeClr val="accent5"/>
                 </a:solidFill>
               </a:rPr>
-              <a:t>Learned weighting pays only when the experts come from different processes.</a:t>
-            </a:r>
-            <a:endParaRPr lang="en-US" sz="1350" dirty="0"/>
-          </a:p>
-        </p:txBody>
-      </p:sp>
-      <p:sp>
-        <p:nvSpPr>
-          <p:cNvPr id="15" name="cc-4"/>
+              <a:t>belief sd 0.0000: it does nothing</a:t>
+            </a:r>
+            <a:endParaRPr lang="en-US" sz="1250" dirty="0"/>
+          </a:p>
+        </p:txBody>
+      </p:sp>
+      <p:sp>
+        <p:nvSpPr>
+          <p:cNvPr id="15" name="neg-4"/>
           <p:cNvSpPr/>
           <p:nvPr/>
         </p:nvSpPr>
         <p:spPr>
           <a:xfrm>
-            <a:off x="640080" y="5321808"/>
-            <a:ext cx="256032" cy="256032"/>
+            <a:off x="4297680" y="3090672"/>
+            <a:ext cx="237744" cy="237744"/>
           </a:xfrm>
           <a:prstGeom prst="ellipse">
             <a:avLst/>
           </a:prstGeom>
           <a:solidFill>
-            <a:schemeClr val="accent2"/>
+            <a:schemeClr val="accent4"/>
           </a:solidFill>
           <a:ln/>
         </p:spPr>
@@ -8492,8 +8123,8 @@
         </p:nvSpPr>
         <p:spPr>
           <a:xfrm>
-            <a:off x="1078992" y="5230368"/>
-            <a:ext cx="3931920" cy="411480"/>
+            <a:off x="4681728" y="3017520"/>
+            <a:ext cx="3017520" cy="548640"/>
           </a:xfrm>
           <a:prstGeom prst="rect">
             <a:avLst/>
@@ -8509,14 +8140,14 @@
               <a:buNone/>
             </a:pPr>
             <a:r>
-              <a:rPr lang="en-US" sz="1600" b="1" dirty="0">
+              <a:rPr lang="en-US" sz="1500" b="1" dirty="0">
                 <a:solidFill>
                   <a:schemeClr val="tx2"/>
                 </a:solidFill>
               </a:rPr>
-              <a:t>Better prediction is not profit</a:t>
-            </a:r>
-            <a:endParaRPr lang="en-US" sz="1600" dirty="0"/>
+              <a:t>Bandit, one-point estimator</a:t>
+            </a:r>
+            <a:endParaRPr lang="en-US" sz="1500" dirty="0"/>
           </a:p>
         </p:txBody>
       </p:sp>
@@ -8528,8 +8159,8 @@
         </p:nvSpPr>
         <p:spPr>
           <a:xfrm>
-            <a:off x="5166360" y="5230368"/>
-            <a:ext cx="6355080" cy="777240"/>
+            <a:off x="4681728" y="3584448"/>
+            <a:ext cx="3017520" cy="640080"/>
           </a:xfrm>
           <a:prstGeom prst="rect">
             <a:avLst/>
@@ -8545,14 +8176,418 @@
               <a:buNone/>
             </a:pPr>
             <a:r>
-              <a:rPr lang="en-US" sz="1350" dirty="0">
+              <a:rPr lang="en-US" sz="1250" dirty="0">
                 <a:solidFill>
                   <a:schemeClr val="accent5"/>
                 </a:solidFill>
               </a:rPr>
-              <a:t>The quality gained falls short of the margin, and the edge sits where access is controlled.</a:t>
-            </a:r>
-            <a:endParaRPr lang="en-US" sz="1350" dirty="0"/>
+              <a:t>the horizon is too short</a:t>
+            </a:r>
+            <a:endParaRPr lang="en-US" sz="1250" dirty="0"/>
+          </a:p>
+        </p:txBody>
+      </p:sp>
+      <p:sp>
+        <p:nvSpPr>
+          <p:cNvPr id="18" name="neg-5"/>
+          <p:cNvSpPr/>
+          <p:nvPr/>
+        </p:nvSpPr>
+        <p:spPr>
+          <a:xfrm>
+            <a:off x="7955280" y="3090672"/>
+            <a:ext cx="237744" cy="237744"/>
+          </a:xfrm>
+          <a:prstGeom prst="ellipse">
+            <a:avLst/>
+          </a:prstGeom>
+          <a:solidFill>
+            <a:schemeClr val="accent4"/>
+          </a:solidFill>
+          <a:ln/>
+        </p:spPr>
+      </p:sp>
+      <p:sp>
+        <p:nvSpPr>
+          <p:cNvPr id="19" name="Text 17"/>
+          <p:cNvSpPr txBox="1"/>
+          <p:nvPr/>
+        </p:nvSpPr>
+        <p:spPr>
+          <a:xfrm>
+            <a:off x="8339328" y="3017520"/>
+            <a:ext cx="3017520" cy="548640"/>
+          </a:xfrm>
+          <a:prstGeom prst="rect">
+            <a:avLst/>
+          </a:prstGeom>
+          <a:noFill/>
+          <a:ln/>
+        </p:spPr>
+        <p:txBody>
+          <a:bodyPr wrap="square" lIns="0" tIns="0" rIns="0" bIns="0" rtlCol="0" anchor="t"/>
+          <a:lstStyle/>
+          <a:p>
+            <a:pPr indent="0" marL="0">
+              <a:buNone/>
+            </a:pPr>
+            <a:r>
+              <a:rPr lang="en-US" sz="1500" b="1" dirty="0">
+                <a:solidFill>
+                  <a:schemeClr val="tx2"/>
+                </a:solidFill>
+              </a:rPr>
+              <a:t>Bayesian / MCMC Kelly</a:t>
+            </a:r>
+            <a:endParaRPr lang="en-US" sz="1500" dirty="0"/>
+          </a:p>
+        </p:txBody>
+      </p:sp>
+      <p:sp>
+        <p:nvSpPr>
+          <p:cNvPr id="20" name="Text 18"/>
+          <p:cNvSpPr txBox="1"/>
+          <p:nvPr/>
+        </p:nvSpPr>
+        <p:spPr>
+          <a:xfrm>
+            <a:off x="8339328" y="3584448"/>
+            <a:ext cx="3017520" cy="640080"/>
+          </a:xfrm>
+          <a:prstGeom prst="rect">
+            <a:avLst/>
+          </a:prstGeom>
+          <a:noFill/>
+          <a:ln/>
+        </p:spPr>
+        <p:txBody>
+          <a:bodyPr wrap="square" lIns="0" tIns="0" rIns="0" bIns="0" rtlCol="0" anchor="t"/>
+          <a:lstStyle/>
+          <a:p>
+            <a:pPr indent="0" marL="0">
+              <a:buNone/>
+            </a:pPr>
+            <a:r>
+              <a:rPr lang="en-US" sz="1250" dirty="0">
+                <a:solidFill>
+                  <a:schemeClr val="accent5"/>
+                </a:solidFill>
+              </a:rPr>
+              <a:t>6 ties, 2 losses, zero wins</a:t>
+            </a:r>
+            <a:endParaRPr lang="en-US" sz="1250" dirty="0"/>
+          </a:p>
+        </p:txBody>
+      </p:sp>
+      <p:sp>
+        <p:nvSpPr>
+          <p:cNvPr id="21" name="neg-6"/>
+          <p:cNvSpPr/>
+          <p:nvPr/>
+        </p:nvSpPr>
+        <p:spPr>
+          <a:xfrm>
+            <a:off x="640080" y="4462272"/>
+            <a:ext cx="237744" cy="237744"/>
+          </a:xfrm>
+          <a:prstGeom prst="ellipse">
+            <a:avLst/>
+          </a:prstGeom>
+          <a:solidFill>
+            <a:schemeClr val="accent4"/>
+          </a:solidFill>
+          <a:ln/>
+        </p:spPr>
+      </p:sp>
+      <p:sp>
+        <p:nvSpPr>
+          <p:cNvPr id="22" name="Text 20"/>
+          <p:cNvSpPr txBox="1"/>
+          <p:nvPr/>
+        </p:nvSpPr>
+        <p:spPr>
+          <a:xfrm>
+            <a:off x="1024128" y="4389120"/>
+            <a:ext cx="3017520" cy="548640"/>
+          </a:xfrm>
+          <a:prstGeom prst="rect">
+            <a:avLst/>
+          </a:prstGeom>
+          <a:noFill/>
+          <a:ln/>
+        </p:spPr>
+        <p:txBody>
+          <a:bodyPr wrap="square" lIns="0" tIns="0" rIns="0" bIns="0" rtlCol="0" anchor="t"/>
+          <a:lstStyle/>
+          <a:p>
+            <a:pPr indent="0" marL="0">
+              <a:buNone/>
+            </a:pPr>
+            <a:r>
+              <a:rPr lang="en-US" sz="1500" b="1" dirty="0">
+                <a:solidFill>
+                  <a:schemeClr val="tx2"/>
+                </a:solidFill>
+              </a:rPr>
+              <a:t>Per-league specialisation</a:t>
+            </a:r>
+            <a:endParaRPr lang="en-US" sz="1500" dirty="0"/>
+          </a:p>
+        </p:txBody>
+      </p:sp>
+      <p:sp>
+        <p:nvSpPr>
+          <p:cNvPr id="23" name="Text 21"/>
+          <p:cNvSpPr txBox="1"/>
+          <p:nvPr/>
+        </p:nvSpPr>
+        <p:spPr>
+          <a:xfrm>
+            <a:off x="1024128" y="4956048"/>
+            <a:ext cx="3017520" cy="640080"/>
+          </a:xfrm>
+          <a:prstGeom prst="rect">
+            <a:avLst/>
+          </a:prstGeom>
+          <a:noFill/>
+          <a:ln/>
+        </p:spPr>
+        <p:txBody>
+          <a:bodyPr wrap="square" lIns="0" tIns="0" rIns="0" bIns="0" rtlCol="0" anchor="t"/>
+          <a:lstStyle/>
+          <a:p>
+            <a:pPr indent="0" marL="0">
+              <a:buNone/>
+            </a:pPr>
+            <a:r>
+              <a:rPr lang="en-US" sz="1250" dirty="0">
+                <a:solidFill>
+                  <a:schemeClr val="accent5"/>
+                </a:solidFill>
+              </a:rPr>
+              <a:t>loses in all six leagues</a:t>
+            </a:r>
+            <a:endParaRPr lang="en-US" sz="1250" dirty="0"/>
+          </a:p>
+        </p:txBody>
+      </p:sp>
+      <p:sp>
+        <p:nvSpPr>
+          <p:cNvPr id="24" name="neg-7"/>
+          <p:cNvSpPr/>
+          <p:nvPr/>
+        </p:nvSpPr>
+        <p:spPr>
+          <a:xfrm>
+            <a:off x="4297680" y="4462272"/>
+            <a:ext cx="237744" cy="237744"/>
+          </a:xfrm>
+          <a:prstGeom prst="ellipse">
+            <a:avLst/>
+          </a:prstGeom>
+          <a:solidFill>
+            <a:schemeClr val="accent4"/>
+          </a:solidFill>
+          <a:ln/>
+        </p:spPr>
+      </p:sp>
+      <p:sp>
+        <p:nvSpPr>
+          <p:cNvPr id="25" name="Text 23"/>
+          <p:cNvSpPr txBox="1"/>
+          <p:nvPr/>
+        </p:nvSpPr>
+        <p:spPr>
+          <a:xfrm>
+            <a:off x="4681728" y="4389120"/>
+            <a:ext cx="3017520" cy="548640"/>
+          </a:xfrm>
+          <a:prstGeom prst="rect">
+            <a:avLst/>
+          </a:prstGeom>
+          <a:noFill/>
+          <a:ln/>
+        </p:spPr>
+        <p:txBody>
+          <a:bodyPr wrap="square" lIns="0" tIns="0" rIns="0" bIns="0" rtlCol="0" anchor="t"/>
+          <a:lstStyle/>
+          <a:p>
+            <a:pPr indent="0" marL="0">
+              <a:buNone/>
+            </a:pPr>
+            <a:r>
+              <a:rPr lang="en-US" sz="1500" b="1" dirty="0">
+                <a:solidFill>
+                  <a:schemeClr val="tx2"/>
+                </a:solidFill>
+              </a:rPr>
+              <a:t>AdaGrad</a:t>
+            </a:r>
+            <a:endParaRPr lang="en-US" sz="1500" dirty="0"/>
+          </a:p>
+        </p:txBody>
+      </p:sp>
+      <p:sp>
+        <p:nvSpPr>
+          <p:cNvPr id="26" name="Text 24"/>
+          <p:cNvSpPr txBox="1"/>
+          <p:nvPr/>
+        </p:nvSpPr>
+        <p:spPr>
+          <a:xfrm>
+            <a:off x="4681728" y="4956048"/>
+            <a:ext cx="3017520" cy="640080"/>
+          </a:xfrm>
+          <a:prstGeom prst="rect">
+            <a:avLst/>
+          </a:prstGeom>
+          <a:noFill/>
+          <a:ln/>
+        </p:spPr>
+        <p:txBody>
+          <a:bodyPr wrap="square" lIns="0" tIns="0" rIns="0" bIns="0" rtlCol="0" anchor="t"/>
+          <a:lstStyle/>
+          <a:p>
+            <a:pPr indent="0" marL="0">
+              <a:buNone/>
+            </a:pPr>
+            <a:r>
+              <a:rPr lang="en-US" sz="1250" dirty="0">
+                <a:solidFill>
+                  <a:schemeClr val="accent5"/>
+                </a:solidFill>
+              </a:rPr>
+              <a:t>recovers 20% at best</a:t>
+            </a:r>
+            <a:endParaRPr lang="en-US" sz="1250" dirty="0"/>
+          </a:p>
+        </p:txBody>
+      </p:sp>
+      <p:sp>
+        <p:nvSpPr>
+          <p:cNvPr id="27" name="neg-8"/>
+          <p:cNvSpPr/>
+          <p:nvPr/>
+        </p:nvSpPr>
+        <p:spPr>
+          <a:xfrm>
+            <a:off x="7955280" y="4462272"/>
+            <a:ext cx="237744" cy="237744"/>
+          </a:xfrm>
+          <a:prstGeom prst="ellipse">
+            <a:avLst/>
+          </a:prstGeom>
+          <a:solidFill>
+            <a:schemeClr val="accent4"/>
+          </a:solidFill>
+          <a:ln/>
+        </p:spPr>
+      </p:sp>
+      <p:sp>
+        <p:nvSpPr>
+          <p:cNvPr id="28" name="Text 26"/>
+          <p:cNvSpPr txBox="1"/>
+          <p:nvPr/>
+        </p:nvSpPr>
+        <p:spPr>
+          <a:xfrm>
+            <a:off x="8339328" y="4389120"/>
+            <a:ext cx="3017520" cy="548640"/>
+          </a:xfrm>
+          <a:prstGeom prst="rect">
+            <a:avLst/>
+          </a:prstGeom>
+          <a:noFill/>
+          <a:ln/>
+        </p:spPr>
+        <p:txBody>
+          <a:bodyPr wrap="square" lIns="0" tIns="0" rIns="0" bIns="0" rtlCol="0" anchor="t"/>
+          <a:lstStyle/>
+          <a:p>
+            <a:pPr indent="0" marL="0">
+              <a:buNone/>
+            </a:pPr>
+            <a:r>
+              <a:rPr lang="en-US" sz="1500" b="1" dirty="0">
+                <a:solidFill>
+                  <a:schemeClr val="tx2"/>
+                </a:solidFill>
+              </a:rPr>
+              <a:t>Joint step + calibration sweep</a:t>
+            </a:r>
+            <a:endParaRPr lang="en-US" sz="1500" dirty="0"/>
+          </a:p>
+        </p:txBody>
+      </p:sp>
+      <p:sp>
+        <p:nvSpPr>
+          <p:cNvPr id="29" name="Text 27"/>
+          <p:cNvSpPr txBox="1"/>
+          <p:nvPr/>
+        </p:nvSpPr>
+        <p:spPr>
+          <a:xfrm>
+            <a:off x="8339328" y="4956048"/>
+            <a:ext cx="3017520" cy="640080"/>
+          </a:xfrm>
+          <a:prstGeom prst="rect">
+            <a:avLst/>
+          </a:prstGeom>
+          <a:noFill/>
+          <a:ln/>
+        </p:spPr>
+        <p:txBody>
+          <a:bodyPr wrap="square" lIns="0" tIns="0" rIns="0" bIns="0" rtlCol="0" anchor="t"/>
+          <a:lstStyle/>
+          <a:p>
+            <a:pPr indent="0" marL="0">
+              <a:buNone/>
+            </a:pPr>
+            <a:r>
+              <a:rPr lang="en-US" sz="1250" dirty="0">
+                <a:solidFill>
+                  <a:schemeClr val="accent5"/>
+                </a:solidFill>
+              </a:rPr>
+              <a:t>no interaction at all</a:t>
+            </a:r>
+            <a:endParaRPr lang="en-US" sz="1250" dirty="0"/>
+          </a:p>
+        </p:txBody>
+      </p:sp>
+      <p:sp>
+        <p:nvSpPr>
+          <p:cNvPr id="30" name="Text 28"/>
+          <p:cNvSpPr txBox="1"/>
+          <p:nvPr/>
+        </p:nvSpPr>
+        <p:spPr>
+          <a:xfrm>
+            <a:off x="640080" y="5852160"/>
+            <a:ext cx="10881360" cy="640080"/>
+          </a:xfrm>
+          <a:prstGeom prst="rect">
+            <a:avLst/>
+          </a:prstGeom>
+          <a:noFill/>
+          <a:ln/>
+        </p:spPr>
+        <p:txBody>
+          <a:bodyPr wrap="square" rtlCol="0" anchor="ctr"/>
+          <a:lstStyle/>
+          <a:p>
+            <a:pPr indent="0" marL="0">
+              <a:buNone/>
+            </a:pPr>
+            <a:r>
+              <a:rPr lang="en-US" sz="1500" dirty="0">
+                <a:solidFill>
+                  <a:schemeClr val="tx1"/>
+                </a:solidFill>
+              </a:rPr>
+              <a:t>One pattern unites them: once the step size is tuned, no further movement of mass over the experts buys anything. The step and the leak control the same quantity.</a:t>
+            </a:r>
+            <a:endParaRPr lang="en-US" sz="1500" dirty="0"/>
           </a:p>
         </p:txBody>
       </p:sp>
@@ -8658,7 +8693,7 @@
                   <a:schemeClr val="tx2"/>
                 </a:solidFill>
               </a:rPr>
-              <a:t>Future work</a:t>
+              <a:t>Conclusions</a:t>
             </a:r>
             <a:endParaRPr lang="en-US" sz="3000" dirty="0"/>
           </a:p>
@@ -8666,14 +8701,106 @@
       </p:sp>
       <p:sp>
         <p:nvSpPr>
-          <p:cNvPr id="3" name="circle-1"/>
+          <p:cNvPr id="3" name="cc-0"/>
           <p:cNvSpPr/>
           <p:nvPr/>
         </p:nvSpPr>
         <p:spPr>
           <a:xfrm>
-            <a:off x="640080" y="1691640"/>
-            <a:ext cx="566928" cy="566928"/>
+            <a:off x="640080" y="1554480"/>
+            <a:ext cx="256032" cy="256032"/>
+          </a:xfrm>
+          <a:prstGeom prst="ellipse">
+            <a:avLst/>
+          </a:prstGeom>
+          <a:solidFill>
+            <a:schemeClr val="accent3"/>
+          </a:solidFill>
+          <a:ln/>
+        </p:spPr>
+      </p:sp>
+      <p:sp>
+        <p:nvSpPr>
+          <p:cNvPr id="4" name="Text 2"/>
+          <p:cNvSpPr txBox="1"/>
+          <p:nvPr/>
+        </p:nvSpPr>
+        <p:spPr>
+          <a:xfrm>
+            <a:off x="1078992" y="1463040"/>
+            <a:ext cx="3931920" cy="411480"/>
+          </a:xfrm>
+          <a:prstGeom prst="rect">
+            <a:avLst/>
+          </a:prstGeom>
+          <a:noFill/>
+          <a:ln/>
+        </p:spPr>
+        <p:txBody>
+          <a:bodyPr wrap="square" lIns="0" tIns="0" rIns="0" bIns="0" rtlCol="0" anchor="t"/>
+          <a:lstStyle/>
+          <a:p>
+            <a:pPr indent="0" marL="0">
+              <a:buNone/>
+            </a:pPr>
+            <a:r>
+              <a:rPr lang="en-US" sz="1600" b="1" dirty="0">
+                <a:solidFill>
+                  <a:schemeClr val="tx2"/>
+                </a:solidFill>
+              </a:rPr>
+              <a:t>The framework applies</a:t>
+            </a:r>
+            <a:endParaRPr lang="en-US" sz="1600" dirty="0"/>
+          </a:p>
+        </p:txBody>
+      </p:sp>
+      <p:sp>
+        <p:nvSpPr>
+          <p:cNvPr id="5" name="Text 3"/>
+          <p:cNvSpPr txBox="1"/>
+          <p:nvPr/>
+        </p:nvSpPr>
+        <p:spPr>
+          <a:xfrm>
+            <a:off x="5166360" y="1463040"/>
+            <a:ext cx="6355080" cy="777240"/>
+          </a:xfrm>
+          <a:prstGeom prst="rect">
+            <a:avLst/>
+          </a:prstGeom>
+          <a:noFill/>
+          <a:ln/>
+        </p:spPr>
+        <p:txBody>
+          <a:bodyPr wrap="square" lIns="0" tIns="0" rIns="0" bIns="0" rtlCol="0" anchor="t"/>
+          <a:lstStyle/>
+          <a:p>
+            <a:pPr indent="0" marL="0">
+              <a:buNone/>
+            </a:pPr>
+            <a:r>
+              <a:rPr lang="en-US" sz="1350" dirty="0">
+                <a:solidFill>
+                  <a:schemeClr val="accent5"/>
+                </a:solidFill>
+              </a:rPr>
+              <a:t>An online mixture of published odds beats the uniform average and almost every individual bookmaker, with no distributional assumption.</a:t>
+            </a:r>
+            <a:endParaRPr lang="en-US" sz="1350" dirty="0"/>
+          </a:p>
+        </p:txBody>
+      </p:sp>
+      <p:sp>
+        <p:nvSpPr>
+          <p:cNvPr id="6" name="cc-1"/>
+          <p:cNvSpPr/>
+          <p:nvPr/>
+        </p:nvSpPr>
+        <p:spPr>
+          <a:xfrm>
+            <a:off x="640080" y="2496312"/>
+            <a:ext cx="256032" cy="256032"/>
           </a:xfrm>
           <a:prstGeom prst="ellipse">
             <a:avLst/>
@@ -8686,50 +8813,50 @@
       </p:sp>
       <p:sp>
         <p:nvSpPr>
-          <p:cNvPr id="4" name="Text 2"/>
+          <p:cNvPr id="7" name="Text 5"/>
           <p:cNvSpPr txBox="1"/>
           <p:nvPr/>
         </p:nvSpPr>
         <p:spPr>
           <a:xfrm>
-            <a:off x="640080" y="1691640"/>
-            <a:ext cx="566928" cy="566928"/>
-          </a:xfrm>
-          <a:prstGeom prst="rect">
-            <a:avLst/>
-          </a:prstGeom>
-          <a:noFill/>
-          <a:ln/>
-        </p:spPr>
-        <p:txBody>
-          <a:bodyPr wrap="square" lIns="0" tIns="0" rIns="0" bIns="0" rtlCol="0" anchor="ctr"/>
-          <a:lstStyle/>
-          <a:p>
-            <a:pPr algn="ctr" indent="0" marL="0">
-              <a:buNone/>
-            </a:pPr>
-            <a:r>
-              <a:rPr lang="en-US" sz="2000" b="1" dirty="0">
-                <a:solidFill>
-                  <a:srgbClr val="FFFFFF"/>
-                </a:solidFill>
-              </a:rPr>
-              <a:t>1</a:t>
-            </a:r>
-            <a:endParaRPr lang="en-US" sz="2000" dirty="0"/>
-          </a:p>
-        </p:txBody>
-      </p:sp>
-      <p:sp>
-        <p:nvSpPr>
-          <p:cNvPr id="5" name="Text 3"/>
+            <a:off x="1078992" y="2404872"/>
+            <a:ext cx="3931920" cy="411480"/>
+          </a:xfrm>
+          <a:prstGeom prst="rect">
+            <a:avLst/>
+          </a:prstGeom>
+          <a:noFill/>
+          <a:ln/>
+        </p:spPr>
+        <p:txBody>
+          <a:bodyPr wrap="square" lIns="0" tIns="0" rIns="0" bIns="0" rtlCol="0" anchor="t"/>
+          <a:lstStyle/>
+          <a:p>
+            <a:pPr indent="0" marL="0">
+              <a:buNone/>
+            </a:pPr>
+            <a:r>
+              <a:rPr lang="en-US" sz="1600" b="1" dirty="0">
+                <a:solidFill>
+                  <a:schemeClr val="tx2"/>
+                </a:solidFill>
+              </a:rPr>
+              <a:t>It reaches the market's edge</a:t>
+            </a:r>
+            <a:endParaRPr lang="en-US" sz="1600" dirty="0"/>
+          </a:p>
+        </p:txBody>
+      </p:sp>
+      <p:sp>
+        <p:nvSpPr>
+          <p:cNvPr id="8" name="Text 6"/>
           <p:cNvSpPr txBox="1"/>
           <p:nvPr/>
         </p:nvSpPr>
         <p:spPr>
           <a:xfrm>
-            <a:off x="1508760" y="1645920"/>
-            <a:ext cx="10058400" cy="411480"/>
+            <a:off x="5166360" y="2404872"/>
+            <a:ext cx="6355080" cy="777240"/>
           </a:xfrm>
           <a:prstGeom prst="rect">
             <a:avLst/>
@@ -8745,27 +8872,83 @@
               <a:buNone/>
             </a:pPr>
             <a:r>
-              <a:rPr lang="en-US" sz="1800" b="1" dirty="0">
+              <a:rPr lang="en-US" sz="1350" dirty="0">
+                <a:solidFill>
+                  <a:schemeClr val="accent5"/>
+                </a:solidFill>
+              </a:rPr>
+              <a:t>Hedge is level with the sharpest bookmaker over the whole decade; an exchange with no operator margin is still ahead.</a:t>
+            </a:r>
+            <a:endParaRPr lang="en-US" sz="1350" dirty="0"/>
+          </a:p>
+        </p:txBody>
+      </p:sp>
+      <p:sp>
+        <p:nvSpPr>
+          <p:cNvPr id="9" name="cc-2"/>
+          <p:cNvSpPr/>
+          <p:nvPr/>
+        </p:nvSpPr>
+        <p:spPr>
+          <a:xfrm>
+            <a:off x="640080" y="3438144"/>
+            <a:ext cx="256032" cy="256032"/>
+          </a:xfrm>
+          <a:prstGeom prst="ellipse">
+            <a:avLst/>
+          </a:prstGeom>
+          <a:solidFill>
+            <a:schemeClr val="accent4"/>
+          </a:solidFill>
+          <a:ln/>
+        </p:spPr>
+      </p:sp>
+      <p:sp>
+        <p:nvSpPr>
+          <p:cNvPr id="10" name="Text 8"/>
+          <p:cNvSpPr txBox="1"/>
+          <p:nvPr/>
+        </p:nvSpPr>
+        <p:spPr>
+          <a:xfrm>
+            <a:off x="1078992" y="3346704"/>
+            <a:ext cx="3931920" cy="411480"/>
+          </a:xfrm>
+          <a:prstGeom prst="rect">
+            <a:avLst/>
+          </a:prstGeom>
+          <a:noFill/>
+          <a:ln/>
+        </p:spPr>
+        <p:txBody>
+          <a:bodyPr wrap="square" lIns="0" tIns="0" rIns="0" bIns="0" rtlCol="0" anchor="t"/>
+          <a:lstStyle/>
+          <a:p>
+            <a:pPr indent="0" marL="0">
+              <a:buNone/>
+            </a:pPr>
+            <a:r>
+              <a:rPr lang="en-US" sz="1600" b="1" dirty="0">
                 <a:solidFill>
                   <a:schemeClr val="tx2"/>
                 </a:solidFill>
               </a:rPr>
-              <a:t>A live odds feed</a:t>
-            </a:r>
-            <a:endParaRPr lang="en-US" sz="1800" dirty="0"/>
-          </a:p>
-        </p:txBody>
-      </p:sp>
-      <p:sp>
-        <p:nvSpPr>
-          <p:cNvPr id="6" name="Text 4"/>
+              <a:t>Check the theory against the data</a:t>
+            </a:r>
+            <a:endParaRPr lang="en-US" sz="1600" dirty="0"/>
+          </a:p>
+        </p:txBody>
+      </p:sp>
+      <p:sp>
+        <p:nvSpPr>
+          <p:cNvPr id="11" name="Text 9"/>
           <p:cNvSpPr txBox="1"/>
           <p:nvPr/>
         </p:nvSpPr>
         <p:spPr>
           <a:xfrm>
-            <a:off x="1508760" y="2066544"/>
-            <a:ext cx="10058400" cy="960120"/>
+            <a:off x="5166360" y="3346704"/>
+            <a:ext cx="6355080" cy="777240"/>
           </a:xfrm>
           <a:prstGeom prst="rect">
             <a:avLst/>
@@ -8786,7 +8969,7 @@
                   <a:schemeClr val="accent5"/>
                 </a:solidFill>
               </a:rPr>
-              <a:t>Every result here says what the method WOULD have done. The three stages are online and causal and the state is one weight vector plus two scalars, so it runs in real time against a streaming API. That turns a statistical edge into an exploitable one.</a:t>
+              <a:t>42% of OGD's margin is geometry, and a regret bound exposed a broken Hedge.</a:t>
             </a:r>
             <a:endParaRPr lang="en-US" sz="1350" dirty="0"/>
           </a:p>
@@ -8794,14 +8977,14 @@
       </p:sp>
       <p:sp>
         <p:nvSpPr>
-          <p:cNvPr id="7" name="circle-2"/>
+          <p:cNvPr id="12" name="cc-3"/>
           <p:cNvSpPr/>
           <p:nvPr/>
         </p:nvSpPr>
         <p:spPr>
           <a:xfrm>
-            <a:off x="640080" y="3200400"/>
-            <a:ext cx="566928" cy="566928"/>
+            <a:off x="640080" y="4379976"/>
+            <a:ext cx="256032" cy="256032"/>
           </a:xfrm>
           <a:prstGeom prst="ellipse">
             <a:avLst/>
@@ -8814,178 +8997,14 @@
       </p:sp>
       <p:sp>
         <p:nvSpPr>
-          <p:cNvPr id="8" name="Text 6"/>
-          <p:cNvSpPr txBox="1"/>
-          <p:nvPr/>
-        </p:nvSpPr>
-        <p:spPr>
-          <a:xfrm>
-            <a:off x="640080" y="3200400"/>
-            <a:ext cx="566928" cy="566928"/>
-          </a:xfrm>
-          <a:prstGeom prst="rect">
-            <a:avLst/>
-          </a:prstGeom>
-          <a:noFill/>
-          <a:ln/>
-        </p:spPr>
-        <p:txBody>
-          <a:bodyPr wrap="square" lIns="0" tIns="0" rIns="0" bIns="0" rtlCol="0" anchor="ctr"/>
-          <a:lstStyle/>
-          <a:p>
-            <a:pPr algn="ctr" indent="0" marL="0">
-              <a:buNone/>
-            </a:pPr>
-            <a:r>
-              <a:rPr lang="en-US" sz="2000" b="1" dirty="0">
-                <a:solidFill>
-                  <a:srgbClr val="FFFFFF"/>
-                </a:solidFill>
-              </a:rPr>
-              <a:t>2</a:t>
-            </a:r>
-            <a:endParaRPr lang="en-US" sz="2000" dirty="0"/>
-          </a:p>
-        </p:txBody>
-      </p:sp>
-      <p:sp>
-        <p:nvSpPr>
-          <p:cNvPr id="9" name="Text 7"/>
-          <p:cNvSpPr txBox="1"/>
-          <p:nvPr/>
-        </p:nvSpPr>
-        <p:spPr>
-          <a:xfrm>
-            <a:off x="1508760" y="3154680"/>
-            <a:ext cx="10058400" cy="411480"/>
-          </a:xfrm>
-          <a:prstGeom prst="rect">
-            <a:avLst/>
-          </a:prstGeom>
-          <a:noFill/>
-          <a:ln/>
-        </p:spPr>
-        <p:txBody>
-          <a:bodyPr wrap="square" lIns="0" tIns="0" rIns="0" bIns="0" rtlCol="0" anchor="t"/>
-          <a:lstStyle/>
-          <a:p>
-            <a:pPr indent="0" marL="0">
-              <a:buNone/>
-            </a:pPr>
-            <a:r>
-              <a:rPr lang="en-US" sz="1800" b="1" dirty="0">
-                <a:solidFill>
-                  <a:schemeClr val="tx2"/>
-                </a:solidFill>
-              </a:rPr>
-              <a:t>A second sport</a:t>
-            </a:r>
-            <a:endParaRPr lang="en-US" sz="1800" dirty="0"/>
-          </a:p>
-        </p:txBody>
-      </p:sp>
-      <p:sp>
-        <p:nvSpPr>
-          <p:cNvPr id="10" name="Text 8"/>
-          <p:cNvSpPr txBox="1"/>
-          <p:nvPr/>
-        </p:nvSpPr>
-        <p:spPr>
-          <a:xfrm>
-            <a:off x="1508760" y="3575304"/>
-            <a:ext cx="10058400" cy="960120"/>
-          </a:xfrm>
-          <a:prstGeom prst="rect">
-            <a:avLst/>
-          </a:prstGeom>
-          <a:noFill/>
-          <a:ln/>
-        </p:spPr>
-        <p:txBody>
-          <a:bodyPr wrap="square" lIns="0" tIns="0" rIns="0" bIns="0" rtlCol="0" anchor="t"/>
-          <a:lstStyle/>
-          <a:p>
-            <a:pPr indent="0" marL="0">
-              <a:buNone/>
-            </a:pPr>
-            <a:r>
-              <a:rPr lang="en-US" sz="1350" dirty="0">
-                <a:solidFill>
-                  <a:schemeClr val="accent5"/>
-                </a:solidFill>
-              </a:rPr>
-              <a:t>Basketball or tennis would show whether the framework generalises. The cost is a data pipeline; the algorithms do not change.</a:t>
-            </a:r>
-            <a:endParaRPr lang="en-US" sz="1350" dirty="0"/>
-          </a:p>
-        </p:txBody>
-      </p:sp>
-      <p:sp>
-        <p:nvSpPr>
-          <p:cNvPr id="11" name="circle-3"/>
-          <p:cNvSpPr/>
-          <p:nvPr/>
-        </p:nvSpPr>
-        <p:spPr>
-          <a:xfrm>
-            <a:off x="640080" y="4709160"/>
-            <a:ext cx="566928" cy="566928"/>
-          </a:xfrm>
-          <a:prstGeom prst="ellipse">
-            <a:avLst/>
-          </a:prstGeom>
-          <a:solidFill>
-            <a:schemeClr val="accent1"/>
-          </a:solidFill>
-          <a:ln/>
-        </p:spPr>
-      </p:sp>
-      <p:sp>
-        <p:nvSpPr>
-          <p:cNvPr id="12" name="Text 10"/>
-          <p:cNvSpPr txBox="1"/>
-          <p:nvPr/>
-        </p:nvSpPr>
-        <p:spPr>
-          <a:xfrm>
-            <a:off x="640080" y="4709160"/>
-            <a:ext cx="566928" cy="566928"/>
-          </a:xfrm>
-          <a:prstGeom prst="rect">
-            <a:avLst/>
-          </a:prstGeom>
-          <a:noFill/>
-          <a:ln/>
-        </p:spPr>
-        <p:txBody>
-          <a:bodyPr wrap="square" lIns="0" tIns="0" rIns="0" bIns="0" rtlCol="0" anchor="ctr"/>
-          <a:lstStyle/>
-          <a:p>
-            <a:pPr algn="ctr" indent="0" marL="0">
-              <a:buNone/>
-            </a:pPr>
-            <a:r>
-              <a:rPr lang="en-US" sz="2000" b="1" dirty="0">
-                <a:solidFill>
-                  <a:srgbClr val="FFFFFF"/>
-                </a:solidFill>
-              </a:rPr>
-              <a:t>3</a:t>
-            </a:r>
-            <a:endParaRPr lang="en-US" sz="2000" dirty="0"/>
-          </a:p>
-        </p:txBody>
-      </p:sp>
-      <p:sp>
-        <p:nvSpPr>
           <p:cNvPr id="13" name="Text 11"/>
           <p:cNvSpPr txBox="1"/>
           <p:nvPr/>
         </p:nvSpPr>
         <p:spPr>
           <a:xfrm>
-            <a:off x="1508760" y="4663440"/>
-            <a:ext cx="10058400" cy="411480"/>
+            <a:off x="1078992" y="4288536"/>
+            <a:ext cx="3931920" cy="411480"/>
           </a:xfrm>
           <a:prstGeom prst="rect">
             <a:avLst/>
@@ -9001,14 +9020,14 @@
               <a:buNone/>
             </a:pPr>
             <a:r>
-              <a:rPr lang="en-US" sz="1800" b="1" dirty="0">
+              <a:rPr lang="en-US" sz="1600" b="1" dirty="0">
                 <a:solidFill>
                   <a:schemeClr val="tx2"/>
                 </a:solidFill>
               </a:rPr>
-              <a:t>Bayesian Model Averaging as a baseline</a:t>
-            </a:r>
-            <a:endParaRPr lang="en-US" sz="1800" dirty="0"/>
+              <a:t>Heterogeneity is where learning pays</a:t>
+            </a:r>
+            <a:endParaRPr lang="en-US" sz="1600" dirty="0"/>
           </a:p>
         </p:txBody>
       </p:sp>
@@ -9020,8 +9039,8 @@
         </p:nvSpPr>
         <p:spPr>
           <a:xfrm>
-            <a:off x="1508760" y="5084064"/>
-            <a:ext cx="10058400" cy="960120"/>
+            <a:off x="5166360" y="4288536"/>
+            <a:ext cx="6355080" cy="777240"/>
           </a:xfrm>
           <a:prstGeom prst="rect">
             <a:avLst/>
@@ -9042,7 +9061,99 @@
                   <a:schemeClr val="accent5"/>
                 </a:solidFill>
               </a:rPr>
-              <a:t>An empirical comparison against the online algorithms, and more light on why the Aggregating Algorithm underperforms here.</a:t>
+              <a:t>The gain is largest when the experts come from different processes, and mostly goes when they do not.</a:t>
+            </a:r>
+            <a:endParaRPr lang="en-US" sz="1350" dirty="0"/>
+          </a:p>
+        </p:txBody>
+      </p:sp>
+      <p:sp>
+        <p:nvSpPr>
+          <p:cNvPr id="15" name="cc-4"/>
+          <p:cNvSpPr/>
+          <p:nvPr/>
+        </p:nvSpPr>
+        <p:spPr>
+          <a:xfrm>
+            <a:off x="640080" y="5321808"/>
+            <a:ext cx="256032" cy="256032"/>
+          </a:xfrm>
+          <a:prstGeom prst="ellipse">
+            <a:avLst/>
+          </a:prstGeom>
+          <a:solidFill>
+            <a:schemeClr val="accent2"/>
+          </a:solidFill>
+          <a:ln/>
+        </p:spPr>
+      </p:sp>
+      <p:sp>
+        <p:nvSpPr>
+          <p:cNvPr id="16" name="Text 14"/>
+          <p:cNvSpPr txBox="1"/>
+          <p:nvPr/>
+        </p:nvSpPr>
+        <p:spPr>
+          <a:xfrm>
+            <a:off x="1078992" y="5230368"/>
+            <a:ext cx="3931920" cy="411480"/>
+          </a:xfrm>
+          <a:prstGeom prst="rect">
+            <a:avLst/>
+          </a:prstGeom>
+          <a:noFill/>
+          <a:ln/>
+        </p:spPr>
+        <p:txBody>
+          <a:bodyPr wrap="square" lIns="0" tIns="0" rIns="0" bIns="0" rtlCol="0" anchor="t"/>
+          <a:lstStyle/>
+          <a:p>
+            <a:pPr indent="0" marL="0">
+              <a:buNone/>
+            </a:pPr>
+            <a:r>
+              <a:rPr lang="en-US" sz="1600" b="1" dirty="0">
+                <a:solidFill>
+                  <a:schemeClr val="tx2"/>
+                </a:solidFill>
+              </a:rPr>
+              <a:t>Better prediction is not profit</a:t>
+            </a:r>
+            <a:endParaRPr lang="en-US" sz="1600" dirty="0"/>
+          </a:p>
+        </p:txBody>
+      </p:sp>
+      <p:sp>
+        <p:nvSpPr>
+          <p:cNvPr id="17" name="Text 15"/>
+          <p:cNvSpPr txBox="1"/>
+          <p:nvPr/>
+        </p:nvSpPr>
+        <p:spPr>
+          <a:xfrm>
+            <a:off x="5166360" y="5230368"/>
+            <a:ext cx="6355080" cy="777240"/>
+          </a:xfrm>
+          <a:prstGeom prst="rect">
+            <a:avLst/>
+          </a:prstGeom>
+          <a:noFill/>
+          <a:ln/>
+        </p:spPr>
+        <p:txBody>
+          <a:bodyPr wrap="square" lIns="0" tIns="0" rIns="0" bIns="0" rtlCol="0" anchor="t"/>
+          <a:lstStyle/>
+          <a:p>
+            <a:pPr indent="0" marL="0">
+              <a:buNone/>
+            </a:pPr>
+            <a:r>
+              <a:rPr lang="en-US" sz="1350" dirty="0">
+                <a:solidFill>
+                  <a:schemeClr val="accent5"/>
+                </a:solidFill>
+              </a:rPr>
+              <a:t>The quality gained falls short of the margin, and the edge sits where access is controlled.</a:t>
             </a:r>
             <a:endParaRPr lang="en-US" sz="1350" dirty="0"/>
           </a:p>
@@ -9128,69 +9239,460 @@
         </p:nvSpPr>
         <p:spPr>
           <a:xfrm>
-            <a:off x="914400" y="2103120"/>
-            <a:ext cx="10332720" cy="1737360"/>
-          </a:xfrm>
-          <a:prstGeom prst="rect">
-            <a:avLst/>
-          </a:prstGeom>
-          <a:noFill/>
-          <a:ln/>
-        </p:spPr>
-        <p:txBody>
-          <a:bodyPr wrap="square" rtlCol="0" anchor="b"/>
+            <a:off x="640080" y="411480"/>
+            <a:ext cx="10881360" cy="777240"/>
+          </a:xfrm>
+          <a:prstGeom prst="rect">
+            <a:avLst/>
+          </a:prstGeom>
+          <a:noFill/>
+          <a:ln/>
+        </p:spPr>
+        <p:txBody>
+          <a:bodyPr wrap="square" rtlCol="0" anchor="ctr"/>
+          <a:lstStyle/>
+          <a:p>
+            <a:pPr algn="l" indent="0" marL="0">
+              <a:buNone/>
+            </a:pPr>
+            <a:r>
+              <a:rPr lang="en-US" sz="3000" b="1" dirty="0">
+                <a:solidFill>
+                  <a:schemeClr val="tx2"/>
+                </a:solidFill>
+              </a:rPr>
+              <a:t>Future work</a:t>
+            </a:r>
+            <a:endParaRPr lang="en-US" sz="3000" dirty="0"/>
+          </a:p>
+        </p:txBody>
+      </p:sp>
+      <p:sp>
+        <p:nvSpPr>
+          <p:cNvPr id="3" name="circle-1"/>
+          <p:cNvSpPr/>
+          <p:nvPr/>
+        </p:nvSpPr>
+        <p:spPr>
+          <a:xfrm>
+            <a:off x="640080" y="1691640"/>
+            <a:ext cx="566928" cy="566928"/>
+          </a:xfrm>
+          <a:prstGeom prst="ellipse">
+            <a:avLst/>
+          </a:prstGeom>
+          <a:solidFill>
+            <a:schemeClr val="accent1"/>
+          </a:solidFill>
+          <a:ln/>
+        </p:spPr>
+      </p:sp>
+      <p:sp>
+        <p:nvSpPr>
+          <p:cNvPr id="4" name="Text 2"/>
+          <p:cNvSpPr txBox="1"/>
+          <p:nvPr/>
+        </p:nvSpPr>
+        <p:spPr>
+          <a:xfrm>
+            <a:off x="640080" y="1691640"/>
+            <a:ext cx="566928" cy="566928"/>
+          </a:xfrm>
+          <a:prstGeom prst="rect">
+            <a:avLst/>
+          </a:prstGeom>
+          <a:noFill/>
+          <a:ln/>
+        </p:spPr>
+        <p:txBody>
+          <a:bodyPr wrap="square" lIns="0" tIns="0" rIns="0" bIns="0" rtlCol="0" anchor="ctr"/>
           <a:lstStyle/>
           <a:p>
             <a:pPr algn="ctr" indent="0" marL="0">
               <a:buNone/>
             </a:pPr>
             <a:r>
-              <a:rPr lang="en-US" sz="4000" b="1" dirty="0">
-                <a:solidFill>
-                  <a:schemeClr val="bg1"/>
-                </a:solidFill>
-              </a:rPr>
-              <a:t>Thank you</a:t>
-            </a:r>
-            <a:endParaRPr lang="en-US" sz="4000" dirty="0"/>
-          </a:p>
-        </p:txBody>
-      </p:sp>
-      <p:sp>
-        <p:nvSpPr>
-          <p:cNvPr id="3" name="Text 0"/>
+              <a:rPr lang="en-US" sz="2000" b="1" dirty="0">
+                <a:solidFill>
+                  <a:srgbClr val="FFFFFF"/>
+                </a:solidFill>
+              </a:rPr>
+              <a:t>1</a:t>
+            </a:r>
+            <a:endParaRPr lang="en-US" sz="2000" dirty="0"/>
+          </a:p>
+        </p:txBody>
+      </p:sp>
+      <p:sp>
+        <p:nvSpPr>
+          <p:cNvPr id="5" name="Text 3"/>
+          <p:cNvSpPr txBox="1"/>
+          <p:nvPr/>
+        </p:nvSpPr>
+        <p:spPr>
+          <a:xfrm>
+            <a:off x="1508760" y="1645920"/>
+            <a:ext cx="10058400" cy="411480"/>
+          </a:xfrm>
+          <a:prstGeom prst="rect">
+            <a:avLst/>
+          </a:prstGeom>
+          <a:noFill/>
+          <a:ln/>
+        </p:spPr>
+        <p:txBody>
+          <a:bodyPr wrap="square" lIns="0" tIns="0" rIns="0" bIns="0" rtlCol="0" anchor="t"/>
+          <a:lstStyle/>
+          <a:p>
+            <a:pPr indent="0" marL="0">
+              <a:buNone/>
+            </a:pPr>
+            <a:r>
+              <a:rPr lang="en-US" sz="1800" b="1" dirty="0">
+                <a:solidFill>
+                  <a:schemeClr val="tx2"/>
+                </a:solidFill>
+              </a:rPr>
+              <a:t>A live odds feed</a:t>
+            </a:r>
+            <a:endParaRPr lang="en-US" sz="1800" dirty="0"/>
+          </a:p>
+        </p:txBody>
+      </p:sp>
+      <p:sp>
+        <p:nvSpPr>
+          <p:cNvPr id="6" name="Text 4"/>
+          <p:cNvSpPr txBox="1"/>
+          <p:nvPr/>
+        </p:nvSpPr>
+        <p:spPr>
+          <a:xfrm>
+            <a:off x="1508760" y="2066544"/>
+            <a:ext cx="10058400" cy="960120"/>
+          </a:xfrm>
+          <a:prstGeom prst="rect">
+            <a:avLst/>
+          </a:prstGeom>
+          <a:noFill/>
+          <a:ln/>
+        </p:spPr>
+        <p:txBody>
+          <a:bodyPr wrap="square" lIns="0" tIns="0" rIns="0" bIns="0" rtlCol="0" anchor="t"/>
+          <a:lstStyle/>
+          <a:p>
+            <a:pPr indent="0" marL="0">
+              <a:buNone/>
+            </a:pPr>
+            <a:r>
+              <a:rPr lang="en-US" sz="1350" dirty="0">
+                <a:solidFill>
+                  <a:schemeClr val="accent5"/>
+                </a:solidFill>
+              </a:rPr>
+              <a:t>Every result here says what the method WOULD have done. The three stages are online and causal and the state is one weight vector plus two scalars, so it runs in real time against a streaming API. That turns a statistical edge into an exploitable one.</a:t>
+            </a:r>
+            <a:endParaRPr lang="en-US" sz="1350" dirty="0"/>
+          </a:p>
+        </p:txBody>
+      </p:sp>
+      <p:sp>
+        <p:nvSpPr>
+          <p:cNvPr id="7" name="circle-2"/>
           <p:cNvSpPr/>
+          <p:nvPr/>
+        </p:nvSpPr>
+        <p:spPr>
+          <a:xfrm>
+            <a:off x="640080" y="3200400"/>
+            <a:ext cx="566928" cy="566928"/>
+          </a:xfrm>
+          <a:prstGeom prst="ellipse">
+            <a:avLst/>
+          </a:prstGeom>
+          <a:solidFill>
+            <a:schemeClr val="accent1"/>
+          </a:solidFill>
+          <a:ln/>
+        </p:spPr>
+      </p:sp>
+      <p:sp>
+        <p:nvSpPr>
+          <p:cNvPr id="8" name="Text 6"/>
+          <p:cNvSpPr txBox="1"/>
+          <p:nvPr/>
+        </p:nvSpPr>
+        <p:spPr>
+          <a:xfrm>
+            <a:off x="640080" y="3200400"/>
+            <a:ext cx="566928" cy="566928"/>
+          </a:xfrm>
+          <a:prstGeom prst="rect">
+            <a:avLst/>
+          </a:prstGeom>
+          <a:noFill/>
+          <a:ln/>
+        </p:spPr>
+        <p:txBody>
+          <a:bodyPr wrap="square" lIns="0" tIns="0" rIns="0" bIns="0" rtlCol="0" anchor="ctr"/>
+          <a:lstStyle/>
+          <a:p>
+            <a:pPr algn="ctr" indent="0" marL="0">
+              <a:buNone/>
+            </a:pPr>
+            <a:r>
+              <a:rPr lang="en-US" sz="2000" b="1" dirty="0">
+                <a:solidFill>
+                  <a:srgbClr val="FFFFFF"/>
+                </a:solidFill>
+              </a:rPr>
+              <a:t>2</a:t>
+            </a:r>
+            <a:endParaRPr lang="en-US" sz="2000" dirty="0"/>
+          </a:p>
+        </p:txBody>
+      </p:sp>
+      <p:sp>
+        <p:nvSpPr>
+          <p:cNvPr id="9" name="Text 7"/>
+          <p:cNvSpPr txBox="1"/>
+          <p:nvPr/>
+        </p:nvSpPr>
+        <p:spPr>
+          <a:xfrm>
+            <a:off x="1508760" y="3154680"/>
+            <a:ext cx="10058400" cy="411480"/>
+          </a:xfrm>
+          <a:prstGeom prst="rect">
+            <a:avLst/>
+          </a:prstGeom>
+          <a:noFill/>
+          <a:ln/>
+        </p:spPr>
+        <p:txBody>
+          <a:bodyPr wrap="square" lIns="0" tIns="0" rIns="0" bIns="0" rtlCol="0" anchor="t"/>
+          <a:lstStyle/>
+          <a:p>
+            <a:pPr indent="0" marL="0">
+              <a:buNone/>
+            </a:pPr>
+            <a:r>
+              <a:rPr lang="en-US" sz="1800" b="1" dirty="0">
+                <a:solidFill>
+                  <a:schemeClr val="tx2"/>
+                </a:solidFill>
+              </a:rPr>
+              <a:t>A second sport</a:t>
+            </a:r>
+            <a:endParaRPr lang="en-US" sz="1800" dirty="0"/>
+          </a:p>
+        </p:txBody>
+      </p:sp>
+      <p:sp>
+        <p:nvSpPr>
+          <p:cNvPr id="10" name="Text 8"/>
+          <p:cNvSpPr txBox="1"/>
+          <p:nvPr/>
+        </p:nvSpPr>
+        <p:spPr>
+          <a:xfrm>
+            <a:off x="1508760" y="3575304"/>
+            <a:ext cx="10058400" cy="960120"/>
+          </a:xfrm>
+          <a:prstGeom prst="rect">
+            <a:avLst/>
+          </a:prstGeom>
+          <a:noFill/>
+          <a:ln/>
+        </p:spPr>
+        <p:txBody>
+          <a:bodyPr wrap="square" lIns="0" tIns="0" rIns="0" bIns="0" rtlCol="0" anchor="t"/>
+          <a:lstStyle/>
+          <a:p>
+            <a:pPr indent="0" marL="0">
+              <a:buNone/>
+            </a:pPr>
+            <a:r>
+              <a:rPr lang="en-US" sz="1350" dirty="0">
+                <a:solidFill>
+                  <a:schemeClr val="accent5"/>
+                </a:solidFill>
+              </a:rPr>
+              <a:t>Basketball or tennis would show whether the framework generalises. The cost is a data pipeline; the algorithms do not change.</a:t>
+            </a:r>
+            <a:endParaRPr lang="en-US" sz="1350" dirty="0"/>
+          </a:p>
+        </p:txBody>
+      </p:sp>
+      <p:sp>
+        <p:nvSpPr>
+          <p:cNvPr id="11" name="circle-3"/>
+          <p:cNvSpPr/>
+          <p:nvPr/>
+        </p:nvSpPr>
+        <p:spPr>
+          <a:xfrm>
+            <a:off x="640080" y="4709160"/>
+            <a:ext cx="566928" cy="566928"/>
+          </a:xfrm>
+          <a:prstGeom prst="ellipse">
+            <a:avLst/>
+          </a:prstGeom>
+          <a:solidFill>
+            <a:schemeClr val="accent1"/>
+          </a:solidFill>
+          <a:ln/>
+        </p:spPr>
+      </p:sp>
+      <p:sp>
+        <p:nvSpPr>
+          <p:cNvPr id="12" name="Text 10"/>
+          <p:cNvSpPr txBox="1"/>
+          <p:nvPr/>
+        </p:nvSpPr>
+        <p:spPr>
+          <a:xfrm>
+            <a:off x="640080" y="4709160"/>
+            <a:ext cx="566928" cy="566928"/>
+          </a:xfrm>
+          <a:prstGeom prst="rect">
+            <a:avLst/>
+          </a:prstGeom>
+          <a:noFill/>
+          <a:ln/>
+        </p:spPr>
+        <p:txBody>
+          <a:bodyPr wrap="square" lIns="0" tIns="0" rIns="0" bIns="0" rtlCol="0" anchor="ctr"/>
+          <a:lstStyle/>
+          <a:p>
+            <a:pPr algn="ctr" indent="0" marL="0">
+              <a:buNone/>
+            </a:pPr>
+            <a:r>
+              <a:rPr lang="en-US" sz="2000" b="1" dirty="0">
+                <a:solidFill>
+                  <a:srgbClr val="FFFFFF"/>
+                </a:solidFill>
+              </a:rPr>
+              <a:t>3</a:t>
+            </a:r>
+            <a:endParaRPr lang="en-US" sz="2000" dirty="0"/>
+          </a:p>
+        </p:txBody>
+      </p:sp>
+      <p:sp>
+        <p:nvSpPr>
+          <p:cNvPr id="13" name="Text 11"/>
+          <p:cNvSpPr txBox="1"/>
+          <p:nvPr/>
+        </p:nvSpPr>
+        <p:spPr>
+          <a:xfrm>
+            <a:off x="1508760" y="4663440"/>
+            <a:ext cx="10058400" cy="411480"/>
+          </a:xfrm>
+          <a:prstGeom prst="rect">
+            <a:avLst/>
+          </a:prstGeom>
+          <a:noFill/>
+          <a:ln/>
+        </p:spPr>
+        <p:txBody>
+          <a:bodyPr wrap="square" lIns="0" tIns="0" rIns="0" bIns="0" rtlCol="0" anchor="t"/>
+          <a:lstStyle/>
+          <a:p>
+            <a:pPr indent="0" marL="0">
+              <a:buNone/>
+            </a:pPr>
+            <a:r>
+              <a:rPr lang="en-US" sz="1800" b="1" dirty="0">
+                <a:solidFill>
+                  <a:schemeClr val="tx2"/>
+                </a:solidFill>
+              </a:rPr>
+              <a:t>Bayesian Model Averaging as a baseline</a:t>
+            </a:r>
+            <a:endParaRPr lang="en-US" sz="1800" dirty="0"/>
+          </a:p>
+        </p:txBody>
+      </p:sp>
+      <p:sp>
+        <p:nvSpPr>
+          <p:cNvPr id="14" name="Text 12"/>
+          <p:cNvSpPr txBox="1"/>
+          <p:nvPr/>
+        </p:nvSpPr>
+        <p:spPr>
+          <a:xfrm>
+            <a:off x="1508760" y="5084064"/>
+            <a:ext cx="10058400" cy="960120"/>
+          </a:xfrm>
+          <a:prstGeom prst="rect">
+            <a:avLst/>
+          </a:prstGeom>
+          <a:noFill/>
+          <a:ln/>
+        </p:spPr>
+        <p:txBody>
+          <a:bodyPr wrap="square" lIns="0" tIns="0" rIns="0" bIns="0" rtlCol="0" anchor="t"/>
+          <a:lstStyle/>
+          <a:p>
+            <a:pPr indent="0" marL="0">
+              <a:buNone/>
+            </a:pPr>
+            <a:r>
+              <a:rPr lang="en-US" sz="1350" dirty="0">
+                <a:solidFill>
+                  <a:schemeClr val="accent5"/>
+                </a:solidFill>
+              </a:rPr>
+              <a:t>An empirical comparison for the online algorithms, side by side with the Aggregating Algorithm, its online Bayesian counterpart.</a:t>
+            </a:r>
+            <a:endParaRPr lang="en-US" sz="1350" dirty="0"/>
+          </a:p>
+        </p:txBody>
+      </p:sp>
+      <p:sp>
+        <p:nvSpPr>
+          <p:cNvPr id="25" name="Slide Number Placeholder 0"/>
+          <p:cNvSpPr>
+            <a:spLocks noGrp="1"/>
+          </p:cNvSpPr>
           <p:nvPr>
-            <p:ph idx="101" type="body" hasCustomPrompt="1"/>
+            <p:ph type="sldNum" sz="quarter" idx="4294967295"/>
           </p:nvPr>
         </p:nvSpPr>
         <p:spPr>
           <a:xfrm>
-            <a:off x="914400" y="3977640"/>
-            <a:ext cx="10332720" cy="1463040"/>
-          </a:xfrm>
-          <a:prstGeom prst="rect">
-            <a:avLst/>
-          </a:prstGeom>
-          <a:noFill/>
-          <a:ln/>
-        </p:spPr>
-        <p:txBody>
-          <a:bodyPr wrap="square" rtlCol="0" anchor="t"/>
-          <a:lstStyle/>
-          <a:p>
-            <a:pPr algn="ctr" indent="0" marL="0">
-              <a:buNone/>
-            </a:pPr>
-            <a:r>
-              <a:rPr lang="en-US" sz="1700" dirty="0">
-                <a:solidFill>
-                  <a:srgbClr val="CBD5E1"/>
-                </a:solidFill>
-              </a:rPr>
-              <a:t>Questions</a:t>
-            </a:r>
-            <a:endParaRPr lang="en-US" sz="1700" dirty="0"/>
+            <a:off x="11521440" y="6355080"/>
+            <a:ext cx="800000" cy="300000"/>
+          </a:xfrm>
+          <a:prstGeom prst="rect">
+            <a:avLst/>
+          </a:prstGeom>
+          <a:extLst>
+            <a:ext uri="{C572A759-6A51-4108-AA02-DFA0A04FC94B}">
+              <ma14:wrappingTextBoxFlag xmlns:ma14="http://schemas.microsoft.com/office/mac/drawingml/2011/main" val="0"/>
+            </a:ext>
+          </a:extLst>
+        </p:spPr>
+        <p:txBody>
+          <a:bodyPr/>
+          <a:lstStyle>
+            <a:lvl1pPr>
+              <a:defRPr sz="1100">
+                <a:solidFill>
+                  <a:schemeClr val="accent6"/>
+                </a:solidFill>
+              </a:defRPr>
+            </a:lvl1pPr>
+          </a:lstStyle>
+          <a:p>
+            <a:pPr algn="l"/>
+            <a:fld id="{F7021451-1387-4CA6-816F-3879F97B5CBC}" type="slidenum">
+              <a:rPr b="0" lang="en-US"/>
+              <a:t>19</a:t>
+            </a:fld>
+            <a:endParaRPr lang="en-US"/>
           </a:p>
         </p:txBody>
       </p:sp>
@@ -9317,6 +9819,107 @@
 </p:sld>
 </file>
 
+<file path=ppt/slides/slide20.xml><?xml version="1.0" encoding="utf-8"?>
+<p:sld xmlns:a="http://schemas.openxmlformats.org/drawingml/2006/main" xmlns:r="http://schemas.openxmlformats.org/officeDocument/2006/relationships" xmlns:p="http://schemas.openxmlformats.org/presentationml/2006/main">
+  <p:cSld name="Slide 20">
+    <p:spTree>
+      <p:nvGrpSpPr>
+        <p:cNvPr id="1" name=""/>
+        <p:cNvGrpSpPr/>
+        <p:nvPr/>
+      </p:nvGrpSpPr>
+      <p:grpSpPr>
+        <a:xfrm>
+          <a:off x="0" y="0"/>
+          <a:ext cx="0" cy="0"/>
+          <a:chOff x="0" y="0"/>
+          <a:chExt cx="0" cy="0"/>
+        </a:xfrm>
+      </p:grpSpPr>
+      <p:sp>
+        <p:nvSpPr>
+          <p:cNvPr id="2" name="Text 0"/>
+          <p:cNvSpPr/>
+          <p:nvPr>
+            <p:ph idx="100" type="title" hasCustomPrompt="1"/>
+          </p:nvPr>
+        </p:nvSpPr>
+        <p:spPr>
+          <a:xfrm>
+            <a:off x="914400" y="2103120"/>
+            <a:ext cx="10332720" cy="1737360"/>
+          </a:xfrm>
+          <a:prstGeom prst="rect">
+            <a:avLst/>
+          </a:prstGeom>
+          <a:noFill/>
+          <a:ln/>
+        </p:spPr>
+        <p:txBody>
+          <a:bodyPr wrap="square" rtlCol="0" anchor="b"/>
+          <a:lstStyle/>
+          <a:p>
+            <a:pPr algn="ctr" indent="0" marL="0">
+              <a:buNone/>
+            </a:pPr>
+            <a:r>
+              <a:rPr lang="en-US" sz="4000" b="1" dirty="0">
+                <a:solidFill>
+                  <a:schemeClr val="bg1"/>
+                </a:solidFill>
+              </a:rPr>
+              <a:t>Thank you</a:t>
+            </a:r>
+            <a:endParaRPr lang="en-US" sz="4000" dirty="0"/>
+          </a:p>
+        </p:txBody>
+      </p:sp>
+      <p:sp>
+        <p:nvSpPr>
+          <p:cNvPr id="3" name="Text 0"/>
+          <p:cNvSpPr/>
+          <p:nvPr>
+            <p:ph idx="101" type="body" hasCustomPrompt="1"/>
+          </p:nvPr>
+        </p:nvSpPr>
+        <p:spPr>
+          <a:xfrm>
+            <a:off x="914400" y="3977640"/>
+            <a:ext cx="10332720" cy="1463040"/>
+          </a:xfrm>
+          <a:prstGeom prst="rect">
+            <a:avLst/>
+          </a:prstGeom>
+          <a:noFill/>
+          <a:ln/>
+        </p:spPr>
+        <p:txBody>
+          <a:bodyPr wrap="square" rtlCol="0" anchor="t"/>
+          <a:lstStyle/>
+          <a:p>
+            <a:pPr algn="ctr" indent="0" marL="0">
+              <a:buNone/>
+            </a:pPr>
+            <a:r>
+              <a:rPr lang="en-US" sz="1700" dirty="0">
+                <a:solidFill>
+                  <a:srgbClr val="CBD5E1"/>
+                </a:solidFill>
+              </a:rPr>
+              <a:t>Questions</a:t>
+            </a:r>
+            <a:endParaRPr lang="en-US" sz="1700" dirty="0"/>
+          </a:p>
+        </p:txBody>
+      </p:sp>
+    </p:spTree>
+  </p:cSld>
+  <p:clrMapOvr>
+    <a:masterClrMapping/>
+  </p:clrMapOvr>
+</p:sld>
+</file>
+
 <file path=ppt/slides/slide3.xml><?xml version="1.0" encoding="utf-8"?>
 <p:sld xmlns:a="http://schemas.openxmlformats.org/drawingml/2006/main" xmlns:r="http://schemas.openxmlformats.org/officeDocument/2006/relationships" xmlns:p="http://schemas.openxmlformats.org/presentationml/2006/main">
   <p:cSld name="Slide 3">
@@ -13018,7 +13621,7 @@
                   <a:schemeClr val="tx1"/>
                 </a:solidFill>
               </a:rPr>
-              <a:t>a sleeping expert is FROZEN, not decayed</a:t>
+              <a:t>sleepers are untouched; the awake group keeps its total mass</a:t>
             </a:r>
             <a:endParaRPr lang="en-US" sz="1500" dirty="0"/>
           </a:p>
@@ -14034,7 +14637,7 @@
                   <a:schemeClr val="accent2"/>
                 </a:solidFill>
               </a:rPr>
-              <a:t>Caught: tail selection would have retuned Hedge and FTRL, and on train the order reverses.</a:t>
+              <a:t>Caught: tail selection would have retuned FTRL, and on train the order reverses.</a:t>
             </a:r>
             <a:endParaRPr lang="en-US" sz="1250" dirty="0"/>
           </a:p>
@@ -14535,7 +15138,7 @@
                   <a:schemeClr val="tx2"/>
                 </a:solidFill>
               </a:rPr>
-              <a:t>A zero-step control; extend every grid edge</a:t>
+              <a:t>Controls: step zero, grid edges, the bound</a:t>
             </a:r>
             <a:endParaRPr lang="en-US" sz="1550" dirty="0"/>
           </a:p>
@@ -14571,7 +15174,7 @@
                   <a:schemeClr val="tx1"/>
                 </a:solidFill>
               </a:rPr>
-              <a:t>Run the same algorithm with step zero. When a sweep's best value sits on its edge, look further before believing it.</a:t>
+              <a:t>Run the same algorithm with step zero, extend any sweep whose best value sits on its edge, and check that the regret bound holds.</a:t>
             </a:r>
             <a:endParaRPr lang="en-US" sz="1250" dirty="0"/>
           </a:p>
@@ -14607,7 +15210,7 @@
                   <a:schemeClr val="accent2"/>
                 </a:solidFill>
               </a:rPr>
-              <a:t>Caught: 42% of the margin credited to learning, and ×1 called optimal for Hedge and FTRL.</a:t>
+              <a:t>Caught: 42% of OGD's margin credited to learning, and a Hedge that broke its own guarantee 50-fold.</a:t>
             </a:r>
             <a:endParaRPr lang="en-US" sz="1250" dirty="0"/>
           </a:p>
@@ -14866,7 +15469,7 @@
                   <a:schemeClr val="accent2"/>
                 </a:solidFill>
               </a:rPr>
-              <a:t>Hedge and FTRL want LESS</a:t>
+              <a:t>FTRL wants LESS, Hedge MORE</a:t>
             </a:r>
             <a:endParaRPr lang="en-US" sz="1600" dirty="0"/>
           </a:p>
@@ -14902,7 +15505,7 @@
                   <a:schemeClr val="tx1"/>
                 </a:solidFill>
               </a:rPr>
-              <a:t>×0.25 and ×0.05. The worst-case bound assumes a loss of 13.8 that the data never produce; the largest observed is 3.76.</a:t>
+              <a:t>FTRL ×0.05; Hedge ×250, on a plateau from ×200 to ×1000. The worst-case bound assumes a loss of 13.8 that the data never produce; the largest observed is 3.76.</a:t>
             </a:r>
             <a:endParaRPr lang="en-US" sz="1400" dirty="0"/>
           </a:p>
@@ -15089,7 +15692,7 @@
                   <a:schemeClr val="accent1"/>
                 </a:solidFill>
               </a:rPr>
-              <a:t>OGD is second</a:t>
+              <a:t>Hedge reaches Pinnacle</a:t>
             </a:r>
             <a:endParaRPr lang="en-US" sz="1800" dirty="0"/>
           </a:p>
@@ -15129,7 +15732,7 @@
                   <a:schemeClr val="tx1"/>
                 </a:solidFill>
               </a:rPr>
-              <a:t>beats the uniform average by 0.00140 (p &lt; 0.001)</a:t>
+              <a:t>Hedge level with PSC over the decade (p = 0.43)</a:t>
             </a:r>
             <a:endParaRPr lang="en-US" sz="1350" dirty="0"/>
           </a:p>
@@ -15147,7 +15750,7 @@
                   <a:schemeClr val="tx1"/>
                 </a:solidFill>
               </a:rPr>
-              <a:t>ahead of every bookmaker but Pinnacle, including two closing prices</a:t>
+              <a:t>Hedge beats OGD (p &lt; 0.001) and the uniform average by 0.0020</a:t>
             </a:r>
             <a:endParaRPr lang="en-US" sz="1350" dirty="0"/>
           </a:p>
@@ -15165,7 +15768,7 @@
                   <a:schemeClr val="tx1"/>
                 </a:solidFill>
               </a:rPr>
-              <a:t>PSC stays ahead by 0.00043</a:t>
+              <a:t>OGD stays 0.00043 behind PSC</a:t>
             </a:r>
             <a:endParaRPr lang="en-US" sz="1350" dirty="0"/>
           </a:p>
@@ -15183,7 +15786,7 @@
                   <a:schemeClr val="tx1"/>
                 </a:solidFill>
               </a:rPr>
-              <a:t>calibration helps all four methods</a:t>
+              <a:t>all three beat every other bookmaker; calibration helps all four</a:t>
             </a:r>
             <a:endParaRPr lang="en-US" sz="1350" dirty="0"/>
           </a:p>

</xml_diff>